<commit_message>
feat(production): refresh external deck dogfood
</commit_message>
<xml_diff>
--- a/outputs/dogfood-ai-collective-chapter-brief/chapter-launch-brief.pptx
+++ b/outputs/dogfood-ai-collective-chapter-brief/chapter-launch-brief.pptx
@@ -1273,13 +1273,7 @@
           <p:nvPr/>
         </p:nvPicPr>
         <p:blipFill>
-          <a:blip r:embed="rId1">
-            <a:extLst>
-              <a:ext uri="{96DAC541-7B7A-43D3-8B79-37D633B846F1}">
-                <asvg:svgBlip xmlns:asvg="http://schemas.microsoft.com/office/drawing/2016/SVG/main" r:embed="rId2"/>
-              </a:ext>
-            </a:extLst>
-          </a:blip>
+          <a:blip r:embed="rId1"/>
           <a:stretch>
             <a:fillRect/>
           </a:stretch>
@@ -1327,7 +1321,7 @@
                 <a:ea typeface="Arial" pitchFamily="34" charset="-122"/>
                 <a:cs typeface="Arial" pitchFamily="34" charset="-120"/>
               </a:rPr>
-              <a:t>AI COLLECTIVE · ORGANIZER BRIEF</a:t>
+              <a:t>AI COLLECTIVE · CLIENT PRESENTATION</a:t>
             </a:r>
             <a:endParaRPr lang="en-US" sz="900" dirty="0"/>
           </a:p>
@@ -1411,7 +1405,7 @@
                 <a:ea typeface="Arial" pitchFamily="34" charset="-122"/>
                 <a:cs typeface="Arial" pitchFamily="34" charset="-120"/>
               </a:rPr>
-              <a:t>As a chapter lead, you’ll be seen as a leader and facilitator in your local AI scene</a:t>
+              <a:t>As a chapter lead, you’ll be seen as a leader and facilitator in your local AI scene.</a:t>
             </a:r>
             <a:endParaRPr lang="en-US" sz="1200" dirty="0"/>
           </a:p>
@@ -1454,7 +1448,7 @@
                 <a:ea typeface="Arial" pitchFamily="34" charset="-122"/>
                 <a:cs typeface="Arial" pitchFamily="34" charset="-120"/>
               </a:rPr>
-              <a:t>Approved Brief</a:t>
+              <a:t>Approved brief</a:t>
             </a:r>
             <a:endParaRPr lang="en-US" sz="800" dirty="0"/>
           </a:p>
@@ -1566,7 +1560,7 @@
                 <a:ea typeface="Arial" pitchFamily="34" charset="-122"/>
                 <a:cs typeface="Arial" pitchFamily="34" charset="-120"/>
               </a:rPr>
-              <a:t>KEY POINT</a:t>
+              <a:t>CORE INSIGHT</a:t>
             </a:r>
             <a:endParaRPr lang="en-US" sz="900" dirty="0"/>
           </a:p>
@@ -1607,7 +1601,7 @@
                 <a:ea typeface="Arial" pitchFamily="34" charset="-122"/>
                 <a:cs typeface="Arial" pitchFamily="34" charset="-120"/>
               </a:rPr>
-              <a:t>Become a “go-to” resource</a:t>
+              <a:t>Become a go-to resource</a:t>
             </a:r>
             <a:endParaRPr lang="en-US" sz="3800" dirty="0"/>
           </a:p>
@@ -1675,7 +1669,7 @@
                 <a:ea typeface="Arial" pitchFamily="34" charset="-122"/>
                 <a:cs typeface="Arial" pitchFamily="34" charset="-120"/>
               </a:rPr>
-              <a:t>As a chapter lead, you’ll be seen as a leader and facilitator in your local AI scene</a:t>
+              <a:t>As a chapter lead, you’ll be seen as a leader and facilitator in your local AI scene.</a:t>
             </a:r>
             <a:endParaRPr lang="en-US" sz="1800" dirty="0"/>
           </a:p>
@@ -1718,7 +1712,7 @@
                 <a:ea typeface="Arial" pitchFamily="34" charset="-122"/>
                 <a:cs typeface="Arial" pitchFamily="34" charset="-120"/>
               </a:rPr>
-              <a:t>Source: GenAI Collective Chapter Startup FAQ · chunk 05</a:t>
+              <a:t>Source: Chapter Startup FAQ · chunk 05</a:t>
             </a:r>
             <a:endParaRPr lang="en-US" sz="800" dirty="0"/>
           </a:p>
@@ -1799,7 +1793,36 @@
       </p:grpSpPr>
       <p:sp>
         <p:nvSpPr>
-          <p:cNvPr id="2" name="Text 0"/>
+          <p:cNvPr id="2" name="Shape 0"/>
+          <p:cNvSpPr/>
+          <p:nvPr/>
+        </p:nvSpPr>
+        <p:spPr>
+          <a:xfrm>
+            <a:off x="0" y="0"/>
+            <a:ext cx="3401568" cy="6858000"/>
+          </a:xfrm>
+          <a:prstGeom prst="rect">
+            <a:avLst/>
+          </a:prstGeom>
+          <a:solidFill>
+            <a:srgbClr val="FF640D">
+              <a:alpha val="8000"/>
+            </a:srgbClr>
+          </a:solidFill>
+          <a:ln w="12700">
+            <a:solidFill>
+              <a:srgbClr val="FF640D">
+                <a:alpha val="0"/>
+              </a:srgbClr>
+            </a:solidFill>
+            <a:prstDash val="solid"/>
+          </a:ln>
+        </p:spPr>
+      </p:sp>
+      <p:sp>
+        <p:nvSpPr>
+          <p:cNvPr id="3" name="Text 1"/>
           <p:cNvSpPr/>
           <p:nvPr/>
         </p:nvSpPr>
@@ -1840,7 +1863,7 @@
       </p:sp>
       <p:sp>
         <p:nvSpPr>
-          <p:cNvPr id="3" name="Text 1"/>
+          <p:cNvPr id="4" name="Text 2"/>
           <p:cNvSpPr/>
           <p:nvPr/>
         </p:nvSpPr>
@@ -1871,7 +1894,7 @@
                 <a:ea typeface="Arial" pitchFamily="34" charset="-122"/>
                 <a:cs typeface="Arial" pitchFamily="34" charset="-120"/>
               </a:rPr>
-              <a:t>KEY POINT</a:t>
+              <a:t>WHAT CHANGES</a:t>
             </a:r>
             <a:endParaRPr lang="en-US" sz="900" dirty="0"/>
           </a:p>
@@ -1879,14 +1902,14 @@
       </p:sp>
       <p:sp>
         <p:nvSpPr>
-          <p:cNvPr id="4" name="Text 2"/>
-          <p:cNvSpPr/>
-          <p:nvPr/>
-        </p:nvSpPr>
-        <p:spPr>
-          <a:xfrm>
-            <a:off x="3858768" y="1572768"/>
-            <a:ext cx="7132320" cy="1417320"/>
+          <p:cNvPr id="5" name="Text 3"/>
+          <p:cNvSpPr/>
+          <p:nvPr/>
+        </p:nvSpPr>
+        <p:spPr>
+          <a:xfrm>
+            <a:off x="3858768" y="1901952"/>
+            <a:ext cx="7132320" cy="1920240"/>
           </a:xfrm>
           <a:prstGeom prst="rect">
             <a:avLst/>
@@ -1904,7 +1927,7 @@
               <a:buNone/>
             </a:pPr>
             <a:r>
-              <a:rPr lang="en-US" sz="3000" dirty="0">
+              <a:rPr lang="en-US" sz="3600" dirty="0">
                 <a:solidFill>
                   <a:srgbClr val="171717"/>
                 </a:solidFill>
@@ -1914,48 +1937,7 @@
               </a:rPr>
               <a:t>Your events are financially sustainable</a:t>
             </a:r>
-            <a:endParaRPr lang="en-US" sz="3000" dirty="0"/>
-          </a:p>
-        </p:txBody>
-      </p:sp>
-      <p:sp>
-        <p:nvSpPr>
-          <p:cNvPr id="5" name="Text 3"/>
-          <p:cNvSpPr/>
-          <p:nvPr/>
-        </p:nvSpPr>
-        <p:spPr>
-          <a:xfrm>
-            <a:off x="3886200" y="3246120"/>
-            <a:ext cx="6812280" cy="1417320"/>
-          </a:xfrm>
-          <a:prstGeom prst="rect">
-            <a:avLst/>
-          </a:prstGeom>
-          <a:noFill/>
-          <a:ln/>
-        </p:spPr>
-        <p:txBody>
-          <a:bodyPr wrap="square" lIns="0" tIns="0" rIns="0" bIns="0" rtlCol="0" anchor="t">
-            <a:normAutofit/>
-          </a:bodyPr>
-          <a:lstStyle/>
-          <a:p>
-            <a:pPr indent="0" marL="0">
-              <a:buNone/>
-            </a:pPr>
-            <a:r>
-              <a:rPr lang="en-US" sz="1700" dirty="0">
-                <a:solidFill>
-                  <a:srgbClr val="171717"/>
-                </a:solidFill>
-                <a:latin typeface="Arial" pitchFamily="34" charset="0"/>
-                <a:ea typeface="Arial" pitchFamily="34" charset="-122"/>
-                <a:cs typeface="Arial" pitchFamily="34" charset="-120"/>
-              </a:rPr>
-              <a:t>we’ll help you with this</a:t>
-            </a:r>
-            <a:endParaRPr lang="en-US" sz="1700" dirty="0"/>
+            <a:endParaRPr lang="en-US" sz="3600" dirty="0"/>
           </a:p>
         </p:txBody>
       </p:sp>
@@ -1996,7 +1978,7 @@
                 <a:ea typeface="Arial" pitchFamily="34" charset="-122"/>
                 <a:cs typeface="Arial" pitchFamily="34" charset="-120"/>
               </a:rPr>
-              <a:t>Source: GenAI Collective Chapter Startup FAQ · chunk 30</a:t>
+              <a:t>Source: Chapter Startup FAQ · chunk 30</a:t>
             </a:r>
             <a:endParaRPr lang="en-US" sz="800" dirty="0"/>
           </a:p>
@@ -2149,7 +2131,7 @@
                 <a:ea typeface="Arial" pitchFamily="34" charset="-122"/>
                 <a:cs typeface="Arial" pitchFamily="34" charset="-120"/>
               </a:rPr>
-              <a:t>We're a global non-profit with 180+ chapters across 40+…</a:t>
+              <a:t>180+ chapters across 40+ countries</a:t>
             </a:r>
             <a:endParaRPr lang="en-US" sz="3200" dirty="0"/>
           </a:p>
@@ -2190,7 +2172,7 @@
                 <a:ea typeface="Arial" pitchFamily="34" charset="-122"/>
                 <a:cs typeface="Arial" pitchFamily="34" charset="-120"/>
               </a:rPr>
-              <a:t>We're a global non-profit with 180+ chapters across 40+ countries, 400+ volunteer organizers, and a community that includes everyone from solo founders to teams at the biggest AI labs in the world</a:t>
+              <a:t>400+ volunteer organizers, with a community that includes everyone from solo founders to teams at the biggest AI labs in the world.</a:t>
             </a:r>
             <a:endParaRPr lang="en-US" sz="1800" dirty="0"/>
           </a:p>
@@ -2295,7 +2277,7 @@
                 <a:ea typeface="Arial" pitchFamily="34" charset="-122"/>
                 <a:cs typeface="Arial" pitchFamily="34" charset="-120"/>
               </a:rPr>
-              <a:t>The AI Collective Newsletter · chunk 79</a:t>
+              <a:t>AI Collective Newsletter · chunk 79</a:t>
             </a:r>
             <a:endParaRPr lang="en-US" sz="2000" dirty="0"/>
           </a:p>
@@ -2338,7 +2320,7 @@
                 <a:ea typeface="Arial" pitchFamily="34" charset="-122"/>
                 <a:cs typeface="Arial" pitchFamily="34" charset="-120"/>
               </a:rPr>
-              <a:t>Source: The AI Collective Newsletter · chunk 79</a:t>
+              <a:t>Source: AI Collective Newsletter · chunk 79</a:t>
             </a:r>
             <a:endParaRPr lang="en-US" sz="800" dirty="0"/>
           </a:p>
@@ -2450,7 +2432,7 @@
                 <a:ea typeface="Arial" pitchFamily="34" charset="-122"/>
                 <a:cs typeface="Arial" pitchFamily="34" charset="-120"/>
               </a:rPr>
-              <a:t>RECOMMENDATION</a:t>
+              <a:t>RECOMMENDED NEXT MOVE</a:t>
             </a:r>
             <a:endParaRPr lang="en-US" sz="900" dirty="0"/>
           </a:p>
@@ -2561,7 +2543,7 @@
                 <a:ea typeface="Arial" pitchFamily="34" charset="-122"/>
                 <a:cs typeface="Arial" pitchFamily="34" charset="-120"/>
               </a:rPr>
-              <a:t>From there, you can attend an event, volunteer to organize, pitch a Byte article, or start a chapter in your city</a:t>
+              <a:t>You can also attend an event, volunteer to organize, or pitch a Byte article.</a:t>
             </a:r>
             <a:endParaRPr lang="en-US" sz="1800" dirty="0"/>
           </a:p>
@@ -2604,7 +2586,7 @@
                 <a:ea typeface="Arial" pitchFamily="34" charset="-122"/>
                 <a:cs typeface="Arial" pitchFamily="34" charset="-120"/>
               </a:rPr>
-              <a:t>Source: The AI Collective Newsletter · chunk 81</a:t>
+              <a:t>Source: AI Collective Newsletter · chunk 81</a:t>
             </a:r>
             <a:endParaRPr lang="en-US" sz="800" dirty="0"/>
           </a:p>

</xml_diff>

<commit_message>
feat(deck): present evidence as professional metrics
</commit_message>
<xml_diff>
--- a/outputs/dogfood-ai-collective-chapter-brief/chapter-launch-brief.pptx
+++ b/outputs/dogfood-ai-collective-chapter-brief/chapter-launch-brief.pptx
@@ -1712,7 +1712,7 @@
                 <a:ea typeface="Arial" pitchFamily="34" charset="-122"/>
                 <a:cs typeface="Arial" pitchFamily="34" charset="-120"/>
               </a:rPr>
-              <a:t>Source: Chapter Startup FAQ · chunk 05</a:t>
+              <a:t>Source: Chapter Startup FAQ</a:t>
             </a:r>
             <a:endParaRPr lang="en-US" sz="800" dirty="0"/>
           </a:p>
@@ -1978,7 +1978,7 @@
                 <a:ea typeface="Arial" pitchFamily="34" charset="-122"/>
                 <a:cs typeface="Arial" pitchFamily="34" charset="-120"/>
               </a:rPr>
-              <a:t>Source: Chapter Startup FAQ · chunk 30</a:t>
+              <a:t>Source: Chapter Startup FAQ</a:t>
             </a:r>
             <a:endParaRPr lang="en-US" sz="800" dirty="0"/>
           </a:p>
@@ -2098,14 +2098,41 @@
       </p:sp>
       <p:sp>
         <p:nvSpPr>
-          <p:cNvPr id="3" name="Text 1"/>
-          <p:cNvSpPr/>
-          <p:nvPr/>
-        </p:nvSpPr>
-        <p:spPr>
-          <a:xfrm>
-            <a:off x="658368" y="1143000"/>
-            <a:ext cx="6675120" cy="1463040"/>
+          <p:cNvPr id="3" name="Shape 1"/>
+          <p:cNvSpPr/>
+          <p:nvPr/>
+        </p:nvSpPr>
+        <p:spPr>
+          <a:xfrm>
+            <a:off x="685800" y="1353312"/>
+            <a:ext cx="4892040" cy="22860"/>
+          </a:xfrm>
+          <a:prstGeom prst="rect">
+            <a:avLst/>
+          </a:prstGeom>
+          <a:solidFill>
+            <a:srgbClr val="FF640D"/>
+          </a:solidFill>
+          <a:ln w="12700">
+            <a:solidFill>
+              <a:srgbClr val="FF640D">
+                <a:alpha val="0"/>
+              </a:srgbClr>
+            </a:solidFill>
+            <a:prstDash val="solid"/>
+          </a:ln>
+        </p:spPr>
+      </p:sp>
+      <p:sp>
+        <p:nvSpPr>
+          <p:cNvPr id="4" name="Text 2"/>
+          <p:cNvSpPr/>
+          <p:nvPr/>
+        </p:nvSpPr>
+        <p:spPr>
+          <a:xfrm>
+            <a:off x="685800" y="1627632"/>
+            <a:ext cx="4892040" cy="1325880"/>
           </a:xfrm>
           <a:prstGeom prst="rect">
             <a:avLst/>
@@ -2123,7 +2150,7 @@
               <a:buNone/>
             </a:pPr>
             <a:r>
-              <a:rPr lang="en-US" sz="3200" dirty="0">
+              <a:rPr lang="en-US" sz="5800" dirty="0">
                 <a:solidFill>
                   <a:srgbClr val="171717"/>
                 </a:solidFill>
@@ -2131,22 +2158,172 @@
                 <a:ea typeface="Arial" pitchFamily="34" charset="-122"/>
                 <a:cs typeface="Arial" pitchFamily="34" charset="-120"/>
               </a:rPr>
-              <a:t>180+ chapters across 40+ countries</a:t>
-            </a:r>
-            <a:endParaRPr lang="en-US" sz="3200" dirty="0"/>
-          </a:p>
-        </p:txBody>
-      </p:sp>
-      <p:sp>
-        <p:nvSpPr>
-          <p:cNvPr id="4" name="Text 2"/>
-          <p:cNvSpPr/>
-          <p:nvPr/>
-        </p:nvSpPr>
-        <p:spPr>
-          <a:xfrm>
-            <a:off x="685800" y="2788920"/>
-            <a:ext cx="6400800" cy="1508760"/>
+              <a:t>180+</a:t>
+            </a:r>
+            <a:endParaRPr lang="en-US" sz="5800" dirty="0"/>
+          </a:p>
+        </p:txBody>
+      </p:sp>
+      <p:sp>
+        <p:nvSpPr>
+          <p:cNvPr id="5" name="Text 3"/>
+          <p:cNvSpPr/>
+          <p:nvPr/>
+        </p:nvSpPr>
+        <p:spPr>
+          <a:xfrm>
+            <a:off x="685800" y="2962656"/>
+            <a:ext cx="4892040" cy="384048"/>
+          </a:xfrm>
+          <a:prstGeom prst="rect">
+            <a:avLst/>
+          </a:prstGeom>
+          <a:noFill/>
+          <a:ln/>
+        </p:spPr>
+        <p:txBody>
+          <a:bodyPr wrap="square" lIns="0" tIns="0" rIns="0" bIns="0" rtlCol="0" anchor="ctr"/>
+          <a:lstStyle/>
+          <a:p>
+            <a:pPr indent="0" marL="0">
+              <a:buNone/>
+            </a:pPr>
+            <a:r>
+              <a:rPr lang="en-US" sz="800" b="1" dirty="0">
+                <a:solidFill>
+                  <a:srgbClr val="171717">
+                    <a:alpha val="66000"/>
+                  </a:srgbClr>
+                </a:solidFill>
+                <a:latin typeface="Arial" pitchFamily="34" charset="0"/>
+                <a:ea typeface="Arial" pitchFamily="34" charset="-122"/>
+                <a:cs typeface="Arial" pitchFamily="34" charset="-120"/>
+              </a:rPr>
+              <a:t>CHAPTERS</a:t>
+            </a:r>
+            <a:endParaRPr lang="en-US" sz="800" dirty="0"/>
+          </a:p>
+        </p:txBody>
+      </p:sp>
+      <p:sp>
+        <p:nvSpPr>
+          <p:cNvPr id="6" name="Shape 4"/>
+          <p:cNvSpPr/>
+          <p:nvPr/>
+        </p:nvSpPr>
+        <p:spPr>
+          <a:xfrm>
+            <a:off x="6217920" y="1353312"/>
+            <a:ext cx="4892040" cy="22860"/>
+          </a:xfrm>
+          <a:prstGeom prst="rect">
+            <a:avLst/>
+          </a:prstGeom>
+          <a:solidFill>
+            <a:srgbClr val="FF640D"/>
+          </a:solidFill>
+          <a:ln w="12700">
+            <a:solidFill>
+              <a:srgbClr val="FF640D">
+                <a:alpha val="0"/>
+              </a:srgbClr>
+            </a:solidFill>
+            <a:prstDash val="solid"/>
+          </a:ln>
+        </p:spPr>
+      </p:sp>
+      <p:sp>
+        <p:nvSpPr>
+          <p:cNvPr id="7" name="Text 5"/>
+          <p:cNvSpPr/>
+          <p:nvPr/>
+        </p:nvSpPr>
+        <p:spPr>
+          <a:xfrm>
+            <a:off x="6217920" y="1627632"/>
+            <a:ext cx="4892040" cy="1325880"/>
+          </a:xfrm>
+          <a:prstGeom prst="rect">
+            <a:avLst/>
+          </a:prstGeom>
+          <a:noFill/>
+          <a:ln/>
+        </p:spPr>
+        <p:txBody>
+          <a:bodyPr wrap="square" lIns="0" tIns="0" rIns="0" bIns="0" rtlCol="0" anchor="ctr">
+            <a:normAutofit/>
+          </a:bodyPr>
+          <a:lstStyle/>
+          <a:p>
+            <a:pPr indent="0" marL="0">
+              <a:buNone/>
+            </a:pPr>
+            <a:r>
+              <a:rPr lang="en-US" sz="5800" dirty="0">
+                <a:solidFill>
+                  <a:srgbClr val="171717"/>
+                </a:solidFill>
+                <a:latin typeface="Arial" pitchFamily="34" charset="0"/>
+                <a:ea typeface="Arial" pitchFamily="34" charset="-122"/>
+                <a:cs typeface="Arial" pitchFamily="34" charset="-120"/>
+              </a:rPr>
+              <a:t>40+</a:t>
+            </a:r>
+            <a:endParaRPr lang="en-US" sz="5800" dirty="0"/>
+          </a:p>
+        </p:txBody>
+      </p:sp>
+      <p:sp>
+        <p:nvSpPr>
+          <p:cNvPr id="8" name="Text 6"/>
+          <p:cNvSpPr/>
+          <p:nvPr/>
+        </p:nvSpPr>
+        <p:spPr>
+          <a:xfrm>
+            <a:off x="6217920" y="2962656"/>
+            <a:ext cx="4892040" cy="384048"/>
+          </a:xfrm>
+          <a:prstGeom prst="rect">
+            <a:avLst/>
+          </a:prstGeom>
+          <a:noFill/>
+          <a:ln/>
+        </p:spPr>
+        <p:txBody>
+          <a:bodyPr wrap="square" lIns="0" tIns="0" rIns="0" bIns="0" rtlCol="0" anchor="ctr"/>
+          <a:lstStyle/>
+          <a:p>
+            <a:pPr indent="0" marL="0">
+              <a:buNone/>
+            </a:pPr>
+            <a:r>
+              <a:rPr lang="en-US" sz="800" b="1" dirty="0">
+                <a:solidFill>
+                  <a:srgbClr val="171717">
+                    <a:alpha val="66000"/>
+                  </a:srgbClr>
+                </a:solidFill>
+                <a:latin typeface="Arial" pitchFamily="34" charset="0"/>
+                <a:ea typeface="Arial" pitchFamily="34" charset="-122"/>
+                <a:cs typeface="Arial" pitchFamily="34" charset="-120"/>
+              </a:rPr>
+              <a:t>COUNTRIES</a:t>
+            </a:r>
+            <a:endParaRPr lang="en-US" sz="800" dirty="0"/>
+          </a:p>
+        </p:txBody>
+      </p:sp>
+      <p:sp>
+        <p:nvSpPr>
+          <p:cNvPr id="9" name="Text 7"/>
+          <p:cNvSpPr/>
+          <p:nvPr/>
+        </p:nvSpPr>
+        <p:spPr>
+          <a:xfrm>
+            <a:off x="685800" y="3886200"/>
+            <a:ext cx="8961120" cy="960120"/>
           </a:xfrm>
           <a:prstGeom prst="rect">
             <a:avLst/>
@@ -2164,7 +2341,7 @@
               <a:buNone/>
             </a:pPr>
             <a:r>
-              <a:rPr lang="en-US" sz="1800" dirty="0">
+              <a:rPr lang="en-US" sz="1600" dirty="0">
                 <a:solidFill>
                   <a:srgbClr val="171717"/>
                 </a:solidFill>
@@ -2174,118 +2351,13 @@
               </a:rPr>
               <a:t>400+ volunteer organizers, with a community that includes everyone from solo founders to teams at the biggest AI labs in the world.</a:t>
             </a:r>
-            <a:endParaRPr lang="en-US" sz="1800" dirty="0"/>
-          </a:p>
-        </p:txBody>
-      </p:sp>
-      <p:sp>
-        <p:nvSpPr>
-          <p:cNvPr id="5" name="Shape 3"/>
-          <p:cNvSpPr/>
-          <p:nvPr/>
-        </p:nvSpPr>
-        <p:spPr>
-          <a:xfrm>
-            <a:off x="7818120" y="658368"/>
-            <a:ext cx="3703320" cy="5440680"/>
-          </a:xfrm>
-          <a:prstGeom prst="rect">
-            <a:avLst/>
-          </a:prstGeom>
-          <a:solidFill>
-            <a:srgbClr val="171717"/>
-          </a:solidFill>
-          <a:ln w="12700">
-            <a:solidFill>
-              <a:srgbClr val="171717"/>
-            </a:solidFill>
-            <a:prstDash val="solid"/>
-          </a:ln>
-        </p:spPr>
-      </p:sp>
-      <p:sp>
-        <p:nvSpPr>
-          <p:cNvPr id="6" name="Text 4"/>
-          <p:cNvSpPr/>
-          <p:nvPr/>
-        </p:nvSpPr>
-        <p:spPr>
-          <a:xfrm>
-            <a:off x="8183880" y="3886200"/>
-            <a:ext cx="2880360" cy="201168"/>
-          </a:xfrm>
-          <a:prstGeom prst="rect">
-            <a:avLst/>
-          </a:prstGeom>
-          <a:noFill/>
-          <a:ln/>
-        </p:spPr>
-        <p:txBody>
-          <a:bodyPr wrap="square" lIns="0" tIns="0" rIns="0" bIns="0" rtlCol="0" anchor="ctr"/>
-          <a:lstStyle/>
-          <a:p>
-            <a:pPr indent="0" marL="0">
-              <a:buNone/>
-            </a:pPr>
-            <a:r>
-              <a:rPr lang="en-US" sz="800" b="1" spc="120" kern="0" dirty="0">
-                <a:solidFill>
-                  <a:srgbClr val="FF640D"/>
-                </a:solidFill>
-                <a:latin typeface="Arial" pitchFamily="34" charset="0"/>
-                <a:ea typeface="Arial" pitchFamily="34" charset="-122"/>
-                <a:cs typeface="Arial" pitchFamily="34" charset="-120"/>
-              </a:rPr>
-              <a:t>TRACEABLE BY DESIGN</a:t>
-            </a:r>
-            <a:endParaRPr lang="en-US" sz="800" dirty="0"/>
-          </a:p>
-        </p:txBody>
-      </p:sp>
-      <p:sp>
-        <p:nvSpPr>
-          <p:cNvPr id="7" name="Text 5"/>
-          <p:cNvSpPr/>
-          <p:nvPr/>
-        </p:nvSpPr>
-        <p:spPr>
-          <a:xfrm>
-            <a:off x="8156448" y="4315968"/>
-            <a:ext cx="2834640" cy="1051560"/>
-          </a:xfrm>
-          <a:prstGeom prst="rect">
-            <a:avLst/>
-          </a:prstGeom>
-          <a:noFill/>
-          <a:ln/>
-        </p:spPr>
-        <p:txBody>
-          <a:bodyPr wrap="square" lIns="0" tIns="0" rIns="0" bIns="0" rtlCol="0" anchor="b">
-            <a:normAutofit/>
-          </a:bodyPr>
-          <a:lstStyle/>
-          <a:p>
-            <a:pPr indent="0" marL="0">
-              <a:buNone/>
-            </a:pPr>
-            <a:r>
-              <a:rPr lang="en-US" sz="2000" dirty="0">
-                <a:solidFill>
-                  <a:srgbClr val="FAF8F3"/>
-                </a:solidFill>
-                <a:latin typeface="Arial" pitchFamily="34" charset="0"/>
-                <a:ea typeface="Arial" pitchFamily="34" charset="-122"/>
-                <a:cs typeface="Arial" pitchFamily="34" charset="-120"/>
-              </a:rPr>
-              <a:t>AI Collective Newsletter · chunk 79</a:t>
-            </a:r>
-            <a:endParaRPr lang="en-US" sz="2000" dirty="0"/>
-          </a:p>
-        </p:txBody>
-      </p:sp>
-      <p:sp>
-        <p:nvSpPr>
-          <p:cNvPr id="8" name="Text 6"/>
+            <a:endParaRPr lang="en-US" sz="1600" dirty="0"/>
+          </a:p>
+        </p:txBody>
+      </p:sp>
+      <p:sp>
+        <p:nvSpPr>
+          <p:cNvPr id="10" name="Text 8"/>
           <p:cNvSpPr/>
           <p:nvPr/>
         </p:nvSpPr>
@@ -2320,7 +2392,7 @@
                 <a:ea typeface="Arial" pitchFamily="34" charset="-122"/>
                 <a:cs typeface="Arial" pitchFamily="34" charset="-120"/>
               </a:rPr>
-              <a:t>Source: AI Collective Newsletter · chunk 79</a:t>
+              <a:t>Source: AI Collective Newsletter</a:t>
             </a:r>
             <a:endParaRPr lang="en-US" sz="800" dirty="0"/>
           </a:p>
@@ -2328,7 +2400,7 @@
       </p:sp>
       <p:sp>
         <p:nvSpPr>
-          <p:cNvPr id="9" name="Text 7"/>
+          <p:cNvPr id="11" name="Text 9"/>
           <p:cNvSpPr/>
           <p:nvPr/>
         </p:nvSpPr>
@@ -2426,7 +2498,7 @@
             <a:r>
               <a:rPr lang="en-US" sz="900" b="1" spc="150" kern="0" dirty="0">
                 <a:solidFill>
-                  <a:srgbClr val="FAF8F3"/>
+                  <a:srgbClr val="000000"/>
                 </a:solidFill>
                 <a:latin typeface="Arial" pitchFamily="34" charset="0"/>
                 <a:ea typeface="Arial" pitchFamily="34" charset="-122"/>
@@ -2467,7 +2539,7 @@
             <a:r>
               <a:rPr lang="en-US" sz="4200" dirty="0">
                 <a:solidFill>
-                  <a:srgbClr val="FAF8F3"/>
+                  <a:srgbClr val="000000"/>
                 </a:solidFill>
                 <a:latin typeface="Arial" pitchFamily="34" charset="0"/>
                 <a:ea typeface="Arial" pitchFamily="34" charset="-122"/>
@@ -2494,13 +2566,13 @@
             <a:avLst/>
           </a:prstGeom>
           <a:solidFill>
-            <a:srgbClr val="FAF8F3">
+            <a:srgbClr val="000000">
               <a:alpha val="80000"/>
             </a:srgbClr>
           </a:solidFill>
           <a:ln w="12700">
             <a:solidFill>
-              <a:srgbClr val="FAF8F3">
+              <a:srgbClr val="000000">
                 <a:alpha val="0"/>
               </a:srgbClr>
             </a:solidFill>
@@ -2537,7 +2609,7 @@
             <a:r>
               <a:rPr lang="en-US" sz="1800" dirty="0">
                 <a:solidFill>
-                  <a:srgbClr val="FAF8F3"/>
+                  <a:srgbClr val="000000"/>
                 </a:solidFill>
                 <a:latin typeface="Arial" pitchFamily="34" charset="0"/>
                 <a:ea typeface="Arial" pitchFamily="34" charset="-122"/>
@@ -2586,7 +2658,7 @@
                 <a:ea typeface="Arial" pitchFamily="34" charset="-122"/>
                 <a:cs typeface="Arial" pitchFamily="34" charset="-120"/>
               </a:rPr>
-              <a:t>Source: AI Collective Newsletter · chunk 81</a:t>
+              <a:t>Source: AI Collective Newsletter</a:t>
             </a:r>
             <a:endParaRPr lang="en-US" sz="800" dirty="0"/>
           </a:p>

</xml_diff>

<commit_message>
feat(deliver): strengthen sparse presentation claims
</commit_message>
<xml_diff>
--- a/outputs/dogfood-ai-collective-chapter-brief/chapter-launch-brief.pptx
+++ b/outputs/dogfood-ai-collective-chapter-brief/chapter-launch-brief.pptx
@@ -1440,7 +1440,7 @@
             <a:r>
               <a:rPr lang="en-US" sz="800" dirty="0">
                 <a:solidFill>
-                  <a:srgbClr val="171717">
+                  <a:srgbClr val="FAF8F3">
                     <a:alpha val="66000"/>
                   </a:srgbClr>
                 </a:solidFill>
@@ -1481,7 +1481,7 @@
             <a:r>
               <a:rPr lang="en-US" sz="800" dirty="0">
                 <a:solidFill>
-                  <a:srgbClr val="171717">
+                  <a:srgbClr val="FAF8F3">
                     <a:alpha val="66000"/>
                   </a:srgbClr>
                 </a:solidFill>
@@ -1773,7 +1773,7 @@
     <p:bg>
       <p:bgPr>
         <a:solidFill>
-          <a:srgbClr val="FAF8F3"/>
+          <a:srgbClr val="171717"/>
         </a:solidFill>
       </p:bgPr>
     </p:bg>
@@ -1799,16 +1799,14 @@
         </p:nvSpPr>
         <p:spPr>
           <a:xfrm>
-            <a:off x="0" y="0"/>
-            <a:ext cx="3401568" cy="6858000"/>
+            <a:off x="685800" y="1207008"/>
+            <a:ext cx="64008" cy="4160520"/>
           </a:xfrm>
           <a:prstGeom prst="rect">
             <a:avLst/>
           </a:prstGeom>
           <a:solidFill>
-            <a:srgbClr val="FF640D">
-              <a:alpha val="8000"/>
-            </a:srgbClr>
+            <a:srgbClr val="FF640D"/>
           </a:solidFill>
           <a:ln w="12700">
             <a:solidFill>
@@ -1828,8 +1826,8 @@
         </p:nvSpPr>
         <p:spPr>
           <a:xfrm>
-            <a:off x="658368" y="1920240"/>
-            <a:ext cx="2743200" cy="1920240"/>
+            <a:off x="9281160" y="4315968"/>
+            <a:ext cx="2331720" cy="1965960"/>
           </a:xfrm>
           <a:prstGeom prst="rect">
             <a:avLst/>
@@ -1843,13 +1841,15 @@
           </a:bodyPr>
           <a:lstStyle/>
           <a:p>
-            <a:pPr indent="0" marL="0">
+            <a:pPr algn="r" indent="0" marL="0">
               <a:buNone/>
             </a:pPr>
             <a:r>
               <a:rPr lang="en-US" sz="10400" dirty="0">
                 <a:solidFill>
-                  <a:srgbClr val="FF640D"/>
+                  <a:srgbClr val="FF640D">
+                    <a:alpha val="90000"/>
+                  </a:srgbClr>
                 </a:solidFill>
                 <a:latin typeface="Arial" pitchFamily="34" charset="0"/>
                 <a:ea typeface="Arial" pitchFamily="34" charset="-122"/>
@@ -1869,7 +1869,7 @@
         </p:nvSpPr>
         <p:spPr>
           <a:xfrm>
-            <a:off x="3886200" y="1170432"/>
+            <a:off x="1005840" y="1353312"/>
             <a:ext cx="5120640" cy="182880"/>
           </a:xfrm>
           <a:prstGeom prst="rect">
@@ -1908,8 +1908,8 @@
         </p:nvSpPr>
         <p:spPr>
           <a:xfrm>
-            <a:off x="3858768" y="1901952"/>
-            <a:ext cx="7132320" cy="1920240"/>
+            <a:off x="987552" y="1828800"/>
+            <a:ext cx="8412480" cy="2560320"/>
           </a:xfrm>
           <a:prstGeom prst="rect">
             <a:avLst/>
@@ -1927,9 +1927,9 @@
               <a:buNone/>
             </a:pPr>
             <a:r>
-              <a:rPr lang="en-US" sz="3600" dirty="0">
+              <a:rPr lang="en-US" sz="4400" dirty="0">
                 <a:solidFill>
-                  <a:srgbClr val="171717"/>
+                  <a:srgbClr val="FAF8F3"/>
                 </a:solidFill>
                 <a:latin typeface="Arial" pitchFamily="34" charset="0"/>
                 <a:ea typeface="Arial" pitchFamily="34" charset="-122"/>
@@ -1937,7 +1937,7 @@
               </a:rPr>
               <a:t>Your events are financially sustainable</a:t>
             </a:r>
-            <a:endParaRPr lang="en-US" sz="3600" dirty="0"/>
+            <a:endParaRPr lang="en-US" sz="4400" dirty="0"/>
           </a:p>
         </p:txBody>
       </p:sp>
@@ -1970,7 +1970,7 @@
             <a:r>
               <a:rPr lang="en-US" sz="800" dirty="0">
                 <a:solidFill>
-                  <a:srgbClr val="171717">
+                  <a:srgbClr val="FAF8F3">
                     <a:alpha val="66000"/>
                   </a:srgbClr>
                 </a:solidFill>
@@ -2011,7 +2011,7 @@
             <a:r>
               <a:rPr lang="en-US" sz="800" dirty="0">
                 <a:solidFill>
-                  <a:srgbClr val="171717">
+                  <a:srgbClr val="FAF8F3">
                     <a:alpha val="66000"/>
                   </a:srgbClr>
                 </a:solidFill>
@@ -2650,7 +2650,7 @@
             <a:r>
               <a:rPr lang="en-US" sz="800" dirty="0">
                 <a:solidFill>
-                  <a:srgbClr val="171717">
+                  <a:srgbClr val="000000">
                     <a:alpha val="66000"/>
                   </a:srgbClr>
                 </a:solidFill>
@@ -2691,7 +2691,7 @@
             <a:r>
               <a:rPr lang="en-US" sz="800" dirty="0">
                 <a:solidFill>
-                  <a:srgbClr val="171717">
+                  <a:srgbClr val="000000">
                     <a:alpha val="66000"/>
                   </a:srgbClr>
                 </a:solidFill>

</xml_diff>

<commit_message>
fix(deck): preserve reviewed logo proportions
</commit_message>
<xml_diff>
--- a/outputs/dogfood-ai-collective-chapter-brief/chapter-launch-brief.pptx
+++ b/outputs/dogfood-ai-collective-chapter-brief/chapter-launch-brief.pptx
@@ -1273,7 +1273,13 @@
           <p:nvPr/>
         </p:nvPicPr>
         <p:blipFill>
-          <a:blip r:embed="rId1"/>
+          <a:blip r:embed="rId1">
+            <a:extLst>
+              <a:ext uri="{96DAC541-7B7A-43D3-8B79-37D633B846F1}">
+                <asvg:svgBlip xmlns:asvg="http://schemas.microsoft.com/office/drawing/2016/SVG/main" r:embed="rId2"/>
+              </a:ext>
+            </a:extLst>
+          </a:blip>
           <a:stretch>
             <a:fillRect/>
           </a:stretch>
@@ -1281,7 +1287,7 @@
         <p:spPr>
           <a:xfrm>
             <a:off x="685800" y="566928"/>
-            <a:ext cx="512064" cy="621792"/>
+            <a:ext cx="515472" cy="621792"/>
           </a:xfrm>
           <a:prstGeom prst="rect">
             <a:avLst/>

</xml_diff>

<commit_message>
feat(deck): raise external dogfood send-it bar
</commit_message>
<xml_diff>
--- a/outputs/dogfood-ai-collective-chapter-brief/chapter-launch-brief.pptx
+++ b/outputs/dogfood-ai-collective-chapter-brief/chapter-launch-brief.pptx
@@ -10,9 +10,13 @@
     <p:sldId id="258" r:id="rId4"/>
     <p:sldId id="259" r:id="rId5"/>
     <p:sldId id="260" r:id="rId6"/>
+    <p:sldId id="261" r:id="rId7"/>
+    <p:sldId id="262" r:id="rId8"/>
+    <p:sldId id="263" r:id="rId9"/>
+    <p:sldId id="264" r:id="rId10"/>
   </p:sldIdLst>
   <p:notesMasterIdLst>
-    <p:notesMasterId r:id="rId7"/>
+    <p:notesMasterId r:id="rId11"/>
   </p:notesMasterIdLst>
   <p:sldSz cx="12192000" cy="6858000"/>
   <p:notesSz cx="6858000" cy="12192000"/>
@@ -685,8 +689,8 @@
             <a:r>
               <a:rPr lang="en-US" dirty="0"/>
               <a:t>WorkshopLM source trace
-Local PDF · GenAI Collective Chapter Startup FAQ.pdf · chunk 30
-Claim ID: claim-bb80dd1be045-29-2</a:t>
+https://newsletter.aicollective.com/ · chunk 79
+Claim ID: claim-60bb5377e97a-78-1</a:t>
             </a:r>
             <a:endParaRPr lang="en-US" dirty="0"/>
           </a:p>
@@ -775,8 +779,8 @@
             <a:r>
               <a:rPr lang="en-US" dirty="0"/>
               <a:t>WorkshopLM source trace
-https://newsletter.aicollective.com/ · chunk 79
-Claim ID: claim-60bb5377e97a-78-1</a:t>
+https://newsletter.aicollective.com/ · Frequently Asked Questions · What’s The AI Collective itself?
+Claim ID: claim-aic-event-formats</a:t>
             </a:r>
             <a:endParaRPr lang="en-US" dirty="0"/>
           </a:p>
@@ -865,8 +869,8 @@
             <a:r>
               <a:rPr lang="en-US" dirty="0"/>
               <a:t>WorkshopLM source trace
-https://newsletter.aicollective.com/ · chunk 81
-Claim ID: claim-60bb5377e97a-80-3</a:t>
+Derived from approved Workshop brief · validate with AI Collective HQ
+Claim ID: derived-30-day-launch-plan</a:t>
             </a:r>
             <a:endParaRPr lang="en-US" dirty="0"/>
           </a:p>
@@ -890,6 +894,368 @@
             <a:fld id="{F7021451-1387-4CA6-816F-3879F97B5CBC}" type="slidenum">
               <a:rPr lang="en-US"/>
               <a:t>5</a:t>
+            </a:fld>
+            <a:endParaRPr lang="en-US"/>
+          </a:p>
+        </p:txBody>
+      </p:sp>
+    </p:spTree>
+    <p:extLst>
+      <p:ext uri="{BB962C8B-B14F-4D97-AF65-F5344CB8AC3E}">
+        <p14:creationId xmlns:p14="http://schemas.microsoft.com/office/powerpoint/2010/main" val="1024086991"/>
+      </p:ext>
+    </p:extLst>
+  </p:cSld>
+  <p:clrMapOvr>
+    <a:masterClrMapping/>
+  </p:clrMapOvr>
+</p:notes>
+</file>
+
+<file path=ppt/notesSlides/notesSlide6.xml><?xml version="1.0" encoding="utf-8"?>
+<p:notes xmlns:a="http://schemas.openxmlformats.org/drawingml/2006/main" xmlns:r="http://schemas.openxmlformats.org/officeDocument/2006/relationships" xmlns:p="http://schemas.openxmlformats.org/presentationml/2006/main">
+  <p:cSld>
+    <p:spTree>
+      <p:nvGrpSpPr>
+        <p:cNvPr id="1" name=""/>
+        <p:cNvGrpSpPr/>
+        <p:nvPr/>
+      </p:nvGrpSpPr>
+      <p:grpSpPr>
+        <a:xfrm>
+          <a:off x="0" y="0"/>
+          <a:ext cx="0" cy="0"/>
+          <a:chOff x="0" y="0"/>
+          <a:chExt cx="0" cy="0"/>
+        </a:xfrm>
+      </p:grpSpPr>
+      <p:sp>
+        <p:nvSpPr>
+          <p:cNvPr id="2" name="Slide Image Placeholder 1"/>
+          <p:cNvSpPr>
+            <a:spLocks noGrp="1" noRot="1" noChangeAspect="1"/>
+          </p:cNvSpPr>
+          <p:nvPr>
+            <p:ph type="sldImg"/>
+          </p:nvPr>
+        </p:nvSpPr>
+        <p:spPr/>
+      </p:sp>
+      <p:sp>
+        <p:nvSpPr>
+          <p:cNvPr id="3" name="Notes Placeholder 2"/>
+          <p:cNvSpPr>
+            <a:spLocks noGrp="1"/>
+          </p:cNvSpPr>
+          <p:nvPr>
+            <p:ph type="body" idx="1"/>
+          </p:nvPr>
+        </p:nvSpPr>
+        <p:spPr/>
+        <p:txBody>
+          <a:bodyPr/>
+          <a:lstStyle/>
+          <a:p>
+            <a:r>
+              <a:rPr lang="en-US" dirty="0"/>
+              <a:t>WorkshopLM source trace
+Local PDF · GenAI Collective Chapter Startup FAQ.pdf · chunk 30
+Claim ID: claim-bb80dd1be045-29-2</a:t>
+            </a:r>
+            <a:endParaRPr lang="en-US" dirty="0"/>
+          </a:p>
+        </p:txBody>
+      </p:sp>
+      <p:sp>
+        <p:nvSpPr>
+          <p:cNvPr id="4" name="Slide Number Placeholder 3"/>
+          <p:cNvSpPr>
+            <a:spLocks noGrp="1"/>
+          </p:cNvSpPr>
+          <p:nvPr>
+            <p:ph type="sldNum" sz="quarter" idx="10"/>
+          </p:nvPr>
+        </p:nvSpPr>
+        <p:spPr/>
+        <p:txBody>
+          <a:bodyPr/>
+          <a:lstStyle/>
+          <a:p>
+            <a:fld id="{F7021451-1387-4CA6-816F-3879F97B5CBC}" type="slidenum">
+              <a:rPr lang="en-US"/>
+              <a:t>6</a:t>
+            </a:fld>
+            <a:endParaRPr lang="en-US"/>
+          </a:p>
+        </p:txBody>
+      </p:sp>
+    </p:spTree>
+    <p:extLst>
+      <p:ext uri="{BB962C8B-B14F-4D97-AF65-F5344CB8AC3E}">
+        <p14:creationId xmlns:p14="http://schemas.microsoft.com/office/powerpoint/2010/main" val="1024086991"/>
+      </p:ext>
+    </p:extLst>
+  </p:cSld>
+  <p:clrMapOvr>
+    <a:masterClrMapping/>
+  </p:clrMapOvr>
+</p:notes>
+</file>
+
+<file path=ppt/notesSlides/notesSlide7.xml><?xml version="1.0" encoding="utf-8"?>
+<p:notes xmlns:a="http://schemas.openxmlformats.org/drawingml/2006/main" xmlns:r="http://schemas.openxmlformats.org/officeDocument/2006/relationships" xmlns:p="http://schemas.openxmlformats.org/presentationml/2006/main">
+  <p:cSld>
+    <p:spTree>
+      <p:nvGrpSpPr>
+        <p:cNvPr id="1" name=""/>
+        <p:cNvGrpSpPr/>
+        <p:nvPr/>
+      </p:nvGrpSpPr>
+      <p:grpSpPr>
+        <a:xfrm>
+          <a:off x="0" y="0"/>
+          <a:ext cx="0" cy="0"/>
+          <a:chOff x="0" y="0"/>
+          <a:chExt cx="0" cy="0"/>
+        </a:xfrm>
+      </p:grpSpPr>
+      <p:sp>
+        <p:nvSpPr>
+          <p:cNvPr id="2" name="Slide Image Placeholder 1"/>
+          <p:cNvSpPr>
+            <a:spLocks noGrp="1" noRot="1" noChangeAspect="1"/>
+          </p:cNvSpPr>
+          <p:nvPr>
+            <p:ph type="sldImg"/>
+          </p:nvPr>
+        </p:nvSpPr>
+        <p:spPr/>
+      </p:sp>
+      <p:sp>
+        <p:nvSpPr>
+          <p:cNvPr id="3" name="Notes Placeholder 2"/>
+          <p:cNvSpPr>
+            <a:spLocks noGrp="1"/>
+          </p:cNvSpPr>
+          <p:nvPr>
+            <p:ph type="body" idx="1"/>
+          </p:nvPr>
+        </p:nvSpPr>
+        <p:spPr/>
+        <p:txBody>
+          <a:bodyPr/>
+          <a:lstStyle/>
+          <a:p>
+            <a:r>
+              <a:rPr lang="en-US" dirty="0"/>
+              <a:t>WorkshopLM source trace
+https://www.aicollective.com/files/Code%20of%20Conduct.pdf · Purpose, Scope, Expected Behavior
+https://www.aicollective.com/files/Data%20Privacy%20and%20Use%20Policy%20~%20The%20AI%20Collective.pdf · Introduction and Scope
+Claim ID: claim-aic-conduct-privacy</a:t>
+            </a:r>
+            <a:endParaRPr lang="en-US" dirty="0"/>
+          </a:p>
+        </p:txBody>
+      </p:sp>
+      <p:sp>
+        <p:nvSpPr>
+          <p:cNvPr id="4" name="Slide Number Placeholder 3"/>
+          <p:cNvSpPr>
+            <a:spLocks noGrp="1"/>
+          </p:cNvSpPr>
+          <p:nvPr>
+            <p:ph type="sldNum" sz="quarter" idx="10"/>
+          </p:nvPr>
+        </p:nvSpPr>
+        <p:spPr/>
+        <p:txBody>
+          <a:bodyPr/>
+          <a:lstStyle/>
+          <a:p>
+            <a:fld id="{F7021451-1387-4CA6-816F-3879F97B5CBC}" type="slidenum">
+              <a:rPr lang="en-US"/>
+              <a:t>7</a:t>
+            </a:fld>
+            <a:endParaRPr lang="en-US"/>
+          </a:p>
+        </p:txBody>
+      </p:sp>
+    </p:spTree>
+    <p:extLst>
+      <p:ext uri="{BB962C8B-B14F-4D97-AF65-F5344CB8AC3E}">
+        <p14:creationId xmlns:p14="http://schemas.microsoft.com/office/powerpoint/2010/main" val="1024086991"/>
+      </p:ext>
+    </p:extLst>
+  </p:cSld>
+  <p:clrMapOvr>
+    <a:masterClrMapping/>
+  </p:clrMapOvr>
+</p:notes>
+</file>
+
+<file path=ppt/notesSlides/notesSlide8.xml><?xml version="1.0" encoding="utf-8"?>
+<p:notes xmlns:a="http://schemas.openxmlformats.org/drawingml/2006/main" xmlns:r="http://schemas.openxmlformats.org/officeDocument/2006/relationships" xmlns:p="http://schemas.openxmlformats.org/presentationml/2006/main">
+  <p:cSld>
+    <p:spTree>
+      <p:nvGrpSpPr>
+        <p:cNvPr id="1" name=""/>
+        <p:cNvGrpSpPr/>
+        <p:nvPr/>
+      </p:nvGrpSpPr>
+      <p:grpSpPr>
+        <a:xfrm>
+          <a:off x="0" y="0"/>
+          <a:ext cx="0" cy="0"/>
+          <a:chOff x="0" y="0"/>
+          <a:chExt cx="0" cy="0"/>
+        </a:xfrm>
+      </p:grpSpPr>
+      <p:sp>
+        <p:nvSpPr>
+          <p:cNvPr id="2" name="Slide Image Placeholder 1"/>
+          <p:cNvSpPr>
+            <a:spLocks noGrp="1" noRot="1" noChangeAspect="1"/>
+          </p:cNvSpPr>
+          <p:nvPr>
+            <p:ph type="sldImg"/>
+          </p:nvPr>
+        </p:nvSpPr>
+        <p:spPr/>
+      </p:sp>
+      <p:sp>
+        <p:nvSpPr>
+          <p:cNvPr id="3" name="Notes Placeholder 2"/>
+          <p:cNvSpPr>
+            <a:spLocks noGrp="1"/>
+          </p:cNvSpPr>
+          <p:nvPr>
+            <p:ph type="body" idx="1"/>
+          </p:nvPr>
+        </p:nvSpPr>
+        <p:spPr/>
+        <p:txBody>
+          <a:bodyPr/>
+          <a:lstStyle/>
+          <a:p>
+            <a:r>
+              <a:rPr lang="en-US" dirty="0"/>
+              <a:t>WorkshopLM source trace
+Derived from approved Workshop brief · validate with AI Collective HQ
+Claim ID: derived-launch-decisions</a:t>
+            </a:r>
+            <a:endParaRPr lang="en-US" dirty="0"/>
+          </a:p>
+        </p:txBody>
+      </p:sp>
+      <p:sp>
+        <p:nvSpPr>
+          <p:cNvPr id="4" name="Slide Number Placeholder 3"/>
+          <p:cNvSpPr>
+            <a:spLocks noGrp="1"/>
+          </p:cNvSpPr>
+          <p:nvPr>
+            <p:ph type="sldNum" sz="quarter" idx="10"/>
+          </p:nvPr>
+        </p:nvSpPr>
+        <p:spPr/>
+        <p:txBody>
+          <a:bodyPr/>
+          <a:lstStyle/>
+          <a:p>
+            <a:fld id="{F7021451-1387-4CA6-816F-3879F97B5CBC}" type="slidenum">
+              <a:rPr lang="en-US"/>
+              <a:t>8</a:t>
+            </a:fld>
+            <a:endParaRPr lang="en-US"/>
+          </a:p>
+        </p:txBody>
+      </p:sp>
+    </p:spTree>
+    <p:extLst>
+      <p:ext uri="{BB962C8B-B14F-4D97-AF65-F5344CB8AC3E}">
+        <p14:creationId xmlns:p14="http://schemas.microsoft.com/office/powerpoint/2010/main" val="1024086991"/>
+      </p:ext>
+    </p:extLst>
+  </p:cSld>
+  <p:clrMapOvr>
+    <a:masterClrMapping/>
+  </p:clrMapOvr>
+</p:notes>
+</file>
+
+<file path=ppt/notesSlides/notesSlide9.xml><?xml version="1.0" encoding="utf-8"?>
+<p:notes xmlns:a="http://schemas.openxmlformats.org/drawingml/2006/main" xmlns:r="http://schemas.openxmlformats.org/officeDocument/2006/relationships" xmlns:p="http://schemas.openxmlformats.org/presentationml/2006/main">
+  <p:cSld>
+    <p:spTree>
+      <p:nvGrpSpPr>
+        <p:cNvPr id="1" name=""/>
+        <p:cNvGrpSpPr/>
+        <p:nvPr/>
+      </p:nvGrpSpPr>
+      <p:grpSpPr>
+        <a:xfrm>
+          <a:off x="0" y="0"/>
+          <a:ext cx="0" cy="0"/>
+          <a:chOff x="0" y="0"/>
+          <a:chExt cx="0" cy="0"/>
+        </a:xfrm>
+      </p:grpSpPr>
+      <p:sp>
+        <p:nvSpPr>
+          <p:cNvPr id="2" name="Slide Image Placeholder 1"/>
+          <p:cNvSpPr>
+            <a:spLocks noGrp="1" noRot="1" noChangeAspect="1"/>
+          </p:cNvSpPr>
+          <p:nvPr>
+            <p:ph type="sldImg"/>
+          </p:nvPr>
+        </p:nvSpPr>
+        <p:spPr/>
+      </p:sp>
+      <p:sp>
+        <p:nvSpPr>
+          <p:cNvPr id="3" name="Notes Placeholder 2"/>
+          <p:cNvSpPr>
+            <a:spLocks noGrp="1"/>
+          </p:cNvSpPr>
+          <p:nvPr>
+            <p:ph type="body" idx="1"/>
+          </p:nvPr>
+        </p:nvSpPr>
+        <p:spPr/>
+        <p:txBody>
+          <a:bodyPr/>
+          <a:lstStyle/>
+          <a:p>
+            <a:r>
+              <a:rPr lang="en-US" dirty="0"/>
+              <a:t>WorkshopLM source trace
+Local PDF · GenAI Collective Chapter Startup FAQ.pdf
+https://newsletter.aicollective.com/ · Frequently Asked Questions
+Claim ID: derived-launch-recommendation</a:t>
+            </a:r>
+            <a:endParaRPr lang="en-US" dirty="0"/>
+          </a:p>
+        </p:txBody>
+      </p:sp>
+      <p:sp>
+        <p:nvSpPr>
+          <p:cNvPr id="4" name="Slide Number Placeholder 3"/>
+          <p:cNvSpPr>
+            <a:spLocks noGrp="1"/>
+          </p:cNvSpPr>
+          <p:nvPr>
+            <p:ph type="sldNum" sz="quarter" idx="10"/>
+          </p:nvPr>
+        </p:nvSpPr>
+        <p:spPr/>
+        <p:txBody>
+          <a:bodyPr/>
+          <a:lstStyle/>
+          <a:p>
+            <a:fld id="{F7021451-1387-4CA6-816F-3879F97B5CBC}" type="slidenum">
+              <a:rPr lang="en-US"/>
+              <a:t>9</a:t>
             </a:fld>
             <a:endParaRPr lang="en-US"/>
           </a:p>
@@ -1303,7 +1669,7 @@
         <p:spPr>
           <a:xfrm>
             <a:off x="685800" y="4343400"/>
-            <a:ext cx="6949440" cy="228600"/>
+            <a:ext cx="9326880" cy="228600"/>
           </a:xfrm>
           <a:prstGeom prst="rect">
             <a:avLst/>
@@ -1368,7 +1734,7 @@
                 <a:ea typeface="Arial" pitchFamily="34" charset="-122"/>
                 <a:cs typeface="Arial" pitchFamily="34" charset="-120"/>
               </a:rPr>
-              <a:t>AI Collective chapter launch briefing</a:t>
+              <a:t>AI Collective chapter launch decision</a:t>
             </a:r>
             <a:endParaRPr lang="en-US" sz="4200" dirty="0"/>
           </a:p>
@@ -1411,7 +1777,7 @@
                 <a:ea typeface="Arial" pitchFamily="34" charset="-122"/>
                 <a:cs typeface="Arial" pitchFamily="34" charset="-120"/>
               </a:rPr>
-              <a:t>As a chapter lead, you’ll be seen as a leader and facilitator in your local AI scene.</a:t>
+              <a:t>A chapter lead becomes a visible facilitator and go-to resource for the local AI community.</a:t>
             </a:r>
             <a:endParaRPr lang="en-US" sz="1200" dirty="0"/>
           </a:p>
@@ -1607,7 +1973,7 @@
                 <a:ea typeface="Arial" pitchFamily="34" charset="-122"/>
                 <a:cs typeface="Arial" pitchFamily="34" charset="-120"/>
               </a:rPr>
-              <a:t>Become a go-to resource</a:t>
+              <a:t>Build the local front door to applied AI</a:t>
             </a:r>
             <a:endParaRPr lang="en-US" sz="3800" dirty="0"/>
           </a:p>
@@ -1675,7 +2041,7 @@
                 <a:ea typeface="Arial" pitchFamily="34" charset="-122"/>
                 <a:cs typeface="Arial" pitchFamily="34" charset="-120"/>
               </a:rPr>
-              <a:t>As a chapter lead, you’ll be seen as a leader and facilitator in your local AI scene.</a:t>
+              <a:t>A chapter lead becomes a visible facilitator and go-to resource for the local AI community.</a:t>
             </a:r>
             <a:endParaRPr lang="en-US" sz="1800" dirty="0"/>
           </a:p>
@@ -1779,7 +2145,7 @@
     <p:bg>
       <p:bgPr>
         <a:solidFill>
-          <a:srgbClr val="171717"/>
+          <a:srgbClr val="FAF8F3"/>
         </a:solidFill>
       </p:bgPr>
     </p:bg>
@@ -1799,14 +2165,53 @@
       </p:grpSpPr>
       <p:sp>
         <p:nvSpPr>
-          <p:cNvPr id="2" name="Shape 0"/>
-          <p:cNvSpPr/>
-          <p:nvPr/>
-        </p:nvSpPr>
-        <p:spPr>
-          <a:xfrm>
-            <a:off x="685800" y="1207008"/>
-            <a:ext cx="64008" cy="4160520"/>
+          <p:cNvPr id="2" name="Text 0"/>
+          <p:cNvSpPr/>
+          <p:nvPr/>
+        </p:nvSpPr>
+        <p:spPr>
+          <a:xfrm>
+            <a:off x="685800" y="749808"/>
+            <a:ext cx="5120640" cy="182880"/>
+          </a:xfrm>
+          <a:prstGeom prst="rect">
+            <a:avLst/>
+          </a:prstGeom>
+          <a:noFill/>
+          <a:ln/>
+        </p:spPr>
+        <p:txBody>
+          <a:bodyPr wrap="square" lIns="0" tIns="0" rIns="0" bIns="0" rtlCol="0" anchor="ctr"/>
+          <a:lstStyle/>
+          <a:p>
+            <a:pPr indent="0" marL="0">
+              <a:buNone/>
+            </a:pPr>
+            <a:r>
+              <a:rPr lang="en-US" sz="900" b="1" spc="150" kern="0" dirty="0">
+                <a:solidFill>
+                  <a:srgbClr val="FF640D"/>
+                </a:solidFill>
+                <a:latin typeface="Arial" pitchFamily="34" charset="0"/>
+                <a:ea typeface="Arial" pitchFamily="34" charset="-122"/>
+                <a:cs typeface="Arial" pitchFamily="34" charset="-120"/>
+              </a:rPr>
+              <a:t>EVIDENCE</a:t>
+            </a:r>
+            <a:endParaRPr lang="en-US" sz="900" dirty="0"/>
+          </a:p>
+        </p:txBody>
+      </p:sp>
+      <p:sp>
+        <p:nvSpPr>
+          <p:cNvPr id="3" name="Shape 1"/>
+          <p:cNvSpPr/>
+          <p:nvPr/>
+        </p:nvSpPr>
+        <p:spPr>
+          <a:xfrm>
+            <a:off x="685800" y="1353312"/>
+            <a:ext cx="4892040" cy="22860"/>
           </a:xfrm>
           <a:prstGeom prst="rect">
             <a:avLst/>
@@ -1826,14 +2231,14 @@
       </p:sp>
       <p:sp>
         <p:nvSpPr>
-          <p:cNvPr id="3" name="Text 1"/>
-          <p:cNvSpPr/>
-          <p:nvPr/>
-        </p:nvSpPr>
-        <p:spPr>
-          <a:xfrm>
-            <a:off x="9281160" y="4315968"/>
-            <a:ext cx="2331720" cy="1965960"/>
+          <p:cNvPr id="4" name="Text 2"/>
+          <p:cNvSpPr/>
+          <p:nvPr/>
+        </p:nvSpPr>
+        <p:spPr>
+          <a:xfrm>
+            <a:off x="685800" y="1627632"/>
+            <a:ext cx="4892040" cy="1325880"/>
           </a:xfrm>
           <a:prstGeom prst="rect">
             <a:avLst/>
@@ -1847,75 +2252,102 @@
           </a:bodyPr>
           <a:lstStyle/>
           <a:p>
-            <a:pPr algn="r" indent="0" marL="0">
-              <a:buNone/>
-            </a:pPr>
-            <a:r>
-              <a:rPr lang="en-US" sz="10400" dirty="0">
-                <a:solidFill>
-                  <a:srgbClr val="FF640D">
-                    <a:alpha val="90000"/>
+            <a:pPr indent="0" marL="0">
+              <a:buNone/>
+            </a:pPr>
+            <a:r>
+              <a:rPr lang="en-US" sz="5800" dirty="0">
+                <a:solidFill>
+                  <a:srgbClr val="171717"/>
+                </a:solidFill>
+                <a:latin typeface="Arial" pitchFamily="34" charset="0"/>
+                <a:ea typeface="Arial" pitchFamily="34" charset="-122"/>
+                <a:cs typeface="Arial" pitchFamily="34" charset="-120"/>
+              </a:rPr>
+              <a:t>180+</a:t>
+            </a:r>
+            <a:endParaRPr lang="en-US" sz="5800" dirty="0"/>
+          </a:p>
+        </p:txBody>
+      </p:sp>
+      <p:sp>
+        <p:nvSpPr>
+          <p:cNvPr id="5" name="Text 3"/>
+          <p:cNvSpPr/>
+          <p:nvPr/>
+        </p:nvSpPr>
+        <p:spPr>
+          <a:xfrm>
+            <a:off x="685800" y="2962656"/>
+            <a:ext cx="4892040" cy="384048"/>
+          </a:xfrm>
+          <a:prstGeom prst="rect">
+            <a:avLst/>
+          </a:prstGeom>
+          <a:noFill/>
+          <a:ln/>
+        </p:spPr>
+        <p:txBody>
+          <a:bodyPr wrap="square" lIns="0" tIns="0" rIns="0" bIns="0" rtlCol="0" anchor="ctr"/>
+          <a:lstStyle/>
+          <a:p>
+            <a:pPr indent="0" marL="0">
+              <a:buNone/>
+            </a:pPr>
+            <a:r>
+              <a:rPr lang="en-US" sz="800" b="1" dirty="0">
+                <a:solidFill>
+                  <a:srgbClr val="171717">
+                    <a:alpha val="66000"/>
                   </a:srgbClr>
                 </a:solidFill>
                 <a:latin typeface="Arial" pitchFamily="34" charset="0"/>
                 <a:ea typeface="Arial" pitchFamily="34" charset="-122"/>
                 <a:cs typeface="Arial" pitchFamily="34" charset="-120"/>
               </a:rPr>
-              <a:t>02</a:t>
-            </a:r>
-            <a:endParaRPr lang="en-US" sz="10400" dirty="0"/>
-          </a:p>
-        </p:txBody>
-      </p:sp>
-      <p:sp>
-        <p:nvSpPr>
-          <p:cNvPr id="4" name="Text 2"/>
-          <p:cNvSpPr/>
-          <p:nvPr/>
-        </p:nvSpPr>
-        <p:spPr>
-          <a:xfrm>
-            <a:off x="1005840" y="1353312"/>
-            <a:ext cx="5120640" cy="182880"/>
-          </a:xfrm>
-          <a:prstGeom prst="rect">
-            <a:avLst/>
-          </a:prstGeom>
-          <a:noFill/>
-          <a:ln/>
-        </p:spPr>
-        <p:txBody>
-          <a:bodyPr wrap="square" lIns="0" tIns="0" rIns="0" bIns="0" rtlCol="0" anchor="ctr"/>
-          <a:lstStyle/>
-          <a:p>
-            <a:pPr indent="0" marL="0">
-              <a:buNone/>
-            </a:pPr>
-            <a:r>
-              <a:rPr lang="en-US" sz="900" b="1" spc="150" kern="0" dirty="0">
-                <a:solidFill>
-                  <a:srgbClr val="FF640D"/>
-                </a:solidFill>
-                <a:latin typeface="Arial" pitchFamily="34" charset="0"/>
-                <a:ea typeface="Arial" pitchFamily="34" charset="-122"/>
-                <a:cs typeface="Arial" pitchFamily="34" charset="-120"/>
-              </a:rPr>
-              <a:t>WHAT CHANGES</a:t>
-            </a:r>
-            <a:endParaRPr lang="en-US" sz="900" dirty="0"/>
-          </a:p>
-        </p:txBody>
-      </p:sp>
-      <p:sp>
-        <p:nvSpPr>
-          <p:cNvPr id="5" name="Text 3"/>
-          <p:cNvSpPr/>
-          <p:nvPr/>
-        </p:nvSpPr>
-        <p:spPr>
-          <a:xfrm>
-            <a:off x="987552" y="1828800"/>
-            <a:ext cx="8412480" cy="2560320"/>
+              <a:t>CHAPTERS</a:t>
+            </a:r>
+            <a:endParaRPr lang="en-US" sz="800" dirty="0"/>
+          </a:p>
+        </p:txBody>
+      </p:sp>
+      <p:sp>
+        <p:nvSpPr>
+          <p:cNvPr id="6" name="Shape 4"/>
+          <p:cNvSpPr/>
+          <p:nvPr/>
+        </p:nvSpPr>
+        <p:spPr>
+          <a:xfrm>
+            <a:off x="6217920" y="1353312"/>
+            <a:ext cx="4892040" cy="22860"/>
+          </a:xfrm>
+          <a:prstGeom prst="rect">
+            <a:avLst/>
+          </a:prstGeom>
+          <a:solidFill>
+            <a:srgbClr val="FF640D"/>
+          </a:solidFill>
+          <a:ln w="12700">
+            <a:solidFill>
+              <a:srgbClr val="FF640D">
+                <a:alpha val="0"/>
+              </a:srgbClr>
+            </a:solidFill>
+            <a:prstDash val="solid"/>
+          </a:ln>
+        </p:spPr>
+      </p:sp>
+      <p:sp>
+        <p:nvSpPr>
+          <p:cNvPr id="7" name="Text 5"/>
+          <p:cNvSpPr/>
+          <p:nvPr/>
+        </p:nvSpPr>
+        <p:spPr>
+          <a:xfrm>
+            <a:off x="6217920" y="1627632"/>
+            <a:ext cx="4892040" cy="1325880"/>
           </a:xfrm>
           <a:prstGeom prst="rect">
             <a:avLst/>
@@ -1933,23 +2365,105 @@
               <a:buNone/>
             </a:pPr>
             <a:r>
-              <a:rPr lang="en-US" sz="4400" dirty="0">
-                <a:solidFill>
-                  <a:srgbClr val="FAF8F3"/>
-                </a:solidFill>
-                <a:latin typeface="Arial" pitchFamily="34" charset="0"/>
-                <a:ea typeface="Arial" pitchFamily="34" charset="-122"/>
-                <a:cs typeface="Arial" pitchFamily="34" charset="-120"/>
-              </a:rPr>
-              <a:t>Your events are financially sustainable</a:t>
-            </a:r>
-            <a:endParaRPr lang="en-US" sz="4400" dirty="0"/>
-          </a:p>
-        </p:txBody>
-      </p:sp>
-      <p:sp>
-        <p:nvSpPr>
-          <p:cNvPr id="6" name="Text 4"/>
+              <a:rPr lang="en-US" sz="5800" dirty="0">
+                <a:solidFill>
+                  <a:srgbClr val="171717"/>
+                </a:solidFill>
+                <a:latin typeface="Arial" pitchFamily="34" charset="0"/>
+                <a:ea typeface="Arial" pitchFamily="34" charset="-122"/>
+                <a:cs typeface="Arial" pitchFamily="34" charset="-120"/>
+              </a:rPr>
+              <a:t>40+</a:t>
+            </a:r>
+            <a:endParaRPr lang="en-US" sz="5800" dirty="0"/>
+          </a:p>
+        </p:txBody>
+      </p:sp>
+      <p:sp>
+        <p:nvSpPr>
+          <p:cNvPr id="8" name="Text 6"/>
+          <p:cNvSpPr/>
+          <p:nvPr/>
+        </p:nvSpPr>
+        <p:spPr>
+          <a:xfrm>
+            <a:off x="6217920" y="2962656"/>
+            <a:ext cx="4892040" cy="384048"/>
+          </a:xfrm>
+          <a:prstGeom prst="rect">
+            <a:avLst/>
+          </a:prstGeom>
+          <a:noFill/>
+          <a:ln/>
+        </p:spPr>
+        <p:txBody>
+          <a:bodyPr wrap="square" lIns="0" tIns="0" rIns="0" bIns="0" rtlCol="0" anchor="ctr"/>
+          <a:lstStyle/>
+          <a:p>
+            <a:pPr indent="0" marL="0">
+              <a:buNone/>
+            </a:pPr>
+            <a:r>
+              <a:rPr lang="en-US" sz="800" b="1" dirty="0">
+                <a:solidFill>
+                  <a:srgbClr val="171717">
+                    <a:alpha val="66000"/>
+                  </a:srgbClr>
+                </a:solidFill>
+                <a:latin typeface="Arial" pitchFamily="34" charset="0"/>
+                <a:ea typeface="Arial" pitchFamily="34" charset="-122"/>
+                <a:cs typeface="Arial" pitchFamily="34" charset="-120"/>
+              </a:rPr>
+              <a:t>COUNTRIES</a:t>
+            </a:r>
+            <a:endParaRPr lang="en-US" sz="800" dirty="0"/>
+          </a:p>
+        </p:txBody>
+      </p:sp>
+      <p:sp>
+        <p:nvSpPr>
+          <p:cNvPr id="9" name="Text 7"/>
+          <p:cNvSpPr/>
+          <p:nvPr/>
+        </p:nvSpPr>
+        <p:spPr>
+          <a:xfrm>
+            <a:off x="685800" y="3886200"/>
+            <a:ext cx="8961120" cy="960120"/>
+          </a:xfrm>
+          <a:prstGeom prst="rect">
+            <a:avLst/>
+          </a:prstGeom>
+          <a:noFill/>
+          <a:ln/>
+        </p:spPr>
+        <p:txBody>
+          <a:bodyPr wrap="square" lIns="0" tIns="0" rIns="0" bIns="0" rtlCol="0" anchor="t">
+            <a:normAutofit/>
+          </a:bodyPr>
+          <a:lstStyle/>
+          <a:p>
+            <a:pPr indent="0" marL="0">
+              <a:buNone/>
+            </a:pPr>
+            <a:r>
+              <a:rPr lang="en-US" sz="1600" dirty="0">
+                <a:solidFill>
+                  <a:srgbClr val="171717"/>
+                </a:solidFill>
+                <a:latin typeface="Arial" pitchFamily="34" charset="0"/>
+                <a:ea typeface="Arial" pitchFamily="34" charset="-122"/>
+                <a:cs typeface="Arial" pitchFamily="34" charset="-120"/>
+              </a:rPr>
+              <a:t>400+ volunteer organizers, with a community that includes everyone from solo founders to teams at the biggest AI labs in the world.</a:t>
+            </a:r>
+            <a:endParaRPr lang="en-US" sz="1600" dirty="0"/>
+          </a:p>
+        </p:txBody>
+      </p:sp>
+      <p:sp>
+        <p:nvSpPr>
+          <p:cNvPr id="10" name="Text 8"/>
           <p:cNvSpPr/>
           <p:nvPr/>
         </p:nvSpPr>
@@ -1976,7 +2490,7 @@
             <a:r>
               <a:rPr lang="en-US" sz="800" dirty="0">
                 <a:solidFill>
-                  <a:srgbClr val="FAF8F3">
+                  <a:srgbClr val="171717">
                     <a:alpha val="66000"/>
                   </a:srgbClr>
                 </a:solidFill>
@@ -1984,7 +2498,7 @@
                 <a:ea typeface="Arial" pitchFamily="34" charset="-122"/>
                 <a:cs typeface="Arial" pitchFamily="34" charset="-120"/>
               </a:rPr>
-              <a:t>Source: Chapter Startup FAQ</a:t>
+              <a:t>Source: AI Collective Newsletter</a:t>
             </a:r>
             <a:endParaRPr lang="en-US" sz="800" dirty="0"/>
           </a:p>
@@ -1992,7 +2506,7 @@
       </p:sp>
       <p:sp>
         <p:nvSpPr>
-          <p:cNvPr id="7" name="Text 5"/>
+          <p:cNvPr id="11" name="Text 9"/>
           <p:cNvSpPr/>
           <p:nvPr/>
         </p:nvSpPr>
@@ -2017,7 +2531,7 @@
             <a:r>
               <a:rPr lang="en-US" sz="800" dirty="0">
                 <a:solidFill>
-                  <a:srgbClr val="FAF8F3">
+                  <a:srgbClr val="171717">
                     <a:alpha val="66000"/>
                   </a:srgbClr>
                 </a:solidFill>
@@ -2065,13 +2579,320 @@
       </p:grpSpPr>
       <p:sp>
         <p:nvSpPr>
+          <p:cNvPr id="2" name="Shape 0"/>
+          <p:cNvSpPr/>
+          <p:nvPr/>
+        </p:nvSpPr>
+        <p:spPr>
+          <a:xfrm>
+            <a:off x="0" y="0"/>
+            <a:ext cx="3401568" cy="6858000"/>
+          </a:xfrm>
+          <a:prstGeom prst="rect">
+            <a:avLst/>
+          </a:prstGeom>
+          <a:solidFill>
+            <a:srgbClr val="FF640D">
+              <a:alpha val="8000"/>
+            </a:srgbClr>
+          </a:solidFill>
+          <a:ln w="12700">
+            <a:solidFill>
+              <a:srgbClr val="FF640D">
+                <a:alpha val="0"/>
+              </a:srgbClr>
+            </a:solidFill>
+            <a:prstDash val="solid"/>
+          </a:ln>
+        </p:spPr>
+      </p:sp>
+      <p:sp>
+        <p:nvSpPr>
+          <p:cNvPr id="3" name="Text 1"/>
+          <p:cNvSpPr/>
+          <p:nvPr/>
+        </p:nvSpPr>
+        <p:spPr>
+          <a:xfrm>
+            <a:off x="658368" y="1920240"/>
+            <a:ext cx="2743200" cy="1920240"/>
+          </a:xfrm>
+          <a:prstGeom prst="rect">
+            <a:avLst/>
+          </a:prstGeom>
+          <a:noFill/>
+          <a:ln/>
+        </p:spPr>
+        <p:txBody>
+          <a:bodyPr wrap="square" lIns="0" tIns="0" rIns="0" bIns="0" rtlCol="0" anchor="ctr">
+            <a:normAutofit/>
+          </a:bodyPr>
+          <a:lstStyle/>
+          <a:p>
+            <a:pPr indent="0" marL="0">
+              <a:buNone/>
+            </a:pPr>
+            <a:r>
+              <a:rPr lang="en-US" sz="10400" dirty="0">
+                <a:solidFill>
+                  <a:srgbClr val="FF640D"/>
+                </a:solidFill>
+                <a:latin typeface="Arial" pitchFamily="34" charset="0"/>
+                <a:ea typeface="Arial" pitchFamily="34" charset="-122"/>
+                <a:cs typeface="Arial" pitchFamily="34" charset="-120"/>
+              </a:rPr>
+              <a:t>03</a:t>
+            </a:r>
+            <a:endParaRPr lang="en-US" sz="10400" dirty="0"/>
+          </a:p>
+        </p:txBody>
+      </p:sp>
+      <p:sp>
+        <p:nvSpPr>
+          <p:cNvPr id="4" name="Text 2"/>
+          <p:cNvSpPr/>
+          <p:nvPr/>
+        </p:nvSpPr>
+        <p:spPr>
+          <a:xfrm>
+            <a:off x="3886200" y="1170432"/>
+            <a:ext cx="5120640" cy="182880"/>
+          </a:xfrm>
+          <a:prstGeom prst="rect">
+            <a:avLst/>
+          </a:prstGeom>
+          <a:noFill/>
+          <a:ln/>
+        </p:spPr>
+        <p:txBody>
+          <a:bodyPr wrap="square" lIns="0" tIns="0" rIns="0" bIns="0" rtlCol="0" anchor="ctr"/>
+          <a:lstStyle/>
+          <a:p>
+            <a:pPr indent="0" marL="0">
+              <a:buNone/>
+            </a:pPr>
+            <a:r>
+              <a:rPr lang="en-US" sz="900" b="1" spc="150" kern="0" dirty="0">
+                <a:solidFill>
+                  <a:srgbClr val="FF640D"/>
+                </a:solidFill>
+                <a:latin typeface="Arial" pitchFamily="34" charset="0"/>
+                <a:ea typeface="Arial" pitchFamily="34" charset="-122"/>
+                <a:cs typeface="Arial" pitchFamily="34" charset="-120"/>
+              </a:rPr>
+              <a:t>WHAT CHANGES</a:t>
+            </a:r>
+            <a:endParaRPr lang="en-US" sz="900" dirty="0"/>
+          </a:p>
+        </p:txBody>
+      </p:sp>
+      <p:sp>
+        <p:nvSpPr>
+          <p:cNvPr id="5" name="Text 3"/>
+          <p:cNvSpPr/>
+          <p:nvPr/>
+        </p:nvSpPr>
+        <p:spPr>
+          <a:xfrm>
+            <a:off x="3858768" y="1572768"/>
+            <a:ext cx="7132320" cy="1417320"/>
+          </a:xfrm>
+          <a:prstGeom prst="rect">
+            <a:avLst/>
+          </a:prstGeom>
+          <a:noFill/>
+          <a:ln/>
+        </p:spPr>
+        <p:txBody>
+          <a:bodyPr wrap="square" lIns="0" tIns="0" rIns="0" bIns="0" rtlCol="0" anchor="ctr">
+            <a:normAutofit/>
+          </a:bodyPr>
+          <a:lstStyle/>
+          <a:p>
+            <a:pPr indent="0" marL="0">
+              <a:buNone/>
+            </a:pPr>
+            <a:r>
+              <a:rPr lang="en-US" sz="3000" dirty="0">
+                <a:solidFill>
+                  <a:srgbClr val="171717"/>
+                </a:solidFill>
+                <a:latin typeface="Arial" pitchFamily="34" charset="0"/>
+                <a:ea typeface="Arial" pitchFamily="34" charset="-122"/>
+                <a:cs typeface="Arial" pitchFamily="34" charset="-120"/>
+              </a:rPr>
+              <a:t>Start with one repeatable event format</a:t>
+            </a:r>
+            <a:endParaRPr lang="en-US" sz="3000" dirty="0"/>
+          </a:p>
+        </p:txBody>
+      </p:sp>
+      <p:sp>
+        <p:nvSpPr>
+          <p:cNvPr id="6" name="Text 4"/>
+          <p:cNvSpPr/>
+          <p:nvPr/>
+        </p:nvSpPr>
+        <p:spPr>
+          <a:xfrm>
+            <a:off x="3886200" y="3246120"/>
+            <a:ext cx="6812280" cy="1417320"/>
+          </a:xfrm>
+          <a:prstGeom prst="rect">
+            <a:avLst/>
+          </a:prstGeom>
+          <a:noFill/>
+          <a:ln/>
+        </p:spPr>
+        <p:txBody>
+          <a:bodyPr wrap="square" lIns="0" tIns="0" rIns="0" bIns="0" rtlCol="0" anchor="t">
+            <a:normAutofit/>
+          </a:bodyPr>
+          <a:lstStyle/>
+          <a:p>
+            <a:pPr indent="0" marL="0">
+              <a:buNone/>
+            </a:pPr>
+            <a:r>
+              <a:rPr lang="en-US" sz="1700" dirty="0">
+                <a:solidFill>
+                  <a:srgbClr val="171717"/>
+                </a:solidFill>
+                <a:latin typeface="Arial" pitchFamily="34" charset="0"/>
+                <a:ea typeface="Arial" pitchFamily="34" charset="-122"/>
+                <a:cs typeface="Arial" pitchFamily="34" charset="-120"/>
+              </a:rPr>
+              <a:t>The network already runs Demo Nights, hackathons, private dinners, and workshops. Choose one format that matches the local audience and can repeat.</a:t>
+            </a:r>
+            <a:endParaRPr lang="en-US" sz="1700" dirty="0"/>
+          </a:p>
+        </p:txBody>
+      </p:sp>
+      <p:sp>
+        <p:nvSpPr>
+          <p:cNvPr id="7" name="Text 5"/>
+          <p:cNvSpPr/>
+          <p:nvPr/>
+        </p:nvSpPr>
+        <p:spPr>
+          <a:xfrm>
+            <a:off x="658368" y="6547104"/>
+            <a:ext cx="9966960" cy="164592"/>
+          </a:xfrm>
+          <a:prstGeom prst="rect">
+            <a:avLst/>
+          </a:prstGeom>
+          <a:noFill/>
+          <a:ln/>
+        </p:spPr>
+        <p:txBody>
+          <a:bodyPr wrap="square" lIns="0" tIns="0" rIns="0" bIns="0" rtlCol="0" anchor="ctr">
+            <a:normAutofit/>
+          </a:bodyPr>
+          <a:lstStyle/>
+          <a:p>
+            <a:pPr indent="0" marL="0">
+              <a:buNone/>
+            </a:pPr>
+            <a:r>
+              <a:rPr lang="en-US" sz="800" dirty="0">
+                <a:solidFill>
+                  <a:srgbClr val="171717">
+                    <a:alpha val="66000"/>
+                  </a:srgbClr>
+                </a:solidFill>
+                <a:latin typeface="Arial" pitchFamily="34" charset="0"/>
+                <a:ea typeface="Arial" pitchFamily="34" charset="-122"/>
+                <a:cs typeface="Arial" pitchFamily="34" charset="-120"/>
+              </a:rPr>
+              <a:t>Source: AI Collective Newsletter · FAQ</a:t>
+            </a:r>
+            <a:endParaRPr lang="en-US" sz="800" dirty="0"/>
+          </a:p>
+        </p:txBody>
+      </p:sp>
+      <p:sp>
+        <p:nvSpPr>
+          <p:cNvPr id="8" name="Text 6"/>
+          <p:cNvSpPr/>
+          <p:nvPr/>
+        </p:nvSpPr>
+        <p:spPr>
+          <a:xfrm>
+            <a:off x="11018520" y="6519672"/>
+            <a:ext cx="502920" cy="182880"/>
+          </a:xfrm>
+          <a:prstGeom prst="rect">
+            <a:avLst/>
+          </a:prstGeom>
+          <a:noFill/>
+          <a:ln/>
+        </p:spPr>
+        <p:txBody>
+          <a:bodyPr wrap="square" lIns="0" tIns="0" rIns="0" bIns="0" rtlCol="0" anchor="ctr"/>
+          <a:lstStyle/>
+          <a:p>
+            <a:pPr algn="r" indent="0" marL="0">
+              <a:buNone/>
+            </a:pPr>
+            <a:r>
+              <a:rPr lang="en-US" sz="800" dirty="0">
+                <a:solidFill>
+                  <a:srgbClr val="171717">
+                    <a:alpha val="66000"/>
+                  </a:srgbClr>
+                </a:solidFill>
+                <a:latin typeface="Arial" pitchFamily="34" charset="0"/>
+                <a:ea typeface="Arial" pitchFamily="34" charset="-122"/>
+                <a:cs typeface="Arial" pitchFamily="34" charset="-120"/>
+              </a:rPr>
+              <a:t>04</a:t>
+            </a:r>
+            <a:endParaRPr lang="en-US" sz="800" dirty="0"/>
+          </a:p>
+        </p:txBody>
+      </p:sp>
+    </p:spTree>
+  </p:cSld>
+  <p:clrMapOvr>
+    <a:masterClrMapping/>
+  </p:clrMapOvr>
+</p:sld>
+</file>
+
+<file path=ppt/slides/slide5.xml><?xml version="1.0" encoding="utf-8"?>
+<p:sld xmlns:a="http://schemas.openxmlformats.org/drawingml/2006/main" xmlns:r="http://schemas.openxmlformats.org/officeDocument/2006/relationships" xmlns:p="http://schemas.openxmlformats.org/presentationml/2006/main">
+  <p:cSld name="Slide 5">
+    <p:bg>
+      <p:bgPr>
+        <a:solidFill>
+          <a:srgbClr val="FAF8F3"/>
+        </a:solidFill>
+      </p:bgPr>
+    </p:bg>
+    <p:spTree>
+      <p:nvGrpSpPr>
+        <p:cNvPr id="1" name=""/>
+        <p:cNvGrpSpPr/>
+        <p:nvPr/>
+      </p:nvGrpSpPr>
+      <p:grpSpPr>
+        <a:xfrm>
+          <a:off x="0" y="0"/>
+          <a:ext cx="0" cy="0"/>
+          <a:chOff x="0" y="0"/>
+          <a:chExt cx="0" cy="0"/>
+        </a:xfrm>
+      </p:grpSpPr>
+      <p:sp>
+        <p:nvSpPr>
           <p:cNvPr id="2" name="Text 0"/>
           <p:cNvSpPr/>
           <p:nvPr/>
         </p:nvSpPr>
         <p:spPr>
           <a:xfrm>
-            <a:off x="685800" y="749808"/>
+            <a:off x="685800" y="713232"/>
             <a:ext cx="5120640" cy="182880"/>
           </a:xfrm>
           <a:prstGeom prst="rect">
@@ -2096,7 +2917,7 @@
                 <a:ea typeface="Arial" pitchFamily="34" charset="-122"/>
                 <a:cs typeface="Arial" pitchFamily="34" charset="-120"/>
               </a:rPr>
-              <a:t>EVIDENCE</a:t>
+              <a:t>LAUNCH PLAN</a:t>
             </a:r>
             <a:endParaRPr lang="en-US" sz="900" dirty="0"/>
           </a:p>
@@ -2104,14 +2925,98 @@
       </p:sp>
       <p:sp>
         <p:nvSpPr>
-          <p:cNvPr id="3" name="Shape 1"/>
-          <p:cNvSpPr/>
-          <p:nvPr/>
-        </p:nvSpPr>
-        <p:spPr>
-          <a:xfrm>
-            <a:off x="685800" y="1353312"/>
-            <a:ext cx="4892040" cy="22860"/>
+          <p:cNvPr id="3" name="Text 1"/>
+          <p:cNvSpPr/>
+          <p:nvPr/>
+        </p:nvSpPr>
+        <p:spPr>
+          <a:xfrm>
+            <a:off x="658368" y="1078992"/>
+            <a:ext cx="10332720" cy="868680"/>
+          </a:xfrm>
+          <a:prstGeom prst="rect">
+            <a:avLst/>
+          </a:prstGeom>
+          <a:noFill/>
+          <a:ln/>
+        </p:spPr>
+        <p:txBody>
+          <a:bodyPr wrap="square" lIns="0" tIns="0" rIns="0" bIns="0" rtlCol="0" anchor="ctr">
+            <a:normAutofit/>
+          </a:bodyPr>
+          <a:lstStyle/>
+          <a:p>
+            <a:pPr indent="0" marL="0">
+              <a:buNone/>
+            </a:pPr>
+            <a:r>
+              <a:rPr lang="en-US" sz="3200" dirty="0">
+                <a:solidFill>
+                  <a:srgbClr val="171717"/>
+                </a:solidFill>
+                <a:latin typeface="Arial" pitchFamily="34" charset="0"/>
+                <a:ea typeface="Arial" pitchFamily="34" charset="-122"/>
+                <a:cs typeface="Arial" pitchFamily="34" charset="-120"/>
+              </a:rPr>
+              <a:t>A four-week launch sequence</a:t>
+            </a:r>
+            <a:endParaRPr lang="en-US" sz="3200" dirty="0"/>
+          </a:p>
+        </p:txBody>
+      </p:sp>
+      <p:sp>
+        <p:nvSpPr>
+          <p:cNvPr id="4" name="Text 2"/>
+          <p:cNvSpPr/>
+          <p:nvPr/>
+        </p:nvSpPr>
+        <p:spPr>
+          <a:xfrm>
+            <a:off x="685800" y="1938528"/>
+            <a:ext cx="9326880" cy="384048"/>
+          </a:xfrm>
+          <a:prstGeom prst="rect">
+            <a:avLst/>
+          </a:prstGeom>
+          <a:noFill/>
+          <a:ln/>
+        </p:spPr>
+        <p:txBody>
+          <a:bodyPr wrap="square" lIns="0" tIns="0" rIns="0" bIns="0" rtlCol="0" anchor="ctr">
+            <a:normAutofit/>
+          </a:bodyPr>
+          <a:lstStyle/>
+          <a:p>
+            <a:pPr indent="0" marL="0">
+              <a:buNone/>
+            </a:pPr>
+            <a:r>
+              <a:rPr lang="en-US" sz="1200" dirty="0">
+                <a:solidFill>
+                  <a:srgbClr val="171717">
+                    <a:alpha val="72000"/>
+                  </a:srgbClr>
+                </a:solidFill>
+                <a:latin typeface="Arial" pitchFamily="34" charset="0"/>
+                <a:ea typeface="Arial" pitchFamily="34" charset="-122"/>
+                <a:cs typeface="Arial" pitchFamily="34" charset="-120"/>
+              </a:rPr>
+              <a:t>WorkshopLM recommendation derived from the chapter brief; confirm timing and required approvals with AI Collective HQ.</a:t>
+            </a:r>
+            <a:endParaRPr lang="en-US" sz="1200" dirty="0"/>
+          </a:p>
+        </p:txBody>
+      </p:sp>
+      <p:sp>
+        <p:nvSpPr>
+          <p:cNvPr id="5" name="Shape 3"/>
+          <p:cNvSpPr/>
+          <p:nvPr/>
+        </p:nvSpPr>
+        <p:spPr>
+          <a:xfrm>
+            <a:off x="685800" y="2743200"/>
+            <a:ext cx="2468880" cy="32004"/>
           </a:xfrm>
           <a:prstGeom prst="rect">
             <a:avLst/>
@@ -2131,14 +3036,82 @@
       </p:sp>
       <p:sp>
         <p:nvSpPr>
-          <p:cNvPr id="4" name="Text 2"/>
-          <p:cNvSpPr/>
-          <p:nvPr/>
-        </p:nvSpPr>
-        <p:spPr>
-          <a:xfrm>
-            <a:off x="685800" y="1627632"/>
-            <a:ext cx="4892040" cy="1325880"/>
+          <p:cNvPr id="6" name="Shape 4"/>
+          <p:cNvSpPr/>
+          <p:nvPr/>
+        </p:nvSpPr>
+        <p:spPr>
+          <a:xfrm>
+            <a:off x="685800" y="2779776"/>
+            <a:ext cx="2468880" cy="1965960"/>
+          </a:xfrm>
+          <a:prstGeom prst="rect">
+            <a:avLst/>
+          </a:prstGeom>
+          <a:solidFill>
+            <a:srgbClr val="FF640D">
+              <a:alpha val="5000"/>
+            </a:srgbClr>
+          </a:solidFill>
+          <a:ln w="12700">
+            <a:solidFill>
+              <a:srgbClr val="FF640D">
+                <a:alpha val="0"/>
+              </a:srgbClr>
+            </a:solidFill>
+            <a:prstDash val="solid"/>
+          </a:ln>
+        </p:spPr>
+      </p:sp>
+      <p:sp>
+        <p:nvSpPr>
+          <p:cNvPr id="7" name="Text 5"/>
+          <p:cNvSpPr/>
+          <p:nvPr/>
+        </p:nvSpPr>
+        <p:spPr>
+          <a:xfrm>
+            <a:off x="850392" y="3063240"/>
+            <a:ext cx="2103120" cy="182880"/>
+          </a:xfrm>
+          <a:prstGeom prst="rect">
+            <a:avLst/>
+          </a:prstGeom>
+          <a:noFill/>
+          <a:ln/>
+        </p:spPr>
+        <p:txBody>
+          <a:bodyPr wrap="square" lIns="0" tIns="0" rIns="0" bIns="0" rtlCol="0" anchor="ctr"/>
+          <a:lstStyle/>
+          <a:p>
+            <a:pPr indent="0" marL="0">
+              <a:buNone/>
+            </a:pPr>
+            <a:r>
+              <a:rPr lang="en-US" sz="800" b="1" spc="120" kern="0" dirty="0">
+                <a:solidFill>
+                  <a:srgbClr val="FF640D"/>
+                </a:solidFill>
+                <a:latin typeface="Arial" pitchFamily="34" charset="0"/>
+                <a:ea typeface="Arial" pitchFamily="34" charset="-122"/>
+                <a:cs typeface="Arial" pitchFamily="34" charset="-120"/>
+              </a:rPr>
+              <a:t>WEEK 1</a:t>
+            </a:r>
+            <a:endParaRPr lang="en-US" sz="800" dirty="0"/>
+          </a:p>
+        </p:txBody>
+      </p:sp>
+      <p:sp>
+        <p:nvSpPr>
+          <p:cNvPr id="8" name="Text 6"/>
+          <p:cNvSpPr/>
+          <p:nvPr/>
+        </p:nvSpPr>
+        <p:spPr>
+          <a:xfrm>
+            <a:off x="850392" y="3493008"/>
+            <a:ext cx="2057400" cy="804672"/>
           </a:xfrm>
           <a:prstGeom prst="rect">
             <a:avLst/>
@@ -2156,7 +3129,7 @@
               <a:buNone/>
             </a:pPr>
             <a:r>
-              <a:rPr lang="en-US" sz="5800" dirty="0">
+              <a:rPr lang="en-US" sz="1700" dirty="0">
                 <a:solidFill>
                   <a:srgbClr val="171717"/>
                 </a:solidFill>
@@ -2164,63 +3137,22 @@
                 <a:ea typeface="Arial" pitchFamily="34" charset="-122"/>
                 <a:cs typeface="Arial" pitchFamily="34" charset="-120"/>
               </a:rPr>
-              <a:t>180+</a:t>
-            </a:r>
-            <a:endParaRPr lang="en-US" sz="5800" dirty="0"/>
-          </a:p>
-        </p:txBody>
-      </p:sp>
-      <p:sp>
-        <p:nvSpPr>
-          <p:cNvPr id="5" name="Text 3"/>
-          <p:cNvSpPr/>
-          <p:nvPr/>
-        </p:nvSpPr>
-        <p:spPr>
-          <a:xfrm>
-            <a:off x="685800" y="2962656"/>
-            <a:ext cx="4892040" cy="384048"/>
-          </a:xfrm>
-          <a:prstGeom prst="rect">
-            <a:avLst/>
-          </a:prstGeom>
-          <a:noFill/>
-          <a:ln/>
-        </p:spPr>
-        <p:txBody>
-          <a:bodyPr wrap="square" lIns="0" tIns="0" rIns="0" bIns="0" rtlCol="0" anchor="ctr"/>
-          <a:lstStyle/>
-          <a:p>
-            <a:pPr indent="0" marL="0">
-              <a:buNone/>
-            </a:pPr>
-            <a:r>
-              <a:rPr lang="en-US" sz="800" b="1" dirty="0">
-                <a:solidFill>
-                  <a:srgbClr val="171717">
-                    <a:alpha val="66000"/>
-                  </a:srgbClr>
-                </a:solidFill>
-                <a:latin typeface="Arial" pitchFamily="34" charset="0"/>
-                <a:ea typeface="Arial" pitchFamily="34" charset="-122"/>
-                <a:cs typeface="Arial" pitchFamily="34" charset="-120"/>
-              </a:rPr>
-              <a:t>CHAPTERS</a:t>
-            </a:r>
-            <a:endParaRPr lang="en-US" sz="800" dirty="0"/>
-          </a:p>
-        </p:txBody>
-      </p:sp>
-      <p:sp>
-        <p:nvSpPr>
-          <p:cNvPr id="6" name="Shape 4"/>
-          <p:cNvSpPr/>
-          <p:nvPr/>
-        </p:nvSpPr>
-        <p:spPr>
-          <a:xfrm>
-            <a:off x="6217920" y="1353312"/>
-            <a:ext cx="4892040" cy="22860"/>
+              <a:t>Confirm the lead team and chapter purpose</a:t>
+            </a:r>
+            <a:endParaRPr lang="en-US" sz="1700" dirty="0"/>
+          </a:p>
+        </p:txBody>
+      </p:sp>
+      <p:sp>
+        <p:nvSpPr>
+          <p:cNvPr id="9" name="Shape 7"/>
+          <p:cNvSpPr/>
+          <p:nvPr/>
+        </p:nvSpPr>
+        <p:spPr>
+          <a:xfrm>
+            <a:off x="3474720" y="2743200"/>
+            <a:ext cx="2468880" cy="32004"/>
           </a:xfrm>
           <a:prstGeom prst="rect">
             <a:avLst/>
@@ -2240,14 +3172,82 @@
       </p:sp>
       <p:sp>
         <p:nvSpPr>
-          <p:cNvPr id="7" name="Text 5"/>
-          <p:cNvSpPr/>
-          <p:nvPr/>
-        </p:nvSpPr>
-        <p:spPr>
-          <a:xfrm>
-            <a:off x="6217920" y="1627632"/>
-            <a:ext cx="4892040" cy="1325880"/>
+          <p:cNvPr id="10" name="Shape 8"/>
+          <p:cNvSpPr/>
+          <p:nvPr/>
+        </p:nvSpPr>
+        <p:spPr>
+          <a:xfrm>
+            <a:off x="3474720" y="2779776"/>
+            <a:ext cx="2468880" cy="1965960"/>
+          </a:xfrm>
+          <a:prstGeom prst="rect">
+            <a:avLst/>
+          </a:prstGeom>
+          <a:solidFill>
+            <a:srgbClr val="FF640D">
+              <a:alpha val="5000"/>
+            </a:srgbClr>
+          </a:solidFill>
+          <a:ln w="12700">
+            <a:solidFill>
+              <a:srgbClr val="FF640D">
+                <a:alpha val="0"/>
+              </a:srgbClr>
+            </a:solidFill>
+            <a:prstDash val="solid"/>
+          </a:ln>
+        </p:spPr>
+      </p:sp>
+      <p:sp>
+        <p:nvSpPr>
+          <p:cNvPr id="11" name="Text 9"/>
+          <p:cNvSpPr/>
+          <p:nvPr/>
+        </p:nvSpPr>
+        <p:spPr>
+          <a:xfrm>
+            <a:off x="3639312" y="3063240"/>
+            <a:ext cx="2103120" cy="182880"/>
+          </a:xfrm>
+          <a:prstGeom prst="rect">
+            <a:avLst/>
+          </a:prstGeom>
+          <a:noFill/>
+          <a:ln/>
+        </p:spPr>
+        <p:txBody>
+          <a:bodyPr wrap="square" lIns="0" tIns="0" rIns="0" bIns="0" rtlCol="0" anchor="ctr"/>
+          <a:lstStyle/>
+          <a:p>
+            <a:pPr indent="0" marL="0">
+              <a:buNone/>
+            </a:pPr>
+            <a:r>
+              <a:rPr lang="en-US" sz="800" b="1" spc="120" kern="0" dirty="0">
+                <a:solidFill>
+                  <a:srgbClr val="FF640D"/>
+                </a:solidFill>
+                <a:latin typeface="Arial" pitchFamily="34" charset="0"/>
+                <a:ea typeface="Arial" pitchFamily="34" charset="-122"/>
+                <a:cs typeface="Arial" pitchFamily="34" charset="-120"/>
+              </a:rPr>
+              <a:t>WEEK 2</a:t>
+            </a:r>
+            <a:endParaRPr lang="en-US" sz="800" dirty="0"/>
+          </a:p>
+        </p:txBody>
+      </p:sp>
+      <p:sp>
+        <p:nvSpPr>
+          <p:cNvPr id="12" name="Text 10"/>
+          <p:cNvSpPr/>
+          <p:nvPr/>
+        </p:nvSpPr>
+        <p:spPr>
+          <a:xfrm>
+            <a:off x="3639312" y="3493008"/>
+            <a:ext cx="2057400" cy="804672"/>
           </a:xfrm>
           <a:prstGeom prst="rect">
             <a:avLst/>
@@ -2265,7 +3265,7 @@
               <a:buNone/>
             </a:pPr>
             <a:r>
-              <a:rPr lang="en-US" sz="5800" dirty="0">
+              <a:rPr lang="en-US" sz="1700" dirty="0">
                 <a:solidFill>
                   <a:srgbClr val="171717"/>
                 </a:solidFill>
@@ -2273,22 +3273,78 @@
                 <a:ea typeface="Arial" pitchFamily="34" charset="-122"/>
                 <a:cs typeface="Arial" pitchFamily="34" charset="-120"/>
               </a:rPr>
-              <a:t>40+</a:t>
-            </a:r>
-            <a:endParaRPr lang="en-US" sz="5800" dirty="0"/>
-          </a:p>
-        </p:txBody>
-      </p:sp>
-      <p:sp>
-        <p:nvSpPr>
-          <p:cNvPr id="8" name="Text 6"/>
-          <p:cNvSpPr/>
-          <p:nvPr/>
-        </p:nvSpPr>
-        <p:spPr>
-          <a:xfrm>
-            <a:off x="6217920" y="2962656"/>
-            <a:ext cx="4892040" cy="384048"/>
+              <a:t>Secure the first format, venue, and partner</a:t>
+            </a:r>
+            <a:endParaRPr lang="en-US" sz="1700" dirty="0"/>
+          </a:p>
+        </p:txBody>
+      </p:sp>
+      <p:sp>
+        <p:nvSpPr>
+          <p:cNvPr id="13" name="Shape 11"/>
+          <p:cNvSpPr/>
+          <p:nvPr/>
+        </p:nvSpPr>
+        <p:spPr>
+          <a:xfrm>
+            <a:off x="6263640" y="2743200"/>
+            <a:ext cx="2468880" cy="32004"/>
+          </a:xfrm>
+          <a:prstGeom prst="rect">
+            <a:avLst/>
+          </a:prstGeom>
+          <a:solidFill>
+            <a:srgbClr val="FF640D"/>
+          </a:solidFill>
+          <a:ln w="12700">
+            <a:solidFill>
+              <a:srgbClr val="FF640D">
+                <a:alpha val="0"/>
+              </a:srgbClr>
+            </a:solidFill>
+            <a:prstDash val="solid"/>
+          </a:ln>
+        </p:spPr>
+      </p:sp>
+      <p:sp>
+        <p:nvSpPr>
+          <p:cNvPr id="14" name="Shape 12"/>
+          <p:cNvSpPr/>
+          <p:nvPr/>
+        </p:nvSpPr>
+        <p:spPr>
+          <a:xfrm>
+            <a:off x="6263640" y="2779776"/>
+            <a:ext cx="2468880" cy="1965960"/>
+          </a:xfrm>
+          <a:prstGeom prst="rect">
+            <a:avLst/>
+          </a:prstGeom>
+          <a:solidFill>
+            <a:srgbClr val="FF640D">
+              <a:alpha val="5000"/>
+            </a:srgbClr>
+          </a:solidFill>
+          <a:ln w="12700">
+            <a:solidFill>
+              <a:srgbClr val="FF640D">
+                <a:alpha val="0"/>
+              </a:srgbClr>
+            </a:solidFill>
+            <a:prstDash val="solid"/>
+          </a:ln>
+        </p:spPr>
+      </p:sp>
+      <p:sp>
+        <p:nvSpPr>
+          <p:cNvPr id="15" name="Text 13"/>
+          <p:cNvSpPr/>
+          <p:nvPr/>
+        </p:nvSpPr>
+        <p:spPr>
+          <a:xfrm>
+            <a:off x="6428232" y="3063240"/>
+            <a:ext cx="2103120" cy="182880"/>
           </a:xfrm>
           <a:prstGeom prst="rect">
             <a:avLst/>
@@ -2304,7 +3360,225 @@
               <a:buNone/>
             </a:pPr>
             <a:r>
-              <a:rPr lang="en-US" sz="800" b="1" dirty="0">
+              <a:rPr lang="en-US" sz="800" b="1" spc="120" kern="0" dirty="0">
+                <a:solidFill>
+                  <a:srgbClr val="FF640D"/>
+                </a:solidFill>
+                <a:latin typeface="Arial" pitchFamily="34" charset="0"/>
+                <a:ea typeface="Arial" pitchFamily="34" charset="-122"/>
+                <a:cs typeface="Arial" pitchFamily="34" charset="-120"/>
+              </a:rPr>
+              <a:t>WEEK 3</a:t>
+            </a:r>
+            <a:endParaRPr lang="en-US" sz="800" dirty="0"/>
+          </a:p>
+        </p:txBody>
+      </p:sp>
+      <p:sp>
+        <p:nvSpPr>
+          <p:cNvPr id="16" name="Text 14"/>
+          <p:cNvSpPr/>
+          <p:nvPr/>
+        </p:nvSpPr>
+        <p:spPr>
+          <a:xfrm>
+            <a:off x="6428232" y="3493008"/>
+            <a:ext cx="2057400" cy="804672"/>
+          </a:xfrm>
+          <a:prstGeom prst="rect">
+            <a:avLst/>
+          </a:prstGeom>
+          <a:noFill/>
+          <a:ln/>
+        </p:spPr>
+        <p:txBody>
+          <a:bodyPr wrap="square" lIns="0" tIns="0" rIns="0" bIns="0" rtlCol="0" anchor="ctr">
+            <a:normAutofit/>
+          </a:bodyPr>
+          <a:lstStyle/>
+          <a:p>
+            <a:pPr indent="0" marL="0">
+              <a:buNone/>
+            </a:pPr>
+            <a:r>
+              <a:rPr lang="en-US" sz="1700" dirty="0">
+                <a:solidFill>
+                  <a:srgbClr val="171717"/>
+                </a:solidFill>
+                <a:latin typeface="Arial" pitchFamily="34" charset="0"/>
+                <a:ea typeface="Arial" pitchFamily="34" charset="-122"/>
+                <a:cs typeface="Arial" pitchFamily="34" charset="-120"/>
+              </a:rPr>
+              <a:t>Open registration and activate local outreach</a:t>
+            </a:r>
+            <a:endParaRPr lang="en-US" sz="1700" dirty="0"/>
+          </a:p>
+        </p:txBody>
+      </p:sp>
+      <p:sp>
+        <p:nvSpPr>
+          <p:cNvPr id="17" name="Shape 15"/>
+          <p:cNvSpPr/>
+          <p:nvPr/>
+        </p:nvSpPr>
+        <p:spPr>
+          <a:xfrm>
+            <a:off x="9052560" y="2743200"/>
+            <a:ext cx="2468880" cy="32004"/>
+          </a:xfrm>
+          <a:prstGeom prst="rect">
+            <a:avLst/>
+          </a:prstGeom>
+          <a:solidFill>
+            <a:srgbClr val="FF640D"/>
+          </a:solidFill>
+          <a:ln w="12700">
+            <a:solidFill>
+              <a:srgbClr val="FF640D">
+                <a:alpha val="0"/>
+              </a:srgbClr>
+            </a:solidFill>
+            <a:prstDash val="solid"/>
+          </a:ln>
+        </p:spPr>
+      </p:sp>
+      <p:sp>
+        <p:nvSpPr>
+          <p:cNvPr id="18" name="Shape 16"/>
+          <p:cNvSpPr/>
+          <p:nvPr/>
+        </p:nvSpPr>
+        <p:spPr>
+          <a:xfrm>
+            <a:off x="9052560" y="2779776"/>
+            <a:ext cx="2468880" cy="1965960"/>
+          </a:xfrm>
+          <a:prstGeom prst="rect">
+            <a:avLst/>
+          </a:prstGeom>
+          <a:solidFill>
+            <a:srgbClr val="FF640D">
+              <a:alpha val="5000"/>
+            </a:srgbClr>
+          </a:solidFill>
+          <a:ln w="12700">
+            <a:solidFill>
+              <a:srgbClr val="FF640D">
+                <a:alpha val="0"/>
+              </a:srgbClr>
+            </a:solidFill>
+            <a:prstDash val="solid"/>
+          </a:ln>
+        </p:spPr>
+      </p:sp>
+      <p:sp>
+        <p:nvSpPr>
+          <p:cNvPr id="19" name="Text 17"/>
+          <p:cNvSpPr/>
+          <p:nvPr/>
+        </p:nvSpPr>
+        <p:spPr>
+          <a:xfrm>
+            <a:off x="9217152" y="3063240"/>
+            <a:ext cx="2103120" cy="182880"/>
+          </a:xfrm>
+          <a:prstGeom prst="rect">
+            <a:avLst/>
+          </a:prstGeom>
+          <a:noFill/>
+          <a:ln/>
+        </p:spPr>
+        <p:txBody>
+          <a:bodyPr wrap="square" lIns="0" tIns="0" rIns="0" bIns="0" rtlCol="0" anchor="ctr"/>
+          <a:lstStyle/>
+          <a:p>
+            <a:pPr indent="0" marL="0">
+              <a:buNone/>
+            </a:pPr>
+            <a:r>
+              <a:rPr lang="en-US" sz="800" b="1" spc="120" kern="0" dirty="0">
+                <a:solidFill>
+                  <a:srgbClr val="FF640D"/>
+                </a:solidFill>
+                <a:latin typeface="Arial" pitchFamily="34" charset="0"/>
+                <a:ea typeface="Arial" pitchFamily="34" charset="-122"/>
+                <a:cs typeface="Arial" pitchFamily="34" charset="-120"/>
+              </a:rPr>
+              <a:t>WEEK 4</a:t>
+            </a:r>
+            <a:endParaRPr lang="en-US" sz="800" dirty="0"/>
+          </a:p>
+        </p:txBody>
+      </p:sp>
+      <p:sp>
+        <p:nvSpPr>
+          <p:cNvPr id="20" name="Text 18"/>
+          <p:cNvSpPr/>
+          <p:nvPr/>
+        </p:nvSpPr>
+        <p:spPr>
+          <a:xfrm>
+            <a:off x="9217152" y="3493008"/>
+            <a:ext cx="2057400" cy="804672"/>
+          </a:xfrm>
+          <a:prstGeom prst="rect">
+            <a:avLst/>
+          </a:prstGeom>
+          <a:noFill/>
+          <a:ln/>
+        </p:spPr>
+        <p:txBody>
+          <a:bodyPr wrap="square" lIns="0" tIns="0" rIns="0" bIns="0" rtlCol="0" anchor="ctr">
+            <a:normAutofit/>
+          </a:bodyPr>
+          <a:lstStyle/>
+          <a:p>
+            <a:pPr indent="0" marL="0">
+              <a:buNone/>
+            </a:pPr>
+            <a:r>
+              <a:rPr lang="en-US" sz="1700" dirty="0">
+                <a:solidFill>
+                  <a:srgbClr val="171717"/>
+                </a:solidFill>
+                <a:latin typeface="Arial" pitchFamily="34" charset="0"/>
+                <a:ea typeface="Arial" pitchFamily="34" charset="-122"/>
+                <a:cs typeface="Arial" pitchFamily="34" charset="-120"/>
+              </a:rPr>
+              <a:t>Host the first event and review the evidence</a:t>
+            </a:r>
+            <a:endParaRPr lang="en-US" sz="1700" dirty="0"/>
+          </a:p>
+        </p:txBody>
+      </p:sp>
+      <p:sp>
+        <p:nvSpPr>
+          <p:cNvPr id="21" name="Text 19"/>
+          <p:cNvSpPr/>
+          <p:nvPr/>
+        </p:nvSpPr>
+        <p:spPr>
+          <a:xfrm>
+            <a:off x="658368" y="6547104"/>
+            <a:ext cx="9966960" cy="164592"/>
+          </a:xfrm>
+          <a:prstGeom prst="rect">
+            <a:avLst/>
+          </a:prstGeom>
+          <a:noFill/>
+          <a:ln/>
+        </p:spPr>
+        <p:txBody>
+          <a:bodyPr wrap="square" lIns="0" tIns="0" rIns="0" bIns="0" rtlCol="0" anchor="ctr">
+            <a:normAutofit/>
+          </a:bodyPr>
+          <a:lstStyle/>
+          <a:p>
+            <a:pPr indent="0" marL="0">
+              <a:buNone/>
+            </a:pPr>
+            <a:r>
+              <a:rPr lang="en-US" sz="800" dirty="0">
                 <a:solidFill>
                   <a:srgbClr val="171717">
                     <a:alpha val="66000"/>
@@ -2314,7 +3588,7 @@
                 <a:ea typeface="Arial" pitchFamily="34" charset="-122"/>
                 <a:cs typeface="Arial" pitchFamily="34" charset="-120"/>
               </a:rPr>
-              <a:t>COUNTRIES</a:t>
+              <a:t>Source: Derived plan · HQ validation required</a:t>
             </a:r>
             <a:endParaRPr lang="en-US" sz="800" dirty="0"/>
           </a:p>
@@ -2322,69 +3596,26 @@
       </p:sp>
       <p:sp>
         <p:nvSpPr>
-          <p:cNvPr id="9" name="Text 7"/>
-          <p:cNvSpPr/>
-          <p:nvPr/>
-        </p:nvSpPr>
-        <p:spPr>
-          <a:xfrm>
-            <a:off x="685800" y="3886200"/>
-            <a:ext cx="8961120" cy="960120"/>
-          </a:xfrm>
-          <a:prstGeom prst="rect">
-            <a:avLst/>
-          </a:prstGeom>
-          <a:noFill/>
-          <a:ln/>
-        </p:spPr>
-        <p:txBody>
-          <a:bodyPr wrap="square" lIns="0" tIns="0" rIns="0" bIns="0" rtlCol="0" anchor="t">
-            <a:normAutofit/>
-          </a:bodyPr>
-          <a:lstStyle/>
-          <a:p>
-            <a:pPr indent="0" marL="0">
-              <a:buNone/>
-            </a:pPr>
-            <a:r>
-              <a:rPr lang="en-US" sz="1600" dirty="0">
-                <a:solidFill>
-                  <a:srgbClr val="171717"/>
-                </a:solidFill>
-                <a:latin typeface="Arial" pitchFamily="34" charset="0"/>
-                <a:ea typeface="Arial" pitchFamily="34" charset="-122"/>
-                <a:cs typeface="Arial" pitchFamily="34" charset="-120"/>
-              </a:rPr>
-              <a:t>400+ volunteer organizers, with a community that includes everyone from solo founders to teams at the biggest AI labs in the world.</a:t>
-            </a:r>
-            <a:endParaRPr lang="en-US" sz="1600" dirty="0"/>
-          </a:p>
-        </p:txBody>
-      </p:sp>
-      <p:sp>
-        <p:nvSpPr>
-          <p:cNvPr id="10" name="Text 8"/>
-          <p:cNvSpPr/>
-          <p:nvPr/>
-        </p:nvSpPr>
-        <p:spPr>
-          <a:xfrm>
-            <a:off x="658368" y="6547104"/>
-            <a:ext cx="9966960" cy="164592"/>
-          </a:xfrm>
-          <a:prstGeom prst="rect">
-            <a:avLst/>
-          </a:prstGeom>
-          <a:noFill/>
-          <a:ln/>
-        </p:spPr>
-        <p:txBody>
-          <a:bodyPr wrap="square" lIns="0" tIns="0" rIns="0" bIns="0" rtlCol="0" anchor="ctr">
-            <a:normAutofit/>
-          </a:bodyPr>
-          <a:lstStyle/>
-          <a:p>
-            <a:pPr indent="0" marL="0">
+          <p:cNvPr id="22" name="Text 20"/>
+          <p:cNvSpPr/>
+          <p:nvPr/>
+        </p:nvSpPr>
+        <p:spPr>
+          <a:xfrm>
+            <a:off x="11018520" y="6519672"/>
+            <a:ext cx="502920" cy="182880"/>
+          </a:xfrm>
+          <a:prstGeom prst="rect">
+            <a:avLst/>
+          </a:prstGeom>
+          <a:noFill/>
+          <a:ln/>
+        </p:spPr>
+        <p:txBody>
+          <a:bodyPr wrap="square" lIns="0" tIns="0" rIns="0" bIns="0" rtlCol="0" anchor="ctr"/>
+          <a:lstStyle/>
+          <a:p>
+            <a:pPr algn="r" indent="0" marL="0">
               <a:buNone/>
             </a:pPr>
             <a:r>
@@ -2398,48 +3629,7 @@
                 <a:ea typeface="Arial" pitchFamily="34" charset="-122"/>
                 <a:cs typeface="Arial" pitchFamily="34" charset="-120"/>
               </a:rPr>
-              <a:t>Source: AI Collective Newsletter</a:t>
-            </a:r>
-            <a:endParaRPr lang="en-US" sz="800" dirty="0"/>
-          </a:p>
-        </p:txBody>
-      </p:sp>
-      <p:sp>
-        <p:nvSpPr>
-          <p:cNvPr id="11" name="Text 9"/>
-          <p:cNvSpPr/>
-          <p:nvPr/>
-        </p:nvSpPr>
-        <p:spPr>
-          <a:xfrm>
-            <a:off x="11018520" y="6519672"/>
-            <a:ext cx="502920" cy="182880"/>
-          </a:xfrm>
-          <a:prstGeom prst="rect">
-            <a:avLst/>
-          </a:prstGeom>
-          <a:noFill/>
-          <a:ln/>
-        </p:spPr>
-        <p:txBody>
-          <a:bodyPr wrap="square" lIns="0" tIns="0" rIns="0" bIns="0" rtlCol="0" anchor="ctr"/>
-          <a:lstStyle/>
-          <a:p>
-            <a:pPr algn="r" indent="0" marL="0">
-              <a:buNone/>
-            </a:pPr>
-            <a:r>
-              <a:rPr lang="en-US" sz="800" dirty="0">
-                <a:solidFill>
-                  <a:srgbClr val="171717">
-                    <a:alpha val="66000"/>
-                  </a:srgbClr>
-                </a:solidFill>
-                <a:latin typeface="Arial" pitchFamily="34" charset="0"/>
-                <a:ea typeface="Arial" pitchFamily="34" charset="-122"/>
-                <a:cs typeface="Arial" pitchFamily="34" charset="-120"/>
-              </a:rPr>
-              <a:t>04</a:t>
+              <a:t>05</a:t>
             </a:r>
             <a:endParaRPr lang="en-US" sz="800" dirty="0"/>
           </a:p>
@@ -2453,9 +3643,1212 @@
 </p:sld>
 </file>
 
-<file path=ppt/slides/slide5.xml><?xml version="1.0" encoding="utf-8"?>
+<file path=ppt/slides/slide6.xml><?xml version="1.0" encoding="utf-8"?>
 <p:sld xmlns:a="http://schemas.openxmlformats.org/drawingml/2006/main" xmlns:r="http://schemas.openxmlformats.org/officeDocument/2006/relationships" xmlns:p="http://schemas.openxmlformats.org/presentationml/2006/main">
-  <p:cSld name="Slide 5">
+  <p:cSld name="Slide 6">
+    <p:bg>
+      <p:bgPr>
+        <a:solidFill>
+          <a:srgbClr val="FAF8F3"/>
+        </a:solidFill>
+      </p:bgPr>
+    </p:bg>
+    <p:spTree>
+      <p:nvGrpSpPr>
+        <p:cNvPr id="1" name=""/>
+        <p:cNvGrpSpPr/>
+        <p:nvPr/>
+      </p:nvGrpSpPr>
+      <p:grpSpPr>
+        <a:xfrm>
+          <a:off x="0" y="0"/>
+          <a:ext cx="0" cy="0"/>
+          <a:chOff x="0" y="0"/>
+          <a:chExt cx="0" cy="0"/>
+        </a:xfrm>
+      </p:grpSpPr>
+      <p:sp>
+        <p:nvSpPr>
+          <p:cNvPr id="2" name="Shape 0"/>
+          <p:cNvSpPr/>
+          <p:nvPr/>
+        </p:nvSpPr>
+        <p:spPr>
+          <a:xfrm>
+            <a:off x="0" y="0"/>
+            <a:ext cx="3401568" cy="6858000"/>
+          </a:xfrm>
+          <a:prstGeom prst="rect">
+            <a:avLst/>
+          </a:prstGeom>
+          <a:solidFill>
+            <a:srgbClr val="FF640D">
+              <a:alpha val="8000"/>
+            </a:srgbClr>
+          </a:solidFill>
+          <a:ln w="12700">
+            <a:solidFill>
+              <a:srgbClr val="FF640D">
+                <a:alpha val="0"/>
+              </a:srgbClr>
+            </a:solidFill>
+            <a:prstDash val="solid"/>
+          </a:ln>
+        </p:spPr>
+      </p:sp>
+      <p:sp>
+        <p:nvSpPr>
+          <p:cNvPr id="3" name="Text 1"/>
+          <p:cNvSpPr/>
+          <p:nvPr/>
+        </p:nvSpPr>
+        <p:spPr>
+          <a:xfrm>
+            <a:off x="658368" y="1920240"/>
+            <a:ext cx="2743200" cy="1920240"/>
+          </a:xfrm>
+          <a:prstGeom prst="rect">
+            <a:avLst/>
+          </a:prstGeom>
+          <a:noFill/>
+          <a:ln/>
+        </p:spPr>
+        <p:txBody>
+          <a:bodyPr wrap="square" lIns="0" tIns="0" rIns="0" bIns="0" rtlCol="0" anchor="ctr">
+            <a:normAutofit/>
+          </a:bodyPr>
+          <a:lstStyle/>
+          <a:p>
+            <a:pPr indent="0" marL="0">
+              <a:buNone/>
+            </a:pPr>
+            <a:r>
+              <a:rPr lang="en-US" sz="10400" dirty="0">
+                <a:solidFill>
+                  <a:srgbClr val="FF640D"/>
+                </a:solidFill>
+                <a:latin typeface="Arial" pitchFamily="34" charset="0"/>
+                <a:ea typeface="Arial" pitchFamily="34" charset="-122"/>
+                <a:cs typeface="Arial" pitchFamily="34" charset="-120"/>
+              </a:rPr>
+              <a:t>05</a:t>
+            </a:r>
+            <a:endParaRPr lang="en-US" sz="10400" dirty="0"/>
+          </a:p>
+        </p:txBody>
+      </p:sp>
+      <p:sp>
+        <p:nvSpPr>
+          <p:cNvPr id="4" name="Text 2"/>
+          <p:cNvSpPr/>
+          <p:nvPr/>
+        </p:nvSpPr>
+        <p:spPr>
+          <a:xfrm>
+            <a:off x="3886200" y="1170432"/>
+            <a:ext cx="5120640" cy="182880"/>
+          </a:xfrm>
+          <a:prstGeom prst="rect">
+            <a:avLst/>
+          </a:prstGeom>
+          <a:noFill/>
+          <a:ln/>
+        </p:spPr>
+        <p:txBody>
+          <a:bodyPr wrap="square" lIns="0" tIns="0" rIns="0" bIns="0" rtlCol="0" anchor="ctr"/>
+          <a:lstStyle/>
+          <a:p>
+            <a:pPr indent="0" marL="0">
+              <a:buNone/>
+            </a:pPr>
+            <a:r>
+              <a:rPr lang="en-US" sz="900" b="1" spc="150" kern="0" dirty="0">
+                <a:solidFill>
+                  <a:srgbClr val="FF640D"/>
+                </a:solidFill>
+                <a:latin typeface="Arial" pitchFamily="34" charset="0"/>
+                <a:ea typeface="Arial" pitchFamily="34" charset="-122"/>
+                <a:cs typeface="Arial" pitchFamily="34" charset="-120"/>
+              </a:rPr>
+              <a:t>WHAT CHANGES</a:t>
+            </a:r>
+            <a:endParaRPr lang="en-US" sz="900" dirty="0"/>
+          </a:p>
+        </p:txBody>
+      </p:sp>
+      <p:sp>
+        <p:nvSpPr>
+          <p:cNvPr id="5" name="Text 3"/>
+          <p:cNvSpPr/>
+          <p:nvPr/>
+        </p:nvSpPr>
+        <p:spPr>
+          <a:xfrm>
+            <a:off x="3858768" y="1572768"/>
+            <a:ext cx="7132320" cy="1417320"/>
+          </a:xfrm>
+          <a:prstGeom prst="rect">
+            <a:avLst/>
+          </a:prstGeom>
+          <a:noFill/>
+          <a:ln/>
+        </p:spPr>
+        <p:txBody>
+          <a:bodyPr wrap="square" lIns="0" tIns="0" rIns="0" bIns="0" rtlCol="0" anchor="ctr">
+            <a:normAutofit/>
+          </a:bodyPr>
+          <a:lstStyle/>
+          <a:p>
+            <a:pPr indent="0" marL="0">
+              <a:buNone/>
+            </a:pPr>
+            <a:r>
+              <a:rPr lang="en-US" sz="3000" dirty="0">
+                <a:solidFill>
+                  <a:srgbClr val="171717"/>
+                </a:solidFill>
+                <a:latin typeface="Arial" pitchFamily="34" charset="0"/>
+                <a:ea typeface="Arial" pitchFamily="34" charset="-122"/>
+                <a:cs typeface="Arial" pitchFamily="34" charset="-120"/>
+              </a:rPr>
+              <a:t>Design for financial sustainability before launch</a:t>
+            </a:r>
+            <a:endParaRPr lang="en-US" sz="3000" dirty="0"/>
+          </a:p>
+        </p:txBody>
+      </p:sp>
+      <p:sp>
+        <p:nvSpPr>
+          <p:cNvPr id="6" name="Text 4"/>
+          <p:cNvSpPr/>
+          <p:nvPr/>
+        </p:nvSpPr>
+        <p:spPr>
+          <a:xfrm>
+            <a:off x="3886200" y="3246120"/>
+            <a:ext cx="6812280" cy="1417320"/>
+          </a:xfrm>
+          <a:prstGeom prst="rect">
+            <a:avLst/>
+          </a:prstGeom>
+          <a:noFill/>
+          <a:ln/>
+        </p:spPr>
+        <p:txBody>
+          <a:bodyPr wrap="square" lIns="0" tIns="0" rIns="0" bIns="0" rtlCol="0" anchor="t">
+            <a:normAutofit/>
+          </a:bodyPr>
+          <a:lstStyle/>
+          <a:p>
+            <a:pPr indent="0" marL="0">
+              <a:buNone/>
+            </a:pPr>
+            <a:r>
+              <a:rPr lang="en-US" sz="1700" dirty="0">
+                <a:solidFill>
+                  <a:srgbClr val="171717"/>
+                </a:solidFill>
+                <a:latin typeface="Arial" pitchFamily="34" charset="0"/>
+                <a:ea typeface="Arial" pitchFamily="34" charset="-122"/>
+                <a:cs typeface="Arial" pitchFamily="34" charset="-120"/>
+              </a:rPr>
+              <a:t>Treat a repeatable venue and partner model as a launch condition—not cleanup after the first event.</a:t>
+            </a:r>
+            <a:endParaRPr lang="en-US" sz="1700" dirty="0"/>
+          </a:p>
+        </p:txBody>
+      </p:sp>
+      <p:sp>
+        <p:nvSpPr>
+          <p:cNvPr id="7" name="Text 5"/>
+          <p:cNvSpPr/>
+          <p:nvPr/>
+        </p:nvSpPr>
+        <p:spPr>
+          <a:xfrm>
+            <a:off x="658368" y="6547104"/>
+            <a:ext cx="9966960" cy="164592"/>
+          </a:xfrm>
+          <a:prstGeom prst="rect">
+            <a:avLst/>
+          </a:prstGeom>
+          <a:noFill/>
+          <a:ln/>
+        </p:spPr>
+        <p:txBody>
+          <a:bodyPr wrap="square" lIns="0" tIns="0" rIns="0" bIns="0" rtlCol="0" anchor="ctr">
+            <a:normAutofit/>
+          </a:bodyPr>
+          <a:lstStyle/>
+          <a:p>
+            <a:pPr indent="0" marL="0">
+              <a:buNone/>
+            </a:pPr>
+            <a:r>
+              <a:rPr lang="en-US" sz="800" dirty="0">
+                <a:solidFill>
+                  <a:srgbClr val="171717">
+                    <a:alpha val="66000"/>
+                  </a:srgbClr>
+                </a:solidFill>
+                <a:latin typeface="Arial" pitchFamily="34" charset="0"/>
+                <a:ea typeface="Arial" pitchFamily="34" charset="-122"/>
+                <a:cs typeface="Arial" pitchFamily="34" charset="-120"/>
+              </a:rPr>
+              <a:t>Source: Chapter Startup FAQ</a:t>
+            </a:r>
+            <a:endParaRPr lang="en-US" sz="800" dirty="0"/>
+          </a:p>
+        </p:txBody>
+      </p:sp>
+      <p:sp>
+        <p:nvSpPr>
+          <p:cNvPr id="8" name="Text 6"/>
+          <p:cNvSpPr/>
+          <p:nvPr/>
+        </p:nvSpPr>
+        <p:spPr>
+          <a:xfrm>
+            <a:off x="11018520" y="6519672"/>
+            <a:ext cx="502920" cy="182880"/>
+          </a:xfrm>
+          <a:prstGeom prst="rect">
+            <a:avLst/>
+          </a:prstGeom>
+          <a:noFill/>
+          <a:ln/>
+        </p:spPr>
+        <p:txBody>
+          <a:bodyPr wrap="square" lIns="0" tIns="0" rIns="0" bIns="0" rtlCol="0" anchor="ctr"/>
+          <a:lstStyle/>
+          <a:p>
+            <a:pPr algn="r" indent="0" marL="0">
+              <a:buNone/>
+            </a:pPr>
+            <a:r>
+              <a:rPr lang="en-US" sz="800" dirty="0">
+                <a:solidFill>
+                  <a:srgbClr val="171717">
+                    <a:alpha val="66000"/>
+                  </a:srgbClr>
+                </a:solidFill>
+                <a:latin typeface="Arial" pitchFamily="34" charset="0"/>
+                <a:ea typeface="Arial" pitchFamily="34" charset="-122"/>
+                <a:cs typeface="Arial" pitchFamily="34" charset="-120"/>
+              </a:rPr>
+              <a:t>06</a:t>
+            </a:r>
+            <a:endParaRPr lang="en-US" sz="800" dirty="0"/>
+          </a:p>
+        </p:txBody>
+      </p:sp>
+    </p:spTree>
+  </p:cSld>
+  <p:clrMapOvr>
+    <a:masterClrMapping/>
+  </p:clrMapOvr>
+</p:sld>
+</file>
+
+<file path=ppt/slides/slide7.xml><?xml version="1.0" encoding="utf-8"?>
+<p:sld xmlns:a="http://schemas.openxmlformats.org/drawingml/2006/main" xmlns:r="http://schemas.openxmlformats.org/officeDocument/2006/relationships" xmlns:p="http://schemas.openxmlformats.org/presentationml/2006/main">
+  <p:cSld name="Slide 7">
+    <p:bg>
+      <p:bgPr>
+        <a:solidFill>
+          <a:srgbClr val="FAF8F3"/>
+        </a:solidFill>
+      </p:bgPr>
+    </p:bg>
+    <p:spTree>
+      <p:nvGrpSpPr>
+        <p:cNvPr id="1" name=""/>
+        <p:cNvGrpSpPr/>
+        <p:nvPr/>
+      </p:nvGrpSpPr>
+      <p:grpSpPr>
+        <a:xfrm>
+          <a:off x="0" y="0"/>
+          <a:ext cx="0" cy="0"/>
+          <a:chOff x="0" y="0"/>
+          <a:chExt cx="0" cy="0"/>
+        </a:xfrm>
+      </p:grpSpPr>
+      <p:sp>
+        <p:nvSpPr>
+          <p:cNvPr id="2" name="Text 0"/>
+          <p:cNvSpPr/>
+          <p:nvPr/>
+        </p:nvSpPr>
+        <p:spPr>
+          <a:xfrm>
+            <a:off x="685800" y="749808"/>
+            <a:ext cx="5120640" cy="182880"/>
+          </a:xfrm>
+          <a:prstGeom prst="rect">
+            <a:avLst/>
+          </a:prstGeom>
+          <a:noFill/>
+          <a:ln/>
+        </p:spPr>
+        <p:txBody>
+          <a:bodyPr wrap="square" lIns="0" tIns="0" rIns="0" bIns="0" rtlCol="0" anchor="ctr"/>
+          <a:lstStyle/>
+          <a:p>
+            <a:pPr indent="0" marL="0">
+              <a:buNone/>
+            </a:pPr>
+            <a:r>
+              <a:rPr lang="en-US" sz="900" b="1" spc="150" kern="0" dirty="0">
+                <a:solidFill>
+                  <a:srgbClr val="FF640D"/>
+                </a:solidFill>
+                <a:latin typeface="Arial" pitchFamily="34" charset="0"/>
+                <a:ea typeface="Arial" pitchFamily="34" charset="-122"/>
+                <a:cs typeface="Arial" pitchFamily="34" charset="-120"/>
+              </a:rPr>
+              <a:t>EVIDENCE</a:t>
+            </a:r>
+            <a:endParaRPr lang="en-US" sz="900" dirty="0"/>
+          </a:p>
+        </p:txBody>
+      </p:sp>
+      <p:sp>
+        <p:nvSpPr>
+          <p:cNvPr id="3" name="Text 1"/>
+          <p:cNvSpPr/>
+          <p:nvPr/>
+        </p:nvSpPr>
+        <p:spPr>
+          <a:xfrm>
+            <a:off x="658368" y="1143000"/>
+            <a:ext cx="6675120" cy="1463040"/>
+          </a:xfrm>
+          <a:prstGeom prst="rect">
+            <a:avLst/>
+          </a:prstGeom>
+          <a:noFill/>
+          <a:ln/>
+        </p:spPr>
+        <p:txBody>
+          <a:bodyPr wrap="square" lIns="0" tIns="0" rIns="0" bIns="0" rtlCol="0" anchor="ctr">
+            <a:normAutofit/>
+          </a:bodyPr>
+          <a:lstStyle/>
+          <a:p>
+            <a:pPr indent="0" marL="0">
+              <a:buNone/>
+            </a:pPr>
+            <a:r>
+              <a:rPr lang="en-US" sz="3200" dirty="0">
+                <a:solidFill>
+                  <a:srgbClr val="171717"/>
+                </a:solidFill>
+                <a:latin typeface="Arial" pitchFamily="34" charset="0"/>
+                <a:ea typeface="Arial" pitchFamily="34" charset="-122"/>
+                <a:cs typeface="Arial" pitchFamily="34" charset="-120"/>
+              </a:rPr>
+              <a:t>Trust begins at registration</a:t>
+            </a:r>
+            <a:endParaRPr lang="en-US" sz="3200" dirty="0"/>
+          </a:p>
+        </p:txBody>
+      </p:sp>
+      <p:sp>
+        <p:nvSpPr>
+          <p:cNvPr id="4" name="Text 2"/>
+          <p:cNvSpPr/>
+          <p:nvPr/>
+        </p:nvSpPr>
+        <p:spPr>
+          <a:xfrm>
+            <a:off x="685800" y="2788920"/>
+            <a:ext cx="6400800" cy="1508760"/>
+          </a:xfrm>
+          <a:prstGeom prst="rect">
+            <a:avLst/>
+          </a:prstGeom>
+          <a:noFill/>
+          <a:ln/>
+        </p:spPr>
+        <p:txBody>
+          <a:bodyPr wrap="square" lIns="0" tIns="0" rIns="0" bIns="0" rtlCol="0" anchor="t">
+            <a:normAutofit/>
+          </a:bodyPr>
+          <a:lstStyle/>
+          <a:p>
+            <a:pPr indent="0" marL="0">
+              <a:buNone/>
+            </a:pPr>
+            <a:r>
+              <a:rPr lang="en-US" sz="1800" dirty="0">
+                <a:solidFill>
+                  <a:srgbClr val="171717"/>
+                </a:solidFill>
+                <a:latin typeface="Arial" pitchFamily="34" charset="0"/>
+                <a:ea typeface="Arial" pitchFamily="34" charset="-122"/>
+                <a:cs typeface="Arial" pitchFamily="34" charset="-120"/>
+              </a:rPr>
+              <a:t>The Code of Conduct covers attendees, speakers, sponsors, and volunteers. The current privacy policy governs event registration data and media use.</a:t>
+            </a:r>
+            <a:endParaRPr lang="en-US" sz="1800" dirty="0"/>
+          </a:p>
+        </p:txBody>
+      </p:sp>
+      <p:sp>
+        <p:nvSpPr>
+          <p:cNvPr id="5" name="Shape 3"/>
+          <p:cNvSpPr/>
+          <p:nvPr/>
+        </p:nvSpPr>
+        <p:spPr>
+          <a:xfrm>
+            <a:off x="7818120" y="658368"/>
+            <a:ext cx="3703320" cy="5440680"/>
+          </a:xfrm>
+          <a:prstGeom prst="rect">
+            <a:avLst/>
+          </a:prstGeom>
+          <a:solidFill>
+            <a:srgbClr val="171717"/>
+          </a:solidFill>
+          <a:ln w="12700">
+            <a:solidFill>
+              <a:srgbClr val="171717"/>
+            </a:solidFill>
+            <a:prstDash val="solid"/>
+          </a:ln>
+        </p:spPr>
+      </p:sp>
+      <p:sp>
+        <p:nvSpPr>
+          <p:cNvPr id="6" name="Text 4"/>
+          <p:cNvSpPr/>
+          <p:nvPr/>
+        </p:nvSpPr>
+        <p:spPr>
+          <a:xfrm>
+            <a:off x="8183880" y="3886200"/>
+            <a:ext cx="2880360" cy="201168"/>
+          </a:xfrm>
+          <a:prstGeom prst="rect">
+            <a:avLst/>
+          </a:prstGeom>
+          <a:noFill/>
+          <a:ln/>
+        </p:spPr>
+        <p:txBody>
+          <a:bodyPr wrap="square" lIns="0" tIns="0" rIns="0" bIns="0" rtlCol="0" anchor="ctr"/>
+          <a:lstStyle/>
+          <a:p>
+            <a:pPr indent="0" marL="0">
+              <a:buNone/>
+            </a:pPr>
+            <a:r>
+              <a:rPr lang="en-US" sz="800" b="1" spc="120" kern="0" dirty="0">
+                <a:solidFill>
+                  <a:srgbClr val="FF640D"/>
+                </a:solidFill>
+                <a:latin typeface="Arial" pitchFamily="34" charset="0"/>
+                <a:ea typeface="Arial" pitchFamily="34" charset="-122"/>
+                <a:cs typeface="Arial" pitchFamily="34" charset="-120"/>
+              </a:rPr>
+              <a:t>SOURCE-BACKED</a:t>
+            </a:r>
+            <a:endParaRPr lang="en-US" sz="800" dirty="0"/>
+          </a:p>
+        </p:txBody>
+      </p:sp>
+      <p:sp>
+        <p:nvSpPr>
+          <p:cNvPr id="7" name="Text 5"/>
+          <p:cNvSpPr/>
+          <p:nvPr/>
+        </p:nvSpPr>
+        <p:spPr>
+          <a:xfrm>
+            <a:off x="8156448" y="4315968"/>
+            <a:ext cx="2834640" cy="1051560"/>
+          </a:xfrm>
+          <a:prstGeom prst="rect">
+            <a:avLst/>
+          </a:prstGeom>
+          <a:noFill/>
+          <a:ln/>
+        </p:spPr>
+        <p:txBody>
+          <a:bodyPr wrap="square" lIns="0" tIns="0" rIns="0" bIns="0" rtlCol="0" anchor="b">
+            <a:normAutofit/>
+          </a:bodyPr>
+          <a:lstStyle/>
+          <a:p>
+            <a:pPr indent="0" marL="0">
+              <a:buNone/>
+            </a:pPr>
+            <a:r>
+              <a:rPr lang="en-US" sz="2000" dirty="0">
+                <a:solidFill>
+                  <a:srgbClr val="FAF8F3"/>
+                </a:solidFill>
+                <a:latin typeface="Arial" pitchFamily="34" charset="0"/>
+                <a:ea typeface="Arial" pitchFamily="34" charset="-122"/>
+                <a:cs typeface="Arial" pitchFamily="34" charset="-120"/>
+              </a:rPr>
+              <a:t>AI Collective · Conduct and Privacy policies</a:t>
+            </a:r>
+            <a:endParaRPr lang="en-US" sz="2000" dirty="0"/>
+          </a:p>
+        </p:txBody>
+      </p:sp>
+      <p:sp>
+        <p:nvSpPr>
+          <p:cNvPr id="8" name="Text 6"/>
+          <p:cNvSpPr/>
+          <p:nvPr/>
+        </p:nvSpPr>
+        <p:spPr>
+          <a:xfrm>
+            <a:off x="658368" y="6547104"/>
+            <a:ext cx="9966960" cy="164592"/>
+          </a:xfrm>
+          <a:prstGeom prst="rect">
+            <a:avLst/>
+          </a:prstGeom>
+          <a:noFill/>
+          <a:ln/>
+        </p:spPr>
+        <p:txBody>
+          <a:bodyPr wrap="square" lIns="0" tIns="0" rIns="0" bIns="0" rtlCol="0" anchor="ctr">
+            <a:normAutofit/>
+          </a:bodyPr>
+          <a:lstStyle/>
+          <a:p>
+            <a:pPr indent="0" marL="0">
+              <a:buNone/>
+            </a:pPr>
+            <a:r>
+              <a:rPr lang="en-US" sz="800" dirty="0">
+                <a:solidFill>
+                  <a:srgbClr val="171717">
+                    <a:alpha val="66000"/>
+                  </a:srgbClr>
+                </a:solidFill>
+                <a:latin typeface="Arial" pitchFamily="34" charset="0"/>
+                <a:ea typeface="Arial" pitchFamily="34" charset="-122"/>
+                <a:cs typeface="Arial" pitchFamily="34" charset="-120"/>
+              </a:rPr>
+              <a:t>Source: AI Collective · Conduct and Privacy policies</a:t>
+            </a:r>
+            <a:endParaRPr lang="en-US" sz="800" dirty="0"/>
+          </a:p>
+        </p:txBody>
+      </p:sp>
+      <p:sp>
+        <p:nvSpPr>
+          <p:cNvPr id="9" name="Text 7"/>
+          <p:cNvSpPr/>
+          <p:nvPr/>
+        </p:nvSpPr>
+        <p:spPr>
+          <a:xfrm>
+            <a:off x="11018520" y="6519672"/>
+            <a:ext cx="502920" cy="182880"/>
+          </a:xfrm>
+          <a:prstGeom prst="rect">
+            <a:avLst/>
+          </a:prstGeom>
+          <a:noFill/>
+          <a:ln/>
+        </p:spPr>
+        <p:txBody>
+          <a:bodyPr wrap="square" lIns="0" tIns="0" rIns="0" bIns="0" rtlCol="0" anchor="ctr"/>
+          <a:lstStyle/>
+          <a:p>
+            <a:pPr algn="r" indent="0" marL="0">
+              <a:buNone/>
+            </a:pPr>
+            <a:r>
+              <a:rPr lang="en-US" sz="800" dirty="0">
+                <a:solidFill>
+                  <a:srgbClr val="171717">
+                    <a:alpha val="66000"/>
+                  </a:srgbClr>
+                </a:solidFill>
+                <a:latin typeface="Arial" pitchFamily="34" charset="0"/>
+                <a:ea typeface="Arial" pitchFamily="34" charset="-122"/>
+                <a:cs typeface="Arial" pitchFamily="34" charset="-120"/>
+              </a:rPr>
+              <a:t>07</a:t>
+            </a:r>
+            <a:endParaRPr lang="en-US" sz="800" dirty="0"/>
+          </a:p>
+        </p:txBody>
+      </p:sp>
+    </p:spTree>
+  </p:cSld>
+  <p:clrMapOvr>
+    <a:masterClrMapping/>
+  </p:clrMapOvr>
+</p:sld>
+</file>
+
+<file path=ppt/slides/slide8.xml><?xml version="1.0" encoding="utf-8"?>
+<p:sld xmlns:a="http://schemas.openxmlformats.org/drawingml/2006/main" xmlns:r="http://schemas.openxmlformats.org/officeDocument/2006/relationships" xmlns:p="http://schemas.openxmlformats.org/presentationml/2006/main">
+  <p:cSld name="Slide 8">
+    <p:bg>
+      <p:bgPr>
+        <a:solidFill>
+          <a:srgbClr val="FAF8F3"/>
+        </a:solidFill>
+      </p:bgPr>
+    </p:bg>
+    <p:spTree>
+      <p:nvGrpSpPr>
+        <p:cNvPr id="1" name=""/>
+        <p:cNvGrpSpPr/>
+        <p:nvPr/>
+      </p:nvGrpSpPr>
+      <p:grpSpPr>
+        <a:xfrm>
+          <a:off x="0" y="0"/>
+          <a:ext cx="0" cy="0"/>
+          <a:chOff x="0" y="0"/>
+          <a:chExt cx="0" cy="0"/>
+        </a:xfrm>
+      </p:grpSpPr>
+      <p:sp>
+        <p:nvSpPr>
+          <p:cNvPr id="2" name="Text 0"/>
+          <p:cNvSpPr/>
+          <p:nvPr/>
+        </p:nvSpPr>
+        <p:spPr>
+          <a:xfrm>
+            <a:off x="685800" y="932688"/>
+            <a:ext cx="5120640" cy="182880"/>
+          </a:xfrm>
+          <a:prstGeom prst="rect">
+            <a:avLst/>
+          </a:prstGeom>
+          <a:noFill/>
+          <a:ln/>
+        </p:spPr>
+        <p:txBody>
+          <a:bodyPr wrap="square" lIns="0" tIns="0" rIns="0" bIns="0" rtlCol="0" anchor="ctr"/>
+          <a:lstStyle/>
+          <a:p>
+            <a:pPr indent="0" marL="0">
+              <a:buNone/>
+            </a:pPr>
+            <a:r>
+              <a:rPr lang="en-US" sz="900" b="1" spc="150" kern="0" dirty="0">
+                <a:solidFill>
+                  <a:srgbClr val="FF640D"/>
+                </a:solidFill>
+                <a:latin typeface="Arial" pitchFamily="34" charset="0"/>
+                <a:ea typeface="Arial" pitchFamily="34" charset="-122"/>
+                <a:cs typeface="Arial" pitchFamily="34" charset="-120"/>
+              </a:rPr>
+              <a:t>DECISION REQUIRED</a:t>
+            </a:r>
+            <a:endParaRPr lang="en-US" sz="900" dirty="0"/>
+          </a:p>
+        </p:txBody>
+      </p:sp>
+      <p:sp>
+        <p:nvSpPr>
+          <p:cNvPr id="3" name="Text 1"/>
+          <p:cNvSpPr/>
+          <p:nvPr/>
+        </p:nvSpPr>
+        <p:spPr>
+          <a:xfrm>
+            <a:off x="658368" y="1353312"/>
+            <a:ext cx="5669280" cy="1417320"/>
+          </a:xfrm>
+          <a:prstGeom prst="rect">
+            <a:avLst/>
+          </a:prstGeom>
+          <a:noFill/>
+          <a:ln/>
+        </p:spPr>
+        <p:txBody>
+          <a:bodyPr wrap="square" lIns="0" tIns="0" rIns="0" bIns="0" rtlCol="0" anchor="ctr">
+            <a:normAutofit/>
+          </a:bodyPr>
+          <a:lstStyle/>
+          <a:p>
+            <a:pPr indent="0" marL="0">
+              <a:buNone/>
+            </a:pPr>
+            <a:r>
+              <a:rPr lang="en-US" sz="3400" dirty="0">
+                <a:solidFill>
+                  <a:srgbClr val="171717"/>
+                </a:solidFill>
+                <a:latin typeface="Arial" pitchFamily="34" charset="0"/>
+                <a:ea typeface="Arial" pitchFamily="34" charset="-122"/>
+                <a:cs typeface="Arial" pitchFamily="34" charset="-120"/>
+              </a:rPr>
+              <a:t>Make three decisions before announcing</a:t>
+            </a:r>
+            <a:endParaRPr lang="en-US" sz="3400" dirty="0"/>
+          </a:p>
+        </p:txBody>
+      </p:sp>
+      <p:sp>
+        <p:nvSpPr>
+          <p:cNvPr id="4" name="Text 2"/>
+          <p:cNvSpPr/>
+          <p:nvPr/>
+        </p:nvSpPr>
+        <p:spPr>
+          <a:xfrm>
+            <a:off x="685800" y="3063240"/>
+            <a:ext cx="5212080" cy="1051560"/>
+          </a:xfrm>
+          <a:prstGeom prst="rect">
+            <a:avLst/>
+          </a:prstGeom>
+          <a:noFill/>
+          <a:ln/>
+        </p:spPr>
+        <p:txBody>
+          <a:bodyPr wrap="square" lIns="0" tIns="0" rIns="0" bIns="0" rtlCol="0" anchor="t">
+            <a:normAutofit/>
+          </a:bodyPr>
+          <a:lstStyle/>
+          <a:p>
+            <a:pPr indent="0" marL="0">
+              <a:buNone/>
+            </a:pPr>
+            <a:r>
+              <a:rPr lang="en-US" sz="1500" dirty="0">
+                <a:solidFill>
+                  <a:srgbClr val="171717">
+                    <a:alpha val="78000"/>
+                  </a:srgbClr>
+                </a:solidFill>
+                <a:latin typeface="Arial" pitchFamily="34" charset="0"/>
+                <a:ea typeface="Arial" pitchFamily="34" charset="-122"/>
+                <a:cs typeface="Arial" pitchFamily="34" charset="-120"/>
+              </a:rPr>
+              <a:t>The launch is credible when ownership, the first experience, and the operating partner are explicit.</a:t>
+            </a:r>
+            <a:endParaRPr lang="en-US" sz="1500" dirty="0"/>
+          </a:p>
+        </p:txBody>
+      </p:sp>
+      <p:sp>
+        <p:nvSpPr>
+          <p:cNvPr id="5" name="Shape 3"/>
+          <p:cNvSpPr/>
+          <p:nvPr/>
+        </p:nvSpPr>
+        <p:spPr>
+          <a:xfrm>
+            <a:off x="6720840" y="1078992"/>
+            <a:ext cx="4754880" cy="896112"/>
+          </a:xfrm>
+          <a:prstGeom prst="rect">
+            <a:avLst/>
+          </a:prstGeom>
+          <a:solidFill>
+            <a:srgbClr val="171717"/>
+          </a:solidFill>
+          <a:ln w="12700">
+            <a:solidFill>
+              <a:srgbClr val="171717"/>
+            </a:solidFill>
+            <a:prstDash val="solid"/>
+          </a:ln>
+        </p:spPr>
+      </p:sp>
+      <p:sp>
+        <p:nvSpPr>
+          <p:cNvPr id="6" name="Text 4"/>
+          <p:cNvSpPr/>
+          <p:nvPr/>
+        </p:nvSpPr>
+        <p:spPr>
+          <a:xfrm>
+            <a:off x="6967728" y="1408176"/>
+            <a:ext cx="384048" cy="164592"/>
+          </a:xfrm>
+          <a:prstGeom prst="rect">
+            <a:avLst/>
+          </a:prstGeom>
+          <a:noFill/>
+          <a:ln/>
+        </p:spPr>
+        <p:txBody>
+          <a:bodyPr wrap="square" lIns="0" tIns="0" rIns="0" bIns="0" rtlCol="0" anchor="ctr"/>
+          <a:lstStyle/>
+          <a:p>
+            <a:pPr indent="0" marL="0">
+              <a:buNone/>
+            </a:pPr>
+            <a:r>
+              <a:rPr lang="en-US" sz="800" b="1" dirty="0">
+                <a:solidFill>
+                  <a:srgbClr val="FF640D"/>
+                </a:solidFill>
+                <a:latin typeface="Arial" pitchFamily="34" charset="0"/>
+                <a:ea typeface="Arial" pitchFamily="34" charset="-122"/>
+                <a:cs typeface="Arial" pitchFamily="34" charset="-120"/>
+              </a:rPr>
+              <a:t>01</a:t>
+            </a:r>
+            <a:endParaRPr lang="en-US" sz="800" dirty="0"/>
+          </a:p>
+        </p:txBody>
+      </p:sp>
+      <p:sp>
+        <p:nvSpPr>
+          <p:cNvPr id="7" name="Text 5"/>
+          <p:cNvSpPr/>
+          <p:nvPr/>
+        </p:nvSpPr>
+        <p:spPr>
+          <a:xfrm>
+            <a:off x="7498080" y="1280160"/>
+            <a:ext cx="3611880" cy="475488"/>
+          </a:xfrm>
+          <a:prstGeom prst="rect">
+            <a:avLst/>
+          </a:prstGeom>
+          <a:noFill/>
+          <a:ln/>
+        </p:spPr>
+        <p:txBody>
+          <a:bodyPr wrap="square" lIns="0" tIns="0" rIns="0" bIns="0" rtlCol="0" anchor="ctr">
+            <a:normAutofit/>
+          </a:bodyPr>
+          <a:lstStyle/>
+          <a:p>
+            <a:pPr indent="0" marL="0">
+              <a:buNone/>
+            </a:pPr>
+            <a:r>
+              <a:rPr lang="en-US" sz="1400" dirty="0">
+                <a:solidFill>
+                  <a:srgbClr val="FAF8F3"/>
+                </a:solidFill>
+                <a:latin typeface="Arial" pitchFamily="34" charset="0"/>
+                <a:ea typeface="Arial" pitchFamily="34" charset="-122"/>
+                <a:cs typeface="Arial" pitchFamily="34" charset="-120"/>
+              </a:rPr>
+              <a:t>Who owns the chapter and each launch workstream?</a:t>
+            </a:r>
+            <a:endParaRPr lang="en-US" sz="1400" dirty="0"/>
+          </a:p>
+        </p:txBody>
+      </p:sp>
+      <p:sp>
+        <p:nvSpPr>
+          <p:cNvPr id="8" name="Shape 6"/>
+          <p:cNvSpPr/>
+          <p:nvPr/>
+        </p:nvSpPr>
+        <p:spPr>
+          <a:xfrm>
+            <a:off x="6720840" y="2194560"/>
+            <a:ext cx="4754880" cy="896112"/>
+          </a:xfrm>
+          <a:prstGeom prst="rect">
+            <a:avLst/>
+          </a:prstGeom>
+          <a:solidFill>
+            <a:srgbClr val="171717"/>
+          </a:solidFill>
+          <a:ln w="12700">
+            <a:solidFill>
+              <a:srgbClr val="171717"/>
+            </a:solidFill>
+            <a:prstDash val="solid"/>
+          </a:ln>
+        </p:spPr>
+      </p:sp>
+      <p:sp>
+        <p:nvSpPr>
+          <p:cNvPr id="9" name="Text 7"/>
+          <p:cNvSpPr/>
+          <p:nvPr/>
+        </p:nvSpPr>
+        <p:spPr>
+          <a:xfrm>
+            <a:off x="6967728" y="2523744"/>
+            <a:ext cx="384048" cy="164592"/>
+          </a:xfrm>
+          <a:prstGeom prst="rect">
+            <a:avLst/>
+          </a:prstGeom>
+          <a:noFill/>
+          <a:ln/>
+        </p:spPr>
+        <p:txBody>
+          <a:bodyPr wrap="square" lIns="0" tIns="0" rIns="0" bIns="0" rtlCol="0" anchor="ctr"/>
+          <a:lstStyle/>
+          <a:p>
+            <a:pPr indent="0" marL="0">
+              <a:buNone/>
+            </a:pPr>
+            <a:r>
+              <a:rPr lang="en-US" sz="800" b="1" dirty="0">
+                <a:solidFill>
+                  <a:srgbClr val="FF640D"/>
+                </a:solidFill>
+                <a:latin typeface="Arial" pitchFamily="34" charset="0"/>
+                <a:ea typeface="Arial" pitchFamily="34" charset="-122"/>
+                <a:cs typeface="Arial" pitchFamily="34" charset="-120"/>
+              </a:rPr>
+              <a:t>02</a:t>
+            </a:r>
+            <a:endParaRPr lang="en-US" sz="800" dirty="0"/>
+          </a:p>
+        </p:txBody>
+      </p:sp>
+      <p:sp>
+        <p:nvSpPr>
+          <p:cNvPr id="10" name="Text 8"/>
+          <p:cNvSpPr/>
+          <p:nvPr/>
+        </p:nvSpPr>
+        <p:spPr>
+          <a:xfrm>
+            <a:off x="7498080" y="2395728"/>
+            <a:ext cx="3611880" cy="475488"/>
+          </a:xfrm>
+          <a:prstGeom prst="rect">
+            <a:avLst/>
+          </a:prstGeom>
+          <a:noFill/>
+          <a:ln/>
+        </p:spPr>
+        <p:txBody>
+          <a:bodyPr wrap="square" lIns="0" tIns="0" rIns="0" bIns="0" rtlCol="0" anchor="ctr">
+            <a:normAutofit/>
+          </a:bodyPr>
+          <a:lstStyle/>
+          <a:p>
+            <a:pPr indent="0" marL="0">
+              <a:buNone/>
+            </a:pPr>
+            <a:r>
+              <a:rPr lang="en-US" sz="1400" dirty="0">
+                <a:solidFill>
+                  <a:srgbClr val="FAF8F3"/>
+                </a:solidFill>
+                <a:latin typeface="Arial" pitchFamily="34" charset="0"/>
+                <a:ea typeface="Arial" pitchFamily="34" charset="-122"/>
+                <a:cs typeface="Arial" pitchFamily="34" charset="-120"/>
+              </a:rPr>
+              <a:t>What is the first event format and target date?</a:t>
+            </a:r>
+            <a:endParaRPr lang="en-US" sz="1400" dirty="0"/>
+          </a:p>
+        </p:txBody>
+      </p:sp>
+      <p:sp>
+        <p:nvSpPr>
+          <p:cNvPr id="11" name="Shape 9"/>
+          <p:cNvSpPr/>
+          <p:nvPr/>
+        </p:nvSpPr>
+        <p:spPr>
+          <a:xfrm>
+            <a:off x="6720840" y="3310128"/>
+            <a:ext cx="4754880" cy="896112"/>
+          </a:xfrm>
+          <a:prstGeom prst="rect">
+            <a:avLst/>
+          </a:prstGeom>
+          <a:solidFill>
+            <a:srgbClr val="171717"/>
+          </a:solidFill>
+          <a:ln w="12700">
+            <a:solidFill>
+              <a:srgbClr val="171717"/>
+            </a:solidFill>
+            <a:prstDash val="solid"/>
+          </a:ln>
+        </p:spPr>
+      </p:sp>
+      <p:sp>
+        <p:nvSpPr>
+          <p:cNvPr id="12" name="Text 10"/>
+          <p:cNvSpPr/>
+          <p:nvPr/>
+        </p:nvSpPr>
+        <p:spPr>
+          <a:xfrm>
+            <a:off x="6967728" y="3639312"/>
+            <a:ext cx="384048" cy="164592"/>
+          </a:xfrm>
+          <a:prstGeom prst="rect">
+            <a:avLst/>
+          </a:prstGeom>
+          <a:noFill/>
+          <a:ln/>
+        </p:spPr>
+        <p:txBody>
+          <a:bodyPr wrap="square" lIns="0" tIns="0" rIns="0" bIns="0" rtlCol="0" anchor="ctr"/>
+          <a:lstStyle/>
+          <a:p>
+            <a:pPr indent="0" marL="0">
+              <a:buNone/>
+            </a:pPr>
+            <a:r>
+              <a:rPr lang="en-US" sz="800" b="1" dirty="0">
+                <a:solidFill>
+                  <a:srgbClr val="FF640D"/>
+                </a:solidFill>
+                <a:latin typeface="Arial" pitchFamily="34" charset="0"/>
+                <a:ea typeface="Arial" pitchFamily="34" charset="-122"/>
+                <a:cs typeface="Arial" pitchFamily="34" charset="-120"/>
+              </a:rPr>
+              <a:t>03</a:t>
+            </a:r>
+            <a:endParaRPr lang="en-US" sz="800" dirty="0"/>
+          </a:p>
+        </p:txBody>
+      </p:sp>
+      <p:sp>
+        <p:nvSpPr>
+          <p:cNvPr id="13" name="Text 11"/>
+          <p:cNvSpPr/>
+          <p:nvPr/>
+        </p:nvSpPr>
+        <p:spPr>
+          <a:xfrm>
+            <a:off x="7498080" y="3511296"/>
+            <a:ext cx="3611880" cy="475488"/>
+          </a:xfrm>
+          <a:prstGeom prst="rect">
+            <a:avLst/>
+          </a:prstGeom>
+          <a:noFill/>
+          <a:ln/>
+        </p:spPr>
+        <p:txBody>
+          <a:bodyPr wrap="square" lIns="0" tIns="0" rIns="0" bIns="0" rtlCol="0" anchor="ctr">
+            <a:normAutofit/>
+          </a:bodyPr>
+          <a:lstStyle/>
+          <a:p>
+            <a:pPr indent="0" marL="0">
+              <a:buNone/>
+            </a:pPr>
+            <a:r>
+              <a:rPr lang="en-US" sz="1400" dirty="0">
+                <a:solidFill>
+                  <a:srgbClr val="FAF8F3"/>
+                </a:solidFill>
+                <a:latin typeface="Arial" pitchFamily="34" charset="0"/>
+                <a:ea typeface="Arial" pitchFamily="34" charset="-122"/>
+                <a:cs typeface="Arial" pitchFamily="34" charset="-120"/>
+              </a:rPr>
+              <a:t>Which venue or partner makes the cadence sustainable?</a:t>
+            </a:r>
+            <a:endParaRPr lang="en-US" sz="1400" dirty="0"/>
+          </a:p>
+        </p:txBody>
+      </p:sp>
+      <p:sp>
+        <p:nvSpPr>
+          <p:cNvPr id="14" name="Text 12"/>
+          <p:cNvSpPr/>
+          <p:nvPr/>
+        </p:nvSpPr>
+        <p:spPr>
+          <a:xfrm>
+            <a:off x="658368" y="6547104"/>
+            <a:ext cx="9966960" cy="164592"/>
+          </a:xfrm>
+          <a:prstGeom prst="rect">
+            <a:avLst/>
+          </a:prstGeom>
+          <a:noFill/>
+          <a:ln/>
+        </p:spPr>
+        <p:txBody>
+          <a:bodyPr wrap="square" lIns="0" tIns="0" rIns="0" bIns="0" rtlCol="0" anchor="ctr">
+            <a:normAutofit/>
+          </a:bodyPr>
+          <a:lstStyle/>
+          <a:p>
+            <a:pPr indent="0" marL="0">
+              <a:buNone/>
+            </a:pPr>
+            <a:r>
+              <a:rPr lang="en-US" sz="800" dirty="0">
+                <a:solidFill>
+                  <a:srgbClr val="171717">
+                    <a:alpha val="66000"/>
+                  </a:srgbClr>
+                </a:solidFill>
+                <a:latin typeface="Arial" pitchFamily="34" charset="0"/>
+                <a:ea typeface="Arial" pitchFamily="34" charset="-122"/>
+                <a:cs typeface="Arial" pitchFamily="34" charset="-120"/>
+              </a:rPr>
+              <a:t>Source: Derived decision frame · HQ validation required</a:t>
+            </a:r>
+            <a:endParaRPr lang="en-US" sz="800" dirty="0"/>
+          </a:p>
+        </p:txBody>
+      </p:sp>
+      <p:sp>
+        <p:nvSpPr>
+          <p:cNvPr id="15" name="Text 13"/>
+          <p:cNvSpPr/>
+          <p:nvPr/>
+        </p:nvSpPr>
+        <p:spPr>
+          <a:xfrm>
+            <a:off x="11018520" y="6519672"/>
+            <a:ext cx="502920" cy="182880"/>
+          </a:xfrm>
+          <a:prstGeom prst="rect">
+            <a:avLst/>
+          </a:prstGeom>
+          <a:noFill/>
+          <a:ln/>
+        </p:spPr>
+        <p:txBody>
+          <a:bodyPr wrap="square" lIns="0" tIns="0" rIns="0" bIns="0" rtlCol="0" anchor="ctr"/>
+          <a:lstStyle/>
+          <a:p>
+            <a:pPr algn="r" indent="0" marL="0">
+              <a:buNone/>
+            </a:pPr>
+            <a:r>
+              <a:rPr lang="en-US" sz="800" dirty="0">
+                <a:solidFill>
+                  <a:srgbClr val="171717">
+                    <a:alpha val="66000"/>
+                  </a:srgbClr>
+                </a:solidFill>
+                <a:latin typeface="Arial" pitchFamily="34" charset="0"/>
+                <a:ea typeface="Arial" pitchFamily="34" charset="-122"/>
+                <a:cs typeface="Arial" pitchFamily="34" charset="-120"/>
+              </a:rPr>
+              <a:t>08</a:t>
+            </a:r>
+            <a:endParaRPr lang="en-US" sz="800" dirty="0"/>
+          </a:p>
+        </p:txBody>
+      </p:sp>
+    </p:spTree>
+  </p:cSld>
+  <p:clrMapOvr>
+    <a:masterClrMapping/>
+  </p:clrMapOvr>
+</p:sld>
+</file>
+
+<file path=ppt/slides/slide9.xml><?xml version="1.0" encoding="utf-8"?>
+<p:sld xmlns:a="http://schemas.openxmlformats.org/drawingml/2006/main" xmlns:r="http://schemas.openxmlformats.org/officeDocument/2006/relationships" xmlns:p="http://schemas.openxmlformats.org/presentationml/2006/main">
+  <p:cSld name="Slide 9">
     <p:bg>
       <p:bgPr>
         <a:solidFill>
@@ -2551,7 +4944,7 @@
                 <a:ea typeface="Arial" pitchFamily="34" charset="-122"/>
                 <a:cs typeface="Arial" pitchFamily="34" charset="-120"/>
               </a:rPr>
-              <a:t>Start a chapter in your city</a:t>
+              <a:t>Approve a 30-day chapter launch sprint</a:t>
             </a:r>
             <a:endParaRPr lang="en-US" sz="4200" dirty="0"/>
           </a:p>
@@ -2621,7 +5014,7 @@
                 <a:ea typeface="Arial" pitchFamily="34" charset="-122"/>
                 <a:cs typeface="Arial" pitchFamily="34" charset="-120"/>
               </a:rPr>
-              <a:t>You can also attend an event, volunteer to organize, or pitch a Byte article.</a:t>
+              <a:t>Use week one to confirm owners and HQ requirements. Do not announce until the first format, date, venue, and trust obligations have named owners.</a:t>
             </a:r>
             <a:endParaRPr lang="en-US" sz="1800" dirty="0"/>
           </a:p>
@@ -2664,7 +5057,7 @@
                 <a:ea typeface="Arial" pitchFamily="34" charset="-122"/>
                 <a:cs typeface="Arial" pitchFamily="34" charset="-120"/>
               </a:rPr>
-              <a:t>Source: AI Collective Newsletter</a:t>
+              <a:t>Source: WorkshopLM recommendation · grounded in chapter brief</a:t>
             </a:r>
             <a:endParaRPr lang="en-US" sz="800" dirty="0"/>
           </a:p>
@@ -2705,7 +5098,7 @@
                 <a:ea typeface="Arial" pitchFamily="34" charset="-122"/>
                 <a:cs typeface="Arial" pitchFamily="34" charset="-120"/>
               </a:rPr>
-              <a:t>05</a:t>
+              <a:t>09</a:t>
             </a:r>
             <a:endParaRPr lang="en-US" sz="800" dirty="0"/>
           </a:p>

</xml_diff>

<commit_message>
feat(deck): raise external proof quality
</commit_message>
<xml_diff>
--- a/outputs/dogfood-ai-collective-chapter-brief/chapter-launch-brief.pptx
+++ b/outputs/dogfood-ai-collective-chapter-brief/chapter-launch-brief.pptx
@@ -2211,7 +2211,7 @@
         <p:spPr>
           <a:xfrm>
             <a:off x="685800" y="1353312"/>
-            <a:ext cx="4892040" cy="22860"/>
+            <a:ext cx="3322320" cy="22860"/>
           </a:xfrm>
           <a:prstGeom prst="rect">
             <a:avLst/>
@@ -2238,7 +2238,7 @@
         <p:spPr>
           <a:xfrm>
             <a:off x="685800" y="1627632"/>
-            <a:ext cx="4892040" cy="1325880"/>
+            <a:ext cx="3322320" cy="1325880"/>
           </a:xfrm>
           <a:prstGeom prst="rect">
             <a:avLst/>
@@ -2256,7 +2256,7 @@
               <a:buNone/>
             </a:pPr>
             <a:r>
-              <a:rPr lang="en-US" sz="5800" dirty="0">
+              <a:rPr lang="en-US" sz="5000" dirty="0">
                 <a:solidFill>
                   <a:srgbClr val="171717"/>
                 </a:solidFill>
@@ -2266,7 +2266,7 @@
               </a:rPr>
               <a:t>180+</a:t>
             </a:r>
-            <a:endParaRPr lang="en-US" sz="5800" dirty="0"/>
+            <a:endParaRPr lang="en-US" sz="5000" dirty="0"/>
           </a:p>
         </p:txBody>
       </p:sp>
@@ -2279,7 +2279,7 @@
         <p:spPr>
           <a:xfrm>
             <a:off x="685800" y="2962656"/>
-            <a:ext cx="4892040" cy="384048"/>
+            <a:ext cx="3322320" cy="384048"/>
           </a:xfrm>
           <a:prstGeom prst="rect">
             <a:avLst/>
@@ -2319,8 +2319,8 @@
         </p:nvSpPr>
         <p:spPr>
           <a:xfrm>
-            <a:off x="6217920" y="1353312"/>
-            <a:ext cx="4892040" cy="22860"/>
+            <a:off x="4419600" y="1353312"/>
+            <a:ext cx="3322320" cy="22860"/>
           </a:xfrm>
           <a:prstGeom prst="rect">
             <a:avLst/>
@@ -2346,8 +2346,8 @@
         </p:nvSpPr>
         <p:spPr>
           <a:xfrm>
-            <a:off x="6217920" y="1627632"/>
-            <a:ext cx="4892040" cy="1325880"/>
+            <a:off x="4419600" y="1627632"/>
+            <a:ext cx="3322320" cy="1325880"/>
           </a:xfrm>
           <a:prstGeom prst="rect">
             <a:avLst/>
@@ -2365,7 +2365,7 @@
               <a:buNone/>
             </a:pPr>
             <a:r>
-              <a:rPr lang="en-US" sz="5800" dirty="0">
+              <a:rPr lang="en-US" sz="5000" dirty="0">
                 <a:solidFill>
                   <a:srgbClr val="171717"/>
                 </a:solidFill>
@@ -2375,7 +2375,7 @@
               </a:rPr>
               <a:t>40+</a:t>
             </a:r>
-            <a:endParaRPr lang="en-US" sz="5800" dirty="0"/>
+            <a:endParaRPr lang="en-US" sz="5000" dirty="0"/>
           </a:p>
         </p:txBody>
       </p:sp>
@@ -2387,8 +2387,8 @@
         </p:nvSpPr>
         <p:spPr>
           <a:xfrm>
-            <a:off x="6217920" y="2962656"/>
-            <a:ext cx="4892040" cy="384048"/>
+            <a:off x="4419600" y="2962656"/>
+            <a:ext cx="3322320" cy="384048"/>
           </a:xfrm>
           <a:prstGeom prst="rect">
             <a:avLst/>
@@ -2422,7 +2422,116 @@
       </p:sp>
       <p:sp>
         <p:nvSpPr>
-          <p:cNvPr id="9" name="Text 7"/>
+          <p:cNvPr id="9" name="Shape 7"/>
+          <p:cNvSpPr/>
+          <p:nvPr/>
+        </p:nvSpPr>
+        <p:spPr>
+          <a:xfrm>
+            <a:off x="8153400" y="1353312"/>
+            <a:ext cx="3322320" cy="22860"/>
+          </a:xfrm>
+          <a:prstGeom prst="rect">
+            <a:avLst/>
+          </a:prstGeom>
+          <a:solidFill>
+            <a:srgbClr val="FF640D"/>
+          </a:solidFill>
+          <a:ln w="12700">
+            <a:solidFill>
+              <a:srgbClr val="FF640D">
+                <a:alpha val="0"/>
+              </a:srgbClr>
+            </a:solidFill>
+            <a:prstDash val="solid"/>
+          </a:ln>
+        </p:spPr>
+      </p:sp>
+      <p:sp>
+        <p:nvSpPr>
+          <p:cNvPr id="10" name="Text 8"/>
+          <p:cNvSpPr/>
+          <p:nvPr/>
+        </p:nvSpPr>
+        <p:spPr>
+          <a:xfrm>
+            <a:off x="8153400" y="1627632"/>
+            <a:ext cx="3322320" cy="1325880"/>
+          </a:xfrm>
+          <a:prstGeom prst="rect">
+            <a:avLst/>
+          </a:prstGeom>
+          <a:noFill/>
+          <a:ln/>
+        </p:spPr>
+        <p:txBody>
+          <a:bodyPr wrap="square" lIns="0" tIns="0" rIns="0" bIns="0" rtlCol="0" anchor="ctr">
+            <a:normAutofit/>
+          </a:bodyPr>
+          <a:lstStyle/>
+          <a:p>
+            <a:pPr indent="0" marL="0">
+              <a:buNone/>
+            </a:pPr>
+            <a:r>
+              <a:rPr lang="en-US" sz="5000" dirty="0">
+                <a:solidFill>
+                  <a:srgbClr val="171717"/>
+                </a:solidFill>
+                <a:latin typeface="Arial" pitchFamily="34" charset="0"/>
+                <a:ea typeface="Arial" pitchFamily="34" charset="-122"/>
+                <a:cs typeface="Arial" pitchFamily="34" charset="-120"/>
+              </a:rPr>
+              <a:t>400+</a:t>
+            </a:r>
+            <a:endParaRPr lang="en-US" sz="5000" dirty="0"/>
+          </a:p>
+        </p:txBody>
+      </p:sp>
+      <p:sp>
+        <p:nvSpPr>
+          <p:cNvPr id="11" name="Text 9"/>
+          <p:cNvSpPr/>
+          <p:nvPr/>
+        </p:nvSpPr>
+        <p:spPr>
+          <a:xfrm>
+            <a:off x="8153400" y="2962656"/>
+            <a:ext cx="3322320" cy="384048"/>
+          </a:xfrm>
+          <a:prstGeom prst="rect">
+            <a:avLst/>
+          </a:prstGeom>
+          <a:noFill/>
+          <a:ln/>
+        </p:spPr>
+        <p:txBody>
+          <a:bodyPr wrap="square" lIns="0" tIns="0" rIns="0" bIns="0" rtlCol="0" anchor="ctr"/>
+          <a:lstStyle/>
+          <a:p>
+            <a:pPr indent="0" marL="0">
+              <a:buNone/>
+            </a:pPr>
+            <a:r>
+              <a:rPr lang="en-US" sz="800" b="1" dirty="0">
+                <a:solidFill>
+                  <a:srgbClr val="171717">
+                    <a:alpha val="66000"/>
+                  </a:srgbClr>
+                </a:solidFill>
+                <a:latin typeface="Arial" pitchFamily="34" charset="0"/>
+                <a:ea typeface="Arial" pitchFamily="34" charset="-122"/>
+                <a:cs typeface="Arial" pitchFamily="34" charset="-120"/>
+              </a:rPr>
+              <a:t>ORGANIZERS</a:t>
+            </a:r>
+            <a:endParaRPr lang="en-US" sz="800" dirty="0"/>
+          </a:p>
+        </p:txBody>
+      </p:sp>
+      <p:sp>
+        <p:nvSpPr>
+          <p:cNvPr id="12" name="Text 10"/>
           <p:cNvSpPr/>
           <p:nvPr/>
         </p:nvSpPr>
@@ -2455,7 +2564,7 @@
                 <a:ea typeface="Arial" pitchFamily="34" charset="-122"/>
                 <a:cs typeface="Arial" pitchFamily="34" charset="-120"/>
               </a:rPr>
-              <a:t>400+ volunteer organizers, with a community that includes everyone from solo founders to teams at the biggest AI labs in the world.</a:t>
+              <a:t>A global community that includes everyone from solo founders to teams at the biggest AI labs in the world.</a:t>
             </a:r>
             <a:endParaRPr lang="en-US" sz="1600" dirty="0"/>
           </a:p>
@@ -2463,7 +2572,7 @@
       </p:sp>
       <p:sp>
         <p:nvSpPr>
-          <p:cNvPr id="10" name="Text 8"/>
+          <p:cNvPr id="13" name="Text 11"/>
           <p:cNvSpPr/>
           <p:nvPr/>
         </p:nvSpPr>
@@ -2506,7 +2615,7 @@
       </p:sp>
       <p:sp>
         <p:nvSpPr>
-          <p:cNvPr id="11" name="Text 9"/>
+          <p:cNvPr id="14" name="Text 12"/>
           <p:cNvSpPr/>
           <p:nvPr/>
         </p:nvSpPr>
@@ -2579,22 +2688,100 @@
       </p:grpSpPr>
       <p:sp>
         <p:nvSpPr>
-          <p:cNvPr id="2" name="Shape 0"/>
-          <p:cNvSpPr/>
-          <p:nvPr/>
-        </p:nvSpPr>
-        <p:spPr>
-          <a:xfrm>
-            <a:off x="0" y="0"/>
-            <a:ext cx="3401568" cy="6858000"/>
+          <p:cNvPr id="2" name="Text 0"/>
+          <p:cNvSpPr/>
+          <p:nvPr/>
+        </p:nvSpPr>
+        <p:spPr>
+          <a:xfrm>
+            <a:off x="685800" y="1051560"/>
+            <a:ext cx="4800600" cy="182880"/>
+          </a:xfrm>
+          <a:prstGeom prst="rect">
+            <a:avLst/>
+          </a:prstGeom>
+          <a:noFill/>
+          <a:ln/>
+        </p:spPr>
+        <p:txBody>
+          <a:bodyPr wrap="square" lIns="0" tIns="0" rIns="0" bIns="0" rtlCol="0" anchor="ctr"/>
+          <a:lstStyle/>
+          <a:p>
+            <a:pPr indent="0" marL="0">
+              <a:buNone/>
+            </a:pPr>
+            <a:r>
+              <a:rPr lang="en-US" sz="900" b="1" spc="150" kern="0" dirty="0">
+                <a:solidFill>
+                  <a:srgbClr val="FF640D"/>
+                </a:solidFill>
+                <a:latin typeface="Arial" pitchFamily="34" charset="0"/>
+                <a:ea typeface="Arial" pitchFamily="34" charset="-122"/>
+                <a:cs typeface="Arial" pitchFamily="34" charset="-120"/>
+              </a:rPr>
+              <a:t>WHAT CHANGES</a:t>
+            </a:r>
+            <a:endParaRPr lang="en-US" sz="900" dirty="0"/>
+          </a:p>
+        </p:txBody>
+      </p:sp>
+      <p:sp>
+        <p:nvSpPr>
+          <p:cNvPr id="3" name="Text 1"/>
+          <p:cNvSpPr/>
+          <p:nvPr/>
+        </p:nvSpPr>
+        <p:spPr>
+          <a:xfrm>
+            <a:off x="658368" y="1554480"/>
+            <a:ext cx="4846320" cy="2148840"/>
+          </a:xfrm>
+          <a:prstGeom prst="rect">
+            <a:avLst/>
+          </a:prstGeom>
+          <a:noFill/>
+          <a:ln/>
+        </p:spPr>
+        <p:txBody>
+          <a:bodyPr wrap="square" lIns="0" tIns="0" rIns="0" bIns="0" rtlCol="0" anchor="ctr">
+            <a:normAutofit/>
+          </a:bodyPr>
+          <a:lstStyle/>
+          <a:p>
+            <a:pPr indent="0" marL="0">
+              <a:buNone/>
+            </a:pPr>
+            <a:r>
+              <a:rPr lang="en-US" sz="3200" dirty="0">
+                <a:solidFill>
+                  <a:srgbClr val="171717"/>
+                </a:solidFill>
+                <a:latin typeface="Arial" pitchFamily="34" charset="0"/>
+                <a:ea typeface="Arial" pitchFamily="34" charset="-122"/>
+                <a:cs typeface="Arial" pitchFamily="34" charset="-120"/>
+              </a:rPr>
+              <a:t>Start with one repeatable event format</a:t>
+            </a:r>
+            <a:endParaRPr lang="en-US" sz="3200" dirty="0"/>
+          </a:p>
+        </p:txBody>
+      </p:sp>
+      <p:sp>
+        <p:nvSpPr>
+          <p:cNvPr id="4" name="Shape 2"/>
+          <p:cNvSpPr/>
+          <p:nvPr/>
+        </p:nvSpPr>
+        <p:spPr>
+          <a:xfrm>
+            <a:off x="5989320" y="1078992"/>
+            <a:ext cx="50292" cy="4251960"/>
           </a:xfrm>
           <a:prstGeom prst="rect">
             <a:avLst/>
           </a:prstGeom>
           <a:solidFill>
-            <a:srgbClr val="FF640D">
-              <a:alpha val="8000"/>
-            </a:srgbClr>
+            <a:srgbClr val="FF640D"/>
           </a:solidFill>
           <a:ln w="12700">
             <a:solidFill>
@@ -2608,14 +2795,14 @@
       </p:sp>
       <p:sp>
         <p:nvSpPr>
-          <p:cNvPr id="3" name="Text 1"/>
-          <p:cNvSpPr/>
-          <p:nvPr/>
-        </p:nvSpPr>
-        <p:spPr>
-          <a:xfrm>
-            <a:off x="658368" y="1920240"/>
-            <a:ext cx="2743200" cy="1920240"/>
+          <p:cNvPr id="5" name="Text 3"/>
+          <p:cNvSpPr/>
+          <p:nvPr/>
+        </p:nvSpPr>
+        <p:spPr>
+          <a:xfrm>
+            <a:off x="6446520" y="1508760"/>
+            <a:ext cx="4617720" cy="3154680"/>
           </a:xfrm>
           <a:prstGeom prst="rect">
             <a:avLst/>
@@ -2633,69 +2820,30 @@
               <a:buNone/>
             </a:pPr>
             <a:r>
-              <a:rPr lang="en-US" sz="10400" dirty="0">
-                <a:solidFill>
-                  <a:srgbClr val="FF640D"/>
-                </a:solidFill>
-                <a:latin typeface="Arial" pitchFamily="34" charset="0"/>
-                <a:ea typeface="Arial" pitchFamily="34" charset="-122"/>
-                <a:cs typeface="Arial" pitchFamily="34" charset="-120"/>
-              </a:rPr>
-              <a:t>03</a:t>
-            </a:r>
-            <a:endParaRPr lang="en-US" sz="10400" dirty="0"/>
-          </a:p>
-        </p:txBody>
-      </p:sp>
-      <p:sp>
-        <p:nvSpPr>
-          <p:cNvPr id="4" name="Text 2"/>
-          <p:cNvSpPr/>
-          <p:nvPr/>
-        </p:nvSpPr>
-        <p:spPr>
-          <a:xfrm>
-            <a:off x="3886200" y="1170432"/>
-            <a:ext cx="5120640" cy="182880"/>
-          </a:xfrm>
-          <a:prstGeom prst="rect">
-            <a:avLst/>
-          </a:prstGeom>
-          <a:noFill/>
-          <a:ln/>
-        </p:spPr>
-        <p:txBody>
-          <a:bodyPr wrap="square" lIns="0" tIns="0" rIns="0" bIns="0" rtlCol="0" anchor="ctr"/>
-          <a:lstStyle/>
-          <a:p>
-            <a:pPr indent="0" marL="0">
-              <a:buNone/>
-            </a:pPr>
-            <a:r>
-              <a:rPr lang="en-US" sz="900" b="1" spc="150" kern="0" dirty="0">
-                <a:solidFill>
-                  <a:srgbClr val="FF640D"/>
-                </a:solidFill>
-                <a:latin typeface="Arial" pitchFamily="34" charset="0"/>
-                <a:ea typeface="Arial" pitchFamily="34" charset="-122"/>
-                <a:cs typeface="Arial" pitchFamily="34" charset="-120"/>
-              </a:rPr>
-              <a:t>WHAT CHANGES</a:t>
-            </a:r>
-            <a:endParaRPr lang="en-US" sz="900" dirty="0"/>
-          </a:p>
-        </p:txBody>
-      </p:sp>
-      <p:sp>
-        <p:nvSpPr>
-          <p:cNvPr id="5" name="Text 3"/>
-          <p:cNvSpPr/>
-          <p:nvPr/>
-        </p:nvSpPr>
-        <p:spPr>
-          <a:xfrm>
-            <a:off x="3858768" y="1572768"/>
-            <a:ext cx="7132320" cy="1417320"/>
+              <a:rPr lang="en-US" sz="1800" dirty="0">
+                <a:solidFill>
+                  <a:srgbClr val="171717"/>
+                </a:solidFill>
+                <a:latin typeface="Arial" pitchFamily="34" charset="0"/>
+                <a:ea typeface="Arial" pitchFamily="34" charset="-122"/>
+                <a:cs typeface="Arial" pitchFamily="34" charset="-120"/>
+              </a:rPr>
+              <a:t>The network already runs Demo Nights, hackathons, private dinners, and workshops. Choose one format that matches the local audience and can repeat.</a:t>
+            </a:r>
+            <a:endParaRPr lang="en-US" sz="1800" dirty="0"/>
+          </a:p>
+        </p:txBody>
+      </p:sp>
+      <p:sp>
+        <p:nvSpPr>
+          <p:cNvPr id="6" name="Text 4"/>
+          <p:cNvSpPr/>
+          <p:nvPr/>
+        </p:nvSpPr>
+        <p:spPr>
+          <a:xfrm>
+            <a:off x="658368" y="6547104"/>
+            <a:ext cx="9966960" cy="164592"/>
           </a:xfrm>
           <a:prstGeom prst="rect">
             <a:avLst/>
@@ -2713,88 +2861,6 @@
               <a:buNone/>
             </a:pPr>
             <a:r>
-              <a:rPr lang="en-US" sz="3000" dirty="0">
-                <a:solidFill>
-                  <a:srgbClr val="171717"/>
-                </a:solidFill>
-                <a:latin typeface="Arial" pitchFamily="34" charset="0"/>
-                <a:ea typeface="Arial" pitchFamily="34" charset="-122"/>
-                <a:cs typeface="Arial" pitchFamily="34" charset="-120"/>
-              </a:rPr>
-              <a:t>Start with one repeatable event format</a:t>
-            </a:r>
-            <a:endParaRPr lang="en-US" sz="3000" dirty="0"/>
-          </a:p>
-        </p:txBody>
-      </p:sp>
-      <p:sp>
-        <p:nvSpPr>
-          <p:cNvPr id="6" name="Text 4"/>
-          <p:cNvSpPr/>
-          <p:nvPr/>
-        </p:nvSpPr>
-        <p:spPr>
-          <a:xfrm>
-            <a:off x="3886200" y="3246120"/>
-            <a:ext cx="6812280" cy="1417320"/>
-          </a:xfrm>
-          <a:prstGeom prst="rect">
-            <a:avLst/>
-          </a:prstGeom>
-          <a:noFill/>
-          <a:ln/>
-        </p:spPr>
-        <p:txBody>
-          <a:bodyPr wrap="square" lIns="0" tIns="0" rIns="0" bIns="0" rtlCol="0" anchor="t">
-            <a:normAutofit/>
-          </a:bodyPr>
-          <a:lstStyle/>
-          <a:p>
-            <a:pPr indent="0" marL="0">
-              <a:buNone/>
-            </a:pPr>
-            <a:r>
-              <a:rPr lang="en-US" sz="1700" dirty="0">
-                <a:solidFill>
-                  <a:srgbClr val="171717"/>
-                </a:solidFill>
-                <a:latin typeface="Arial" pitchFamily="34" charset="0"/>
-                <a:ea typeface="Arial" pitchFamily="34" charset="-122"/>
-                <a:cs typeface="Arial" pitchFamily="34" charset="-120"/>
-              </a:rPr>
-              <a:t>The network already runs Demo Nights, hackathons, private dinners, and workshops. Choose one format that matches the local audience and can repeat.</a:t>
-            </a:r>
-            <a:endParaRPr lang="en-US" sz="1700" dirty="0"/>
-          </a:p>
-        </p:txBody>
-      </p:sp>
-      <p:sp>
-        <p:nvSpPr>
-          <p:cNvPr id="7" name="Text 5"/>
-          <p:cNvSpPr/>
-          <p:nvPr/>
-        </p:nvSpPr>
-        <p:spPr>
-          <a:xfrm>
-            <a:off x="658368" y="6547104"/>
-            <a:ext cx="9966960" cy="164592"/>
-          </a:xfrm>
-          <a:prstGeom prst="rect">
-            <a:avLst/>
-          </a:prstGeom>
-          <a:noFill/>
-          <a:ln/>
-        </p:spPr>
-        <p:txBody>
-          <a:bodyPr wrap="square" lIns="0" tIns="0" rIns="0" bIns="0" rtlCol="0" anchor="ctr">
-            <a:normAutofit/>
-          </a:bodyPr>
-          <a:lstStyle/>
-          <a:p>
-            <a:pPr indent="0" marL="0">
-              <a:buNone/>
-            </a:pPr>
-            <a:r>
               <a:rPr lang="en-US" sz="800" dirty="0">
                 <a:solidFill>
                   <a:srgbClr val="171717">
@@ -2813,7 +2879,7 @@
       </p:sp>
       <p:sp>
         <p:nvSpPr>
-          <p:cNvPr id="8" name="Text 6"/>
+          <p:cNvPr id="7" name="Text 5"/>
           <p:cNvSpPr/>
           <p:nvPr/>
         </p:nvSpPr>
@@ -3669,22 +3735,100 @@
       </p:grpSpPr>
       <p:sp>
         <p:nvSpPr>
-          <p:cNvPr id="2" name="Shape 0"/>
-          <p:cNvSpPr/>
-          <p:nvPr/>
-        </p:nvSpPr>
-        <p:spPr>
-          <a:xfrm>
-            <a:off x="0" y="0"/>
-            <a:ext cx="3401568" cy="6858000"/>
+          <p:cNvPr id="2" name="Text 0"/>
+          <p:cNvSpPr/>
+          <p:nvPr/>
+        </p:nvSpPr>
+        <p:spPr>
+          <a:xfrm>
+            <a:off x="685800" y="1051560"/>
+            <a:ext cx="4800600" cy="182880"/>
+          </a:xfrm>
+          <a:prstGeom prst="rect">
+            <a:avLst/>
+          </a:prstGeom>
+          <a:noFill/>
+          <a:ln/>
+        </p:spPr>
+        <p:txBody>
+          <a:bodyPr wrap="square" lIns="0" tIns="0" rIns="0" bIns="0" rtlCol="0" anchor="ctr"/>
+          <a:lstStyle/>
+          <a:p>
+            <a:pPr indent="0" marL="0">
+              <a:buNone/>
+            </a:pPr>
+            <a:r>
+              <a:rPr lang="en-US" sz="900" b="1" spc="150" kern="0" dirty="0">
+                <a:solidFill>
+                  <a:srgbClr val="FF640D"/>
+                </a:solidFill>
+                <a:latin typeface="Arial" pitchFamily="34" charset="0"/>
+                <a:ea typeface="Arial" pitchFamily="34" charset="-122"/>
+                <a:cs typeface="Arial" pitchFamily="34" charset="-120"/>
+              </a:rPr>
+              <a:t>WHAT CHANGES</a:t>
+            </a:r>
+            <a:endParaRPr lang="en-US" sz="900" dirty="0"/>
+          </a:p>
+        </p:txBody>
+      </p:sp>
+      <p:sp>
+        <p:nvSpPr>
+          <p:cNvPr id="3" name="Text 1"/>
+          <p:cNvSpPr/>
+          <p:nvPr/>
+        </p:nvSpPr>
+        <p:spPr>
+          <a:xfrm>
+            <a:off x="658368" y="1554480"/>
+            <a:ext cx="4846320" cy="2148840"/>
+          </a:xfrm>
+          <a:prstGeom prst="rect">
+            <a:avLst/>
+          </a:prstGeom>
+          <a:noFill/>
+          <a:ln/>
+        </p:spPr>
+        <p:txBody>
+          <a:bodyPr wrap="square" lIns="0" tIns="0" rIns="0" bIns="0" rtlCol="0" anchor="ctr">
+            <a:normAutofit/>
+          </a:bodyPr>
+          <a:lstStyle/>
+          <a:p>
+            <a:pPr indent="0" marL="0">
+              <a:buNone/>
+            </a:pPr>
+            <a:r>
+              <a:rPr lang="en-US" sz="3200" dirty="0">
+                <a:solidFill>
+                  <a:srgbClr val="171717"/>
+                </a:solidFill>
+                <a:latin typeface="Arial" pitchFamily="34" charset="0"/>
+                <a:ea typeface="Arial" pitchFamily="34" charset="-122"/>
+                <a:cs typeface="Arial" pitchFamily="34" charset="-120"/>
+              </a:rPr>
+              <a:t>Design for financial sustainability before launch</a:t>
+            </a:r>
+            <a:endParaRPr lang="en-US" sz="3200" dirty="0"/>
+          </a:p>
+        </p:txBody>
+      </p:sp>
+      <p:sp>
+        <p:nvSpPr>
+          <p:cNvPr id="4" name="Shape 2"/>
+          <p:cNvSpPr/>
+          <p:nvPr/>
+        </p:nvSpPr>
+        <p:spPr>
+          <a:xfrm>
+            <a:off x="5989320" y="1078992"/>
+            <a:ext cx="50292" cy="4251960"/>
           </a:xfrm>
           <a:prstGeom prst="rect">
             <a:avLst/>
           </a:prstGeom>
           <a:solidFill>
-            <a:srgbClr val="FF640D">
-              <a:alpha val="8000"/>
-            </a:srgbClr>
+            <a:srgbClr val="FF640D"/>
           </a:solidFill>
           <a:ln w="12700">
             <a:solidFill>
@@ -3698,14 +3842,14 @@
       </p:sp>
       <p:sp>
         <p:nvSpPr>
-          <p:cNvPr id="3" name="Text 1"/>
-          <p:cNvSpPr/>
-          <p:nvPr/>
-        </p:nvSpPr>
-        <p:spPr>
-          <a:xfrm>
-            <a:off x="658368" y="1920240"/>
-            <a:ext cx="2743200" cy="1920240"/>
+          <p:cNvPr id="5" name="Text 3"/>
+          <p:cNvSpPr/>
+          <p:nvPr/>
+        </p:nvSpPr>
+        <p:spPr>
+          <a:xfrm>
+            <a:off x="6446520" y="1508760"/>
+            <a:ext cx="4617720" cy="3154680"/>
           </a:xfrm>
           <a:prstGeom prst="rect">
             <a:avLst/>
@@ -3723,69 +3867,30 @@
               <a:buNone/>
             </a:pPr>
             <a:r>
-              <a:rPr lang="en-US" sz="10400" dirty="0">
-                <a:solidFill>
-                  <a:srgbClr val="FF640D"/>
-                </a:solidFill>
-                <a:latin typeface="Arial" pitchFamily="34" charset="0"/>
-                <a:ea typeface="Arial" pitchFamily="34" charset="-122"/>
-                <a:cs typeface="Arial" pitchFamily="34" charset="-120"/>
-              </a:rPr>
-              <a:t>05</a:t>
-            </a:r>
-            <a:endParaRPr lang="en-US" sz="10400" dirty="0"/>
-          </a:p>
-        </p:txBody>
-      </p:sp>
-      <p:sp>
-        <p:nvSpPr>
-          <p:cNvPr id="4" name="Text 2"/>
-          <p:cNvSpPr/>
-          <p:nvPr/>
-        </p:nvSpPr>
-        <p:spPr>
-          <a:xfrm>
-            <a:off x="3886200" y="1170432"/>
-            <a:ext cx="5120640" cy="182880"/>
-          </a:xfrm>
-          <a:prstGeom prst="rect">
-            <a:avLst/>
-          </a:prstGeom>
-          <a:noFill/>
-          <a:ln/>
-        </p:spPr>
-        <p:txBody>
-          <a:bodyPr wrap="square" lIns="0" tIns="0" rIns="0" bIns="0" rtlCol="0" anchor="ctr"/>
-          <a:lstStyle/>
-          <a:p>
-            <a:pPr indent="0" marL="0">
-              <a:buNone/>
-            </a:pPr>
-            <a:r>
-              <a:rPr lang="en-US" sz="900" b="1" spc="150" kern="0" dirty="0">
-                <a:solidFill>
-                  <a:srgbClr val="FF640D"/>
-                </a:solidFill>
-                <a:latin typeface="Arial" pitchFamily="34" charset="0"/>
-                <a:ea typeface="Arial" pitchFamily="34" charset="-122"/>
-                <a:cs typeface="Arial" pitchFamily="34" charset="-120"/>
-              </a:rPr>
-              <a:t>WHAT CHANGES</a:t>
-            </a:r>
-            <a:endParaRPr lang="en-US" sz="900" dirty="0"/>
-          </a:p>
-        </p:txBody>
-      </p:sp>
-      <p:sp>
-        <p:nvSpPr>
-          <p:cNvPr id="5" name="Text 3"/>
-          <p:cNvSpPr/>
-          <p:nvPr/>
-        </p:nvSpPr>
-        <p:spPr>
-          <a:xfrm>
-            <a:off x="3858768" y="1572768"/>
-            <a:ext cx="7132320" cy="1417320"/>
+              <a:rPr lang="en-US" sz="1800" dirty="0">
+                <a:solidFill>
+                  <a:srgbClr val="171717"/>
+                </a:solidFill>
+                <a:latin typeface="Arial" pitchFamily="34" charset="0"/>
+                <a:ea typeface="Arial" pitchFamily="34" charset="-122"/>
+                <a:cs typeface="Arial" pitchFamily="34" charset="-120"/>
+              </a:rPr>
+              <a:t>Treat a repeatable venue and partner model as a launch condition—not cleanup after the first event.</a:t>
+            </a:r>
+            <a:endParaRPr lang="en-US" sz="1800" dirty="0"/>
+          </a:p>
+        </p:txBody>
+      </p:sp>
+      <p:sp>
+        <p:nvSpPr>
+          <p:cNvPr id="6" name="Text 4"/>
+          <p:cNvSpPr/>
+          <p:nvPr/>
+        </p:nvSpPr>
+        <p:spPr>
+          <a:xfrm>
+            <a:off x="658368" y="6547104"/>
+            <a:ext cx="9966960" cy="164592"/>
           </a:xfrm>
           <a:prstGeom prst="rect">
             <a:avLst/>
@@ -3803,88 +3908,6 @@
               <a:buNone/>
             </a:pPr>
             <a:r>
-              <a:rPr lang="en-US" sz="3000" dirty="0">
-                <a:solidFill>
-                  <a:srgbClr val="171717"/>
-                </a:solidFill>
-                <a:latin typeface="Arial" pitchFamily="34" charset="0"/>
-                <a:ea typeface="Arial" pitchFamily="34" charset="-122"/>
-                <a:cs typeface="Arial" pitchFamily="34" charset="-120"/>
-              </a:rPr>
-              <a:t>Design for financial sustainability before launch</a:t>
-            </a:r>
-            <a:endParaRPr lang="en-US" sz="3000" dirty="0"/>
-          </a:p>
-        </p:txBody>
-      </p:sp>
-      <p:sp>
-        <p:nvSpPr>
-          <p:cNvPr id="6" name="Text 4"/>
-          <p:cNvSpPr/>
-          <p:nvPr/>
-        </p:nvSpPr>
-        <p:spPr>
-          <a:xfrm>
-            <a:off x="3886200" y="3246120"/>
-            <a:ext cx="6812280" cy="1417320"/>
-          </a:xfrm>
-          <a:prstGeom prst="rect">
-            <a:avLst/>
-          </a:prstGeom>
-          <a:noFill/>
-          <a:ln/>
-        </p:spPr>
-        <p:txBody>
-          <a:bodyPr wrap="square" lIns="0" tIns="0" rIns="0" bIns="0" rtlCol="0" anchor="t">
-            <a:normAutofit/>
-          </a:bodyPr>
-          <a:lstStyle/>
-          <a:p>
-            <a:pPr indent="0" marL="0">
-              <a:buNone/>
-            </a:pPr>
-            <a:r>
-              <a:rPr lang="en-US" sz="1700" dirty="0">
-                <a:solidFill>
-                  <a:srgbClr val="171717"/>
-                </a:solidFill>
-                <a:latin typeface="Arial" pitchFamily="34" charset="0"/>
-                <a:ea typeface="Arial" pitchFamily="34" charset="-122"/>
-                <a:cs typeface="Arial" pitchFamily="34" charset="-120"/>
-              </a:rPr>
-              <a:t>Treat a repeatable venue and partner model as a launch condition—not cleanup after the first event.</a:t>
-            </a:r>
-            <a:endParaRPr lang="en-US" sz="1700" dirty="0"/>
-          </a:p>
-        </p:txBody>
-      </p:sp>
-      <p:sp>
-        <p:nvSpPr>
-          <p:cNvPr id="7" name="Text 5"/>
-          <p:cNvSpPr/>
-          <p:nvPr/>
-        </p:nvSpPr>
-        <p:spPr>
-          <a:xfrm>
-            <a:off x="658368" y="6547104"/>
-            <a:ext cx="9966960" cy="164592"/>
-          </a:xfrm>
-          <a:prstGeom prst="rect">
-            <a:avLst/>
-          </a:prstGeom>
-          <a:noFill/>
-          <a:ln/>
-        </p:spPr>
-        <p:txBody>
-          <a:bodyPr wrap="square" lIns="0" tIns="0" rIns="0" bIns="0" rtlCol="0" anchor="ctr">
-            <a:normAutofit/>
-          </a:bodyPr>
-          <a:lstStyle/>
-          <a:p>
-            <a:pPr indent="0" marL="0">
-              <a:buNone/>
-            </a:pPr>
-            <a:r>
               <a:rPr lang="en-US" sz="800" dirty="0">
                 <a:solidFill>
                   <a:srgbClr val="171717">
@@ -3903,7 +3926,7 @@
       </p:sp>
       <p:sp>
         <p:nvSpPr>
-          <p:cNvPr id="8" name="Text 6"/>
+          <p:cNvPr id="7" name="Text 5"/>
           <p:cNvSpPr/>
           <p:nvPr/>
         </p:nvSpPr>

</xml_diff>

<commit_message>
make Slides language true everywhere
</commit_message>
<xml_diff>
--- a/outputs/dogfood-ai-collective-chapter-brief/chapter-launch-brief.pptx
+++ b/outputs/dogfood-ai-collective-chapter-brief/chapter-launch-brief.pptx
@@ -1669,7 +1669,7 @@
         <p:spPr>
           <a:xfrm>
             <a:off x="685800" y="4343400"/>
-            <a:ext cx="9326880" cy="228600"/>
+            <a:ext cx="9784080" cy="228600"/>
           </a:xfrm>
           <a:prstGeom prst="rect">
             <a:avLst/>
@@ -1693,7 +1693,7 @@
                 <a:ea typeface="Arial" pitchFamily="34" charset="-122"/>
                 <a:cs typeface="Arial" pitchFamily="34" charset="-120"/>
               </a:rPr>
-              <a:t>AI COLLECTIVE · CLIENT PRESENTATION</a:t>
+              <a:t>AI COLLECTIVE · CLIENT SLIDES</a:t>
             </a:r>
             <a:endParaRPr lang="en-US" sz="900" dirty="0"/>
           </a:p>

</xml_diff>